<commit_message>
Update slide 4 to signal broader challenges beyond the 6 shown
</commit_message>
<xml_diff>
--- a/Fakeeh_Care_Group_v2.pptx
+++ b/Fakeeh_Care_Group_v2.pptx
@@ -11736,6 +11736,1473 @@
 </file>
 
 <file path=ppt/slides/slide2.xml><?xml version="1.0" encoding="utf-8"?>
+<p:sld xmlns:a="http://schemas.openxmlformats.org/drawingml/2006/main" xmlns:p="http://schemas.openxmlformats.org/presentationml/2006/main" xmlns:r="http://schemas.openxmlformats.org/officeDocument/2006/relationships">
+  <p:cSld>
+    <p:spTree>
+      <p:nvGrpSpPr>
+        <p:cNvPr id="1" name=""/>
+        <p:cNvGrpSpPr/>
+        <p:nvPr/>
+      </p:nvGrpSpPr>
+      <p:grpSpPr/>
+      <p:sp>
+        <p:nvSpPr>
+          <p:cNvPr id="2" name="Title 1"/>
+          <p:cNvSpPr>
+            <a:spLocks noGrp="1"/>
+          </p:cNvSpPr>
+          <p:nvPr>
+            <p:ph type="title"/>
+          </p:nvPr>
+        </p:nvSpPr>
+        <p:spPr/>
+        <p:txBody>
+          <a:bodyPr/>
+          <a:lstStyle/>
+          <a:p/>
+        </p:txBody>
+      </p:sp>
+      <p:sp>
+        <p:nvSpPr>
+          <p:cNvPr id="3" name="Rectangle 2"/>
+          <p:cNvSpPr/>
+          <p:nvPr/>
+        </p:nvSpPr>
+        <p:spPr>
+          <a:xfrm>
+            <a:off x="0" y="0"/>
+            <a:ext cx="9144000" cy="5143500"/>
+          </a:xfrm>
+          <a:prstGeom prst="rect">
+            <a:avLst/>
+          </a:prstGeom>
+          <a:solidFill>
+            <a:srgbClr val="F7F5F0"/>
+          </a:solidFill>
+          <a:ln>
+            <a:noFill/>
+          </a:ln>
+        </p:spPr>
+        <p:style>
+          <a:lnRef idx="1">
+            <a:schemeClr val="accent1"/>
+          </a:lnRef>
+          <a:fillRef idx="3">
+            <a:schemeClr val="accent1"/>
+          </a:fillRef>
+          <a:effectRef idx="2">
+            <a:schemeClr val="accent1"/>
+          </a:effectRef>
+          <a:fontRef idx="minor">
+            <a:schemeClr val="lt1"/>
+          </a:fontRef>
+        </p:style>
+        <p:txBody>
+          <a:bodyPr rtlCol="0" anchor="ctr"/>
+          <a:lstStyle/>
+          <a:p>
+            <a:pPr algn="ctr"/>
+          </a:p>
+        </p:txBody>
+      </p:sp>
+      <p:sp>
+        <p:nvSpPr>
+          <p:cNvPr id="4" name="Rectangle 3"/>
+          <p:cNvSpPr/>
+          <p:nvPr/>
+        </p:nvSpPr>
+        <p:spPr>
+          <a:xfrm>
+            <a:off x="0" y="0"/>
+            <a:ext cx="9144000" cy="41100"/>
+          </a:xfrm>
+          <a:prstGeom prst="rect">
+            <a:avLst/>
+          </a:prstGeom>
+          <a:solidFill>
+            <a:srgbClr val="B44030"/>
+          </a:solidFill>
+          <a:ln>
+            <a:noFill/>
+          </a:ln>
+        </p:spPr>
+        <p:style>
+          <a:lnRef idx="1">
+            <a:schemeClr val="accent1"/>
+          </a:lnRef>
+          <a:fillRef idx="3">
+            <a:schemeClr val="accent1"/>
+          </a:fillRef>
+          <a:effectRef idx="2">
+            <a:schemeClr val="accent1"/>
+          </a:effectRef>
+          <a:fontRef idx="minor">
+            <a:schemeClr val="lt1"/>
+          </a:fontRef>
+        </p:style>
+        <p:txBody>
+          <a:bodyPr rtlCol="0" anchor="ctr"/>
+          <a:lstStyle/>
+          <a:p>
+            <a:pPr algn="ctr"/>
+          </a:p>
+        </p:txBody>
+      </p:sp>
+      <p:sp>
+        <p:nvSpPr>
+          <p:cNvPr id="5" name="TextBox 4"/>
+          <p:cNvSpPr txBox="1"/>
+          <p:nvPr/>
+        </p:nvSpPr>
+        <p:spPr>
+          <a:xfrm>
+            <a:off x="320040" y="201168"/>
+            <a:ext cx="6400800" cy="502920"/>
+          </a:xfrm>
+          <a:prstGeom prst="rect">
+            <a:avLst/>
+          </a:prstGeom>
+          <a:noFill/>
+        </p:spPr>
+        <p:txBody>
+          <a:bodyPr wrap="square">
+            <a:spAutoFit/>
+          </a:bodyPr>
+          <a:lstStyle/>
+          <a:p>
+            <a:pPr algn="l"/>
+            <a:r>
+              <a:rPr sz="2200" b="1" i="0">
+                <a:solidFill>
+                  <a:srgbClr val="0D2B3D"/>
+                </a:solidFill>
+                <a:latin typeface="Georgia"/>
+              </a:rPr>
+              <a:t>Fakeeh Care Group — At a Glance</a:t>
+            </a:r>
+          </a:p>
+        </p:txBody>
+      </p:sp>
+      <p:sp>
+        <p:nvSpPr>
+          <p:cNvPr id="6" name="TextBox 5"/>
+          <p:cNvSpPr txBox="1"/>
+          <p:nvPr/>
+        </p:nvSpPr>
+        <p:spPr>
+          <a:xfrm>
+            <a:off x="320040" y="749808"/>
+            <a:ext cx="8046720" cy="347472"/>
+          </a:xfrm>
+          <a:prstGeom prst="rect">
+            <a:avLst/>
+          </a:prstGeom>
+          <a:noFill/>
+        </p:spPr>
+        <p:txBody>
+          <a:bodyPr wrap="square">
+            <a:spAutoFit/>
+          </a:bodyPr>
+          <a:lstStyle/>
+          <a:p>
+            <a:pPr algn="l"/>
+            <a:r>
+              <a:rPr sz="1100" b="0" i="1">
+                <a:solidFill>
+                  <a:srgbClr val="5A6A78"/>
+                </a:solidFill>
+                <a:latin typeface="Calibri"/>
+              </a:rPr>
+              <a:t>Dubai's leading private healthcare network — delivering world-class care since 1978.</a:t>
+            </a:r>
+          </a:p>
+        </p:txBody>
+      </p:sp>
+      <p:sp>
+        <p:nvSpPr>
+          <p:cNvPr id="7" name="Rectangle 6"/>
+          <p:cNvSpPr/>
+          <p:nvPr/>
+        </p:nvSpPr>
+        <p:spPr>
+          <a:xfrm>
+            <a:off x="320040" y="1152144"/>
+            <a:ext cx="8503920" cy="13800"/>
+          </a:xfrm>
+          <a:prstGeom prst="rect">
+            <a:avLst/>
+          </a:prstGeom>
+          <a:solidFill>
+            <a:srgbClr val="CCC5BB"/>
+          </a:solidFill>
+          <a:ln>
+            <a:noFill/>
+          </a:ln>
+        </p:spPr>
+        <p:style>
+          <a:lnRef idx="1">
+            <a:schemeClr val="accent1"/>
+          </a:lnRef>
+          <a:fillRef idx="3">
+            <a:schemeClr val="accent1"/>
+          </a:fillRef>
+          <a:effectRef idx="2">
+            <a:schemeClr val="accent1"/>
+          </a:effectRef>
+          <a:fontRef idx="minor">
+            <a:schemeClr val="lt1"/>
+          </a:fontRef>
+        </p:style>
+        <p:txBody>
+          <a:bodyPr rtlCol="0" anchor="ctr"/>
+          <a:lstStyle/>
+          <a:p>
+            <a:pPr algn="ctr"/>
+          </a:p>
+        </p:txBody>
+      </p:sp>
+      <p:sp>
+        <p:nvSpPr>
+          <p:cNvPr id="8" name="Rectangle 7"/>
+          <p:cNvSpPr/>
+          <p:nvPr/>
+        </p:nvSpPr>
+        <p:spPr>
+          <a:xfrm>
+            <a:off x="320040" y="1261872"/>
+            <a:ext cx="1993392" cy="1078992"/>
+          </a:xfrm>
+          <a:prstGeom prst="rect">
+            <a:avLst/>
+          </a:prstGeom>
+          <a:solidFill>
+            <a:srgbClr val="FFFFFF"/>
+          </a:solidFill>
+          <a:ln w="9525">
+            <a:solidFill>
+              <a:srgbClr val="DDD5C8"/>
+            </a:solidFill>
+          </a:ln>
+        </p:spPr>
+        <p:style>
+          <a:lnRef idx="1">
+            <a:schemeClr val="accent1"/>
+          </a:lnRef>
+          <a:fillRef idx="3">
+            <a:schemeClr val="accent1"/>
+          </a:fillRef>
+          <a:effectRef idx="2">
+            <a:schemeClr val="accent1"/>
+          </a:effectRef>
+          <a:fontRef idx="minor">
+            <a:schemeClr val="lt1"/>
+          </a:fontRef>
+        </p:style>
+        <p:txBody>
+          <a:bodyPr rtlCol="0" anchor="ctr"/>
+          <a:lstStyle/>
+          <a:p>
+            <a:pPr algn="ctr"/>
+          </a:p>
+        </p:txBody>
+      </p:sp>
+      <p:sp>
+        <p:nvSpPr>
+          <p:cNvPr id="9" name="Rectangle 8"/>
+          <p:cNvSpPr/>
+          <p:nvPr/>
+        </p:nvSpPr>
+        <p:spPr>
+          <a:xfrm>
+            <a:off x="320040" y="1261872"/>
+            <a:ext cx="1993392" cy="18000"/>
+          </a:xfrm>
+          <a:prstGeom prst="rect">
+            <a:avLst/>
+          </a:prstGeom>
+          <a:solidFill>
+            <a:srgbClr val="B44030"/>
+          </a:solidFill>
+          <a:ln>
+            <a:noFill/>
+          </a:ln>
+        </p:spPr>
+        <p:style>
+          <a:lnRef idx="1">
+            <a:schemeClr val="accent1"/>
+          </a:lnRef>
+          <a:fillRef idx="3">
+            <a:schemeClr val="accent1"/>
+          </a:fillRef>
+          <a:effectRef idx="2">
+            <a:schemeClr val="accent1"/>
+          </a:effectRef>
+          <a:fontRef idx="minor">
+            <a:schemeClr val="lt1"/>
+          </a:fontRef>
+        </p:style>
+        <p:txBody>
+          <a:bodyPr rtlCol="0" anchor="ctr"/>
+          <a:lstStyle/>
+          <a:p>
+            <a:pPr algn="ctr"/>
+          </a:p>
+        </p:txBody>
+      </p:sp>
+      <p:sp>
+        <p:nvSpPr>
+          <p:cNvPr id="10" name="TextBox 9"/>
+          <p:cNvSpPr txBox="1"/>
+          <p:nvPr/>
+        </p:nvSpPr>
+        <p:spPr>
+          <a:xfrm>
+            <a:off x="429768" y="1353312"/>
+            <a:ext cx="1773936" cy="457200"/>
+          </a:xfrm>
+          <a:prstGeom prst="rect">
+            <a:avLst/>
+          </a:prstGeom>
+          <a:noFill/>
+        </p:spPr>
+        <p:txBody>
+          <a:bodyPr wrap="square">
+            <a:spAutoFit/>
+          </a:bodyPr>
+          <a:lstStyle/>
+          <a:p>
+            <a:pPr algn="l"/>
+            <a:r>
+              <a:rPr sz="2000" b="1" i="0">
+                <a:solidFill>
+                  <a:srgbClr val="0D2B3D"/>
+                </a:solidFill>
+                <a:latin typeface="Georgia"/>
+              </a:rPr>
+              <a:t>1.89M+</a:t>
+            </a:r>
+          </a:p>
+        </p:txBody>
+      </p:sp>
+      <p:sp>
+        <p:nvSpPr>
+          <p:cNvPr id="11" name="TextBox 10"/>
+          <p:cNvSpPr txBox="1"/>
+          <p:nvPr/>
+        </p:nvSpPr>
+        <p:spPr>
+          <a:xfrm>
+            <a:off x="429768" y="1828800"/>
+            <a:ext cx="1773936" cy="420624"/>
+          </a:xfrm>
+          <a:prstGeom prst="rect">
+            <a:avLst/>
+          </a:prstGeom>
+          <a:noFill/>
+        </p:spPr>
+        <p:txBody>
+          <a:bodyPr wrap="square">
+            <a:spAutoFit/>
+          </a:bodyPr>
+          <a:lstStyle/>
+          <a:p>
+            <a:pPr algn="l"/>
+            <a:r>
+              <a:rPr sz="900" b="0" i="0">
+                <a:solidFill>
+                  <a:srgbClr val="5A6A78"/>
+                </a:solidFill>
+                <a:latin typeface="Calibri"/>
+              </a:rPr>
+              <a:t>Patients/year</a:t>
+            </a:r>
+          </a:p>
+        </p:txBody>
+      </p:sp>
+      <p:sp>
+        <p:nvSpPr>
+          <p:cNvPr id="12" name="Rectangle 11"/>
+          <p:cNvSpPr/>
+          <p:nvPr/>
+        </p:nvSpPr>
+        <p:spPr>
+          <a:xfrm>
+            <a:off x="2432304" y="1261872"/>
+            <a:ext cx="1993392" cy="1078992"/>
+          </a:xfrm>
+          <a:prstGeom prst="rect">
+            <a:avLst/>
+          </a:prstGeom>
+          <a:solidFill>
+            <a:srgbClr val="FFFFFF"/>
+          </a:solidFill>
+          <a:ln w="9525">
+            <a:solidFill>
+              <a:srgbClr val="DDD5C8"/>
+            </a:solidFill>
+          </a:ln>
+        </p:spPr>
+        <p:style>
+          <a:lnRef idx="1">
+            <a:schemeClr val="accent1"/>
+          </a:lnRef>
+          <a:fillRef idx="3">
+            <a:schemeClr val="accent1"/>
+          </a:fillRef>
+          <a:effectRef idx="2">
+            <a:schemeClr val="accent1"/>
+          </a:effectRef>
+          <a:fontRef idx="minor">
+            <a:schemeClr val="lt1"/>
+          </a:fontRef>
+        </p:style>
+        <p:txBody>
+          <a:bodyPr rtlCol="0" anchor="ctr"/>
+          <a:lstStyle/>
+          <a:p>
+            <a:pPr algn="ctr"/>
+          </a:p>
+        </p:txBody>
+      </p:sp>
+      <p:sp>
+        <p:nvSpPr>
+          <p:cNvPr id="13" name="Rectangle 12"/>
+          <p:cNvSpPr/>
+          <p:nvPr/>
+        </p:nvSpPr>
+        <p:spPr>
+          <a:xfrm>
+            <a:off x="2432304" y="1261872"/>
+            <a:ext cx="1993392" cy="18000"/>
+          </a:xfrm>
+          <a:prstGeom prst="rect">
+            <a:avLst/>
+          </a:prstGeom>
+          <a:solidFill>
+            <a:srgbClr val="B44030"/>
+          </a:solidFill>
+          <a:ln>
+            <a:noFill/>
+          </a:ln>
+        </p:spPr>
+        <p:style>
+          <a:lnRef idx="1">
+            <a:schemeClr val="accent1"/>
+          </a:lnRef>
+          <a:fillRef idx="3">
+            <a:schemeClr val="accent1"/>
+          </a:fillRef>
+          <a:effectRef idx="2">
+            <a:schemeClr val="accent1"/>
+          </a:effectRef>
+          <a:fontRef idx="minor">
+            <a:schemeClr val="lt1"/>
+          </a:fontRef>
+        </p:style>
+        <p:txBody>
+          <a:bodyPr rtlCol="0" anchor="ctr"/>
+          <a:lstStyle/>
+          <a:p>
+            <a:pPr algn="ctr"/>
+          </a:p>
+        </p:txBody>
+      </p:sp>
+      <p:sp>
+        <p:nvSpPr>
+          <p:cNvPr id="14" name="TextBox 13"/>
+          <p:cNvSpPr txBox="1"/>
+          <p:nvPr/>
+        </p:nvSpPr>
+        <p:spPr>
+          <a:xfrm>
+            <a:off x="2542032" y="1353312"/>
+            <a:ext cx="1773936" cy="457200"/>
+          </a:xfrm>
+          <a:prstGeom prst="rect">
+            <a:avLst/>
+          </a:prstGeom>
+          <a:noFill/>
+        </p:spPr>
+        <p:txBody>
+          <a:bodyPr wrap="square">
+            <a:spAutoFit/>
+          </a:bodyPr>
+          <a:lstStyle/>
+          <a:p>
+            <a:pPr algn="l"/>
+            <a:r>
+              <a:rPr sz="2000" b="1" i="0">
+                <a:solidFill>
+                  <a:srgbClr val="0D2B3D"/>
+                </a:solidFill>
+                <a:latin typeface="Georgia"/>
+              </a:rPr>
+              <a:t>4,500+</a:t>
+            </a:r>
+          </a:p>
+        </p:txBody>
+      </p:sp>
+      <p:sp>
+        <p:nvSpPr>
+          <p:cNvPr id="15" name="TextBox 14"/>
+          <p:cNvSpPr txBox="1"/>
+          <p:nvPr/>
+        </p:nvSpPr>
+        <p:spPr>
+          <a:xfrm>
+            <a:off x="2542032" y="1828800"/>
+            <a:ext cx="1773936" cy="420624"/>
+          </a:xfrm>
+          <a:prstGeom prst="rect">
+            <a:avLst/>
+          </a:prstGeom>
+          <a:noFill/>
+        </p:spPr>
+        <p:txBody>
+          <a:bodyPr wrap="square">
+            <a:spAutoFit/>
+          </a:bodyPr>
+          <a:lstStyle/>
+          <a:p>
+            <a:pPr algn="l"/>
+            <a:r>
+              <a:rPr sz="900" b="0" i="0">
+                <a:solidFill>
+                  <a:srgbClr val="5A6A78"/>
+                </a:solidFill>
+                <a:latin typeface="Calibri"/>
+              </a:rPr>
+              <a:t>Beds &amp; growing</a:t>
+            </a:r>
+          </a:p>
+        </p:txBody>
+      </p:sp>
+      <p:sp>
+        <p:nvSpPr>
+          <p:cNvPr id="16" name="Rectangle 15"/>
+          <p:cNvSpPr/>
+          <p:nvPr/>
+        </p:nvSpPr>
+        <p:spPr>
+          <a:xfrm>
+            <a:off x="4544568" y="1261872"/>
+            <a:ext cx="1993392" cy="1078992"/>
+          </a:xfrm>
+          <a:prstGeom prst="rect">
+            <a:avLst/>
+          </a:prstGeom>
+          <a:solidFill>
+            <a:srgbClr val="FFFFFF"/>
+          </a:solidFill>
+          <a:ln w="9525">
+            <a:solidFill>
+              <a:srgbClr val="DDD5C8"/>
+            </a:solidFill>
+          </a:ln>
+        </p:spPr>
+        <p:style>
+          <a:lnRef idx="1">
+            <a:schemeClr val="accent1"/>
+          </a:lnRef>
+          <a:fillRef idx="3">
+            <a:schemeClr val="accent1"/>
+          </a:fillRef>
+          <a:effectRef idx="2">
+            <a:schemeClr val="accent1"/>
+          </a:effectRef>
+          <a:fontRef idx="minor">
+            <a:schemeClr val="lt1"/>
+          </a:fontRef>
+        </p:style>
+        <p:txBody>
+          <a:bodyPr rtlCol="0" anchor="ctr"/>
+          <a:lstStyle/>
+          <a:p>
+            <a:pPr algn="ctr"/>
+          </a:p>
+        </p:txBody>
+      </p:sp>
+      <p:sp>
+        <p:nvSpPr>
+          <p:cNvPr id="17" name="Rectangle 16"/>
+          <p:cNvSpPr/>
+          <p:nvPr/>
+        </p:nvSpPr>
+        <p:spPr>
+          <a:xfrm>
+            <a:off x="4544568" y="1261872"/>
+            <a:ext cx="1993392" cy="18000"/>
+          </a:xfrm>
+          <a:prstGeom prst="rect">
+            <a:avLst/>
+          </a:prstGeom>
+          <a:solidFill>
+            <a:srgbClr val="B44030"/>
+          </a:solidFill>
+          <a:ln>
+            <a:noFill/>
+          </a:ln>
+        </p:spPr>
+        <p:style>
+          <a:lnRef idx="1">
+            <a:schemeClr val="accent1"/>
+          </a:lnRef>
+          <a:fillRef idx="3">
+            <a:schemeClr val="accent1"/>
+          </a:fillRef>
+          <a:effectRef idx="2">
+            <a:schemeClr val="accent1"/>
+          </a:effectRef>
+          <a:fontRef idx="minor">
+            <a:schemeClr val="lt1"/>
+          </a:fontRef>
+        </p:style>
+        <p:txBody>
+          <a:bodyPr rtlCol="0" anchor="ctr"/>
+          <a:lstStyle/>
+          <a:p>
+            <a:pPr algn="ctr"/>
+          </a:p>
+        </p:txBody>
+      </p:sp>
+      <p:sp>
+        <p:nvSpPr>
+          <p:cNvPr id="18" name="TextBox 17"/>
+          <p:cNvSpPr txBox="1"/>
+          <p:nvPr/>
+        </p:nvSpPr>
+        <p:spPr>
+          <a:xfrm>
+            <a:off x="4654296" y="1353312"/>
+            <a:ext cx="1773936" cy="457200"/>
+          </a:xfrm>
+          <a:prstGeom prst="rect">
+            <a:avLst/>
+          </a:prstGeom>
+          <a:noFill/>
+        </p:spPr>
+        <p:txBody>
+          <a:bodyPr wrap="square">
+            <a:spAutoFit/>
+          </a:bodyPr>
+          <a:lstStyle/>
+          <a:p>
+            <a:pPr algn="l"/>
+            <a:r>
+              <a:rPr sz="2000" b="1" i="0">
+                <a:solidFill>
+                  <a:srgbClr val="0D2B3D"/>
+                </a:solidFill>
+                <a:latin typeface="Georgia"/>
+              </a:rPr>
+              <a:t>900+</a:t>
+            </a:r>
+          </a:p>
+        </p:txBody>
+      </p:sp>
+      <p:sp>
+        <p:nvSpPr>
+          <p:cNvPr id="19" name="TextBox 18"/>
+          <p:cNvSpPr txBox="1"/>
+          <p:nvPr/>
+        </p:nvSpPr>
+        <p:spPr>
+          <a:xfrm>
+            <a:off x="4654296" y="1828800"/>
+            <a:ext cx="1773936" cy="420624"/>
+          </a:xfrm>
+          <a:prstGeom prst="rect">
+            <a:avLst/>
+          </a:prstGeom>
+          <a:noFill/>
+        </p:spPr>
+        <p:txBody>
+          <a:bodyPr wrap="square">
+            <a:spAutoFit/>
+          </a:bodyPr>
+          <a:lstStyle/>
+          <a:p>
+            <a:pPr algn="l"/>
+            <a:r>
+              <a:rPr sz="900" b="0" i="0">
+                <a:solidFill>
+                  <a:srgbClr val="5A6A78"/>
+                </a:solidFill>
+                <a:latin typeface="Calibri"/>
+              </a:rPr>
+              <a:t>Doctors, 50+ specialties</a:t>
+            </a:r>
+          </a:p>
+        </p:txBody>
+      </p:sp>
+      <p:sp>
+        <p:nvSpPr>
+          <p:cNvPr id="20" name="Rectangle 19"/>
+          <p:cNvSpPr/>
+          <p:nvPr/>
+        </p:nvSpPr>
+        <p:spPr>
+          <a:xfrm>
+            <a:off x="6656832" y="1261872"/>
+            <a:ext cx="1993392" cy="1078992"/>
+          </a:xfrm>
+          <a:prstGeom prst="rect">
+            <a:avLst/>
+          </a:prstGeom>
+          <a:solidFill>
+            <a:srgbClr val="FFFFFF"/>
+          </a:solidFill>
+          <a:ln w="9525">
+            <a:solidFill>
+              <a:srgbClr val="DDD5C8"/>
+            </a:solidFill>
+          </a:ln>
+        </p:spPr>
+        <p:style>
+          <a:lnRef idx="1">
+            <a:schemeClr val="accent1"/>
+          </a:lnRef>
+          <a:fillRef idx="3">
+            <a:schemeClr val="accent1"/>
+          </a:fillRef>
+          <a:effectRef idx="2">
+            <a:schemeClr val="accent1"/>
+          </a:effectRef>
+          <a:fontRef idx="minor">
+            <a:schemeClr val="lt1"/>
+          </a:fontRef>
+        </p:style>
+        <p:txBody>
+          <a:bodyPr rtlCol="0" anchor="ctr"/>
+          <a:lstStyle/>
+          <a:p>
+            <a:pPr algn="ctr"/>
+          </a:p>
+        </p:txBody>
+      </p:sp>
+      <p:sp>
+        <p:nvSpPr>
+          <p:cNvPr id="21" name="Rectangle 20"/>
+          <p:cNvSpPr/>
+          <p:nvPr/>
+        </p:nvSpPr>
+        <p:spPr>
+          <a:xfrm>
+            <a:off x="6656832" y="1261872"/>
+            <a:ext cx="1993392" cy="18000"/>
+          </a:xfrm>
+          <a:prstGeom prst="rect">
+            <a:avLst/>
+          </a:prstGeom>
+          <a:solidFill>
+            <a:srgbClr val="B44030"/>
+          </a:solidFill>
+          <a:ln>
+            <a:noFill/>
+          </a:ln>
+        </p:spPr>
+        <p:style>
+          <a:lnRef idx="1">
+            <a:schemeClr val="accent1"/>
+          </a:lnRef>
+          <a:fillRef idx="3">
+            <a:schemeClr val="accent1"/>
+          </a:fillRef>
+          <a:effectRef idx="2">
+            <a:schemeClr val="accent1"/>
+          </a:effectRef>
+          <a:fontRef idx="minor">
+            <a:schemeClr val="lt1"/>
+          </a:fontRef>
+        </p:style>
+        <p:txBody>
+          <a:bodyPr rtlCol="0" anchor="ctr"/>
+          <a:lstStyle/>
+          <a:p>
+            <a:pPr algn="ctr"/>
+          </a:p>
+        </p:txBody>
+      </p:sp>
+      <p:sp>
+        <p:nvSpPr>
+          <p:cNvPr id="22" name="TextBox 21"/>
+          <p:cNvSpPr txBox="1"/>
+          <p:nvPr/>
+        </p:nvSpPr>
+        <p:spPr>
+          <a:xfrm>
+            <a:off x="6766560" y="1353312"/>
+            <a:ext cx="1773936" cy="457200"/>
+          </a:xfrm>
+          <a:prstGeom prst="rect">
+            <a:avLst/>
+          </a:prstGeom>
+          <a:noFill/>
+        </p:spPr>
+        <p:txBody>
+          <a:bodyPr wrap="square">
+            <a:spAutoFit/>
+          </a:bodyPr>
+          <a:lstStyle/>
+          <a:p>
+            <a:pPr algn="l"/>
+            <a:r>
+              <a:rPr sz="2000" b="1" i="0">
+                <a:solidFill>
+                  <a:srgbClr val="0D2B3D"/>
+                </a:solidFill>
+                <a:latin typeface="Georgia"/>
+              </a:rPr>
+              <a:t>31+</a:t>
+            </a:r>
+          </a:p>
+        </p:txBody>
+      </p:sp>
+      <p:sp>
+        <p:nvSpPr>
+          <p:cNvPr id="23" name="TextBox 22"/>
+          <p:cNvSpPr txBox="1"/>
+          <p:nvPr/>
+        </p:nvSpPr>
+        <p:spPr>
+          <a:xfrm>
+            <a:off x="6766560" y="1828800"/>
+            <a:ext cx="1773936" cy="420624"/>
+          </a:xfrm>
+          <a:prstGeom prst="rect">
+            <a:avLst/>
+          </a:prstGeom>
+          <a:noFill/>
+        </p:spPr>
+        <p:txBody>
+          <a:bodyPr wrap="square">
+            <a:spAutoFit/>
+          </a:bodyPr>
+          <a:lstStyle/>
+          <a:p>
+            <a:pPr algn="l"/>
+            <a:r>
+              <a:rPr sz="900" b="0" i="0">
+                <a:solidFill>
+                  <a:srgbClr val="5A6A78"/>
+                </a:solidFill>
+                <a:latin typeface="Calibri"/>
+              </a:rPr>
+              <a:t>Facilities across UAE &amp; GCC</a:t>
+            </a:r>
+          </a:p>
+        </p:txBody>
+      </p:sp>
+      <p:sp>
+        <p:nvSpPr>
+          <p:cNvPr id="24" name="Rectangle 23"/>
+          <p:cNvSpPr/>
+          <p:nvPr/>
+        </p:nvSpPr>
+        <p:spPr>
+          <a:xfrm>
+            <a:off x="320040" y="2487168"/>
+            <a:ext cx="4160520" cy="2176272"/>
+          </a:xfrm>
+          <a:prstGeom prst="rect">
+            <a:avLst/>
+          </a:prstGeom>
+          <a:solidFill>
+            <a:srgbClr val="FFFFFF"/>
+          </a:solidFill>
+          <a:ln w="9525">
+            <a:solidFill>
+              <a:srgbClr val="DDD5C8"/>
+            </a:solidFill>
+          </a:ln>
+        </p:spPr>
+        <p:style>
+          <a:lnRef idx="1">
+            <a:schemeClr val="accent1"/>
+          </a:lnRef>
+          <a:fillRef idx="3">
+            <a:schemeClr val="accent1"/>
+          </a:fillRef>
+          <a:effectRef idx="2">
+            <a:schemeClr val="accent1"/>
+          </a:effectRef>
+          <a:fontRef idx="minor">
+            <a:schemeClr val="lt1"/>
+          </a:fontRef>
+        </p:style>
+        <p:txBody>
+          <a:bodyPr rtlCol="0" anchor="ctr"/>
+          <a:lstStyle/>
+          <a:p>
+            <a:pPr algn="ctr"/>
+          </a:p>
+        </p:txBody>
+      </p:sp>
+      <p:sp>
+        <p:nvSpPr>
+          <p:cNvPr id="25" name="Rectangle 24"/>
+          <p:cNvSpPr/>
+          <p:nvPr/>
+        </p:nvSpPr>
+        <p:spPr>
+          <a:xfrm>
+            <a:off x="320040" y="2487168"/>
+            <a:ext cx="4160520" cy="18000"/>
+          </a:xfrm>
+          <a:prstGeom prst="rect">
+            <a:avLst/>
+          </a:prstGeom>
+          <a:solidFill>
+            <a:srgbClr val="B44030"/>
+          </a:solidFill>
+          <a:ln>
+            <a:noFill/>
+          </a:ln>
+        </p:spPr>
+        <p:style>
+          <a:lnRef idx="1">
+            <a:schemeClr val="accent1"/>
+          </a:lnRef>
+          <a:fillRef idx="3">
+            <a:schemeClr val="accent1"/>
+          </a:fillRef>
+          <a:effectRef idx="2">
+            <a:schemeClr val="accent1"/>
+          </a:effectRef>
+          <a:fontRef idx="minor">
+            <a:schemeClr val="lt1"/>
+          </a:fontRef>
+        </p:style>
+        <p:txBody>
+          <a:bodyPr rtlCol="0" anchor="ctr"/>
+          <a:lstStyle/>
+          <a:p>
+            <a:pPr algn="ctr"/>
+          </a:p>
+        </p:txBody>
+      </p:sp>
+      <p:sp>
+        <p:nvSpPr>
+          <p:cNvPr id="26" name="TextBox 25"/>
+          <p:cNvSpPr txBox="1"/>
+          <p:nvPr/>
+        </p:nvSpPr>
+        <p:spPr>
+          <a:xfrm>
+            <a:off x="457200" y="2560320"/>
+            <a:ext cx="3886200" cy="292608"/>
+          </a:xfrm>
+          <a:prstGeom prst="rect">
+            <a:avLst/>
+          </a:prstGeom>
+          <a:noFill/>
+        </p:spPr>
+        <p:txBody>
+          <a:bodyPr wrap="square">
+            <a:spAutoFit/>
+          </a:bodyPr>
+          <a:lstStyle/>
+          <a:p>
+            <a:pPr algn="l"/>
+            <a:r>
+              <a:rPr sz="1000" b="1" i="0">
+                <a:solidFill>
+                  <a:srgbClr val="0D2B3D"/>
+                </a:solidFill>
+                <a:latin typeface="Georgia"/>
+              </a:rPr>
+              <a:t>What They Do</a:t>
+            </a:r>
+          </a:p>
+        </p:txBody>
+      </p:sp>
+      <p:sp>
+        <p:nvSpPr>
+          <p:cNvPr id="27" name="Rectangle 26"/>
+          <p:cNvSpPr/>
+          <p:nvPr/>
+        </p:nvSpPr>
+        <p:spPr>
+          <a:xfrm>
+            <a:off x="457200" y="2889504"/>
+            <a:ext cx="3886200" cy="9200"/>
+          </a:xfrm>
+          <a:prstGeom prst="rect">
+            <a:avLst/>
+          </a:prstGeom>
+          <a:solidFill>
+            <a:srgbClr val="DDD5C8"/>
+          </a:solidFill>
+          <a:ln>
+            <a:noFill/>
+          </a:ln>
+        </p:spPr>
+        <p:style>
+          <a:lnRef idx="1">
+            <a:schemeClr val="accent1"/>
+          </a:lnRef>
+          <a:fillRef idx="3">
+            <a:schemeClr val="accent1"/>
+          </a:fillRef>
+          <a:effectRef idx="2">
+            <a:schemeClr val="accent1"/>
+          </a:effectRef>
+          <a:fontRef idx="minor">
+            <a:schemeClr val="lt1"/>
+          </a:fontRef>
+        </p:style>
+        <p:txBody>
+          <a:bodyPr rtlCol="0" anchor="ctr"/>
+          <a:lstStyle/>
+          <a:p>
+            <a:pPr algn="ctr"/>
+          </a:p>
+        </p:txBody>
+      </p:sp>
+      <p:sp>
+        <p:nvSpPr>
+          <p:cNvPr id="28" name="TextBox 27"/>
+          <p:cNvSpPr txBox="1"/>
+          <p:nvPr/>
+        </p:nvSpPr>
+        <p:spPr>
+          <a:xfrm>
+            <a:off x="457200" y="2962656"/>
+            <a:ext cx="3886200" cy="1572768"/>
+          </a:xfrm>
+          <a:prstGeom prst="rect">
+            <a:avLst/>
+          </a:prstGeom>
+          <a:noFill/>
+        </p:spPr>
+        <p:txBody>
+          <a:bodyPr wrap="square">
+            <a:spAutoFit/>
+          </a:bodyPr>
+          <a:lstStyle/>
+          <a:p>
+            <a:pPr algn="l">
+              <a:spcBef>
+                <a:spcPts val="300"/>
+              </a:spcBef>
+            </a:pPr>
+            <a:r>
+              <a:rPr sz="850">
+                <a:solidFill>
+                  <a:srgbClr val="5A6A78"/>
+                </a:solidFill>
+                <a:latin typeface="Calibri"/>
+              </a:rPr>
+              <a:t>• Multi-specialty tertiary &amp; quaternary care across medicine, surgery, oncology, neuroscience, and women's health</a:t>
+            </a:r>
+          </a:p>
+          <a:p>
+            <a:pPr algn="l">
+              <a:spcBef>
+                <a:spcPts val="300"/>
+              </a:spcBef>
+            </a:pPr>
+            <a:r>
+              <a:rPr sz="850">
+                <a:solidFill>
+                  <a:srgbClr val="5A6A78"/>
+                </a:solidFill>
+                <a:latin typeface="Calibri"/>
+              </a:rPr>
+              <a:t>• Primary care network — 22 Medicentres clinics across Dubai and the Northern Emirates</a:t>
+            </a:r>
+          </a:p>
+          <a:p>
+            <a:pPr algn="l">
+              <a:spcBef>
+                <a:spcPts val="300"/>
+              </a:spcBef>
+            </a:pPr>
+            <a:r>
+              <a:rPr sz="850">
+                <a:solidFill>
+                  <a:srgbClr val="5A6A78"/>
+                </a:solidFill>
+                <a:latin typeface="Calibri"/>
+              </a:rPr>
+              <a:t>• Advanced diagnostics: CAP-accredited labs, imaging, and robotic surgery programs</a:t>
+            </a:r>
+          </a:p>
+          <a:p>
+            <a:pPr algn="l">
+              <a:spcBef>
+                <a:spcPts val="300"/>
+              </a:spcBef>
+            </a:pPr>
+            <a:r>
+              <a:rPr sz="850">
+                <a:solidFill>
+                  <a:srgbClr val="5A6A78"/>
+                </a:solidFill>
+                <a:latin typeface="Calibri"/>
+              </a:rPr>
+              <a:t>• Academic &amp; research hospital: Fakeeh University Hospital (Dubai Silicon Oasis) — DHA accredited</a:t>
+            </a:r>
+          </a:p>
+          <a:p>
+            <a:pPr algn="l">
+              <a:spcBef>
+                <a:spcPts val="300"/>
+              </a:spcBef>
+            </a:pPr>
+            <a:r>
+              <a:rPr sz="850">
+                <a:solidFill>
+                  <a:srgbClr val="5A6A78"/>
+                </a:solidFill>
+                <a:latin typeface="Calibri"/>
+              </a:rPr>
+              <a:t>• Telehealth &amp; digital health programs serving remote and expatriate populations</a:t>
+            </a:r>
+          </a:p>
+        </p:txBody>
+      </p:sp>
+      <p:sp>
+        <p:nvSpPr>
+          <p:cNvPr id="29" name="Rectangle 28"/>
+          <p:cNvSpPr/>
+          <p:nvPr/>
+        </p:nvSpPr>
+        <p:spPr>
+          <a:xfrm>
+            <a:off x="4599432" y="2487168"/>
+            <a:ext cx="4160520" cy="2176272"/>
+          </a:xfrm>
+          <a:prstGeom prst="rect">
+            <a:avLst/>
+          </a:prstGeom>
+          <a:solidFill>
+            <a:srgbClr val="FFFFFF"/>
+          </a:solidFill>
+          <a:ln w="9525">
+            <a:solidFill>
+              <a:srgbClr val="DDD5C8"/>
+            </a:solidFill>
+          </a:ln>
+        </p:spPr>
+        <p:style>
+          <a:lnRef idx="1">
+            <a:schemeClr val="accent1"/>
+          </a:lnRef>
+          <a:fillRef idx="3">
+            <a:schemeClr val="accent1"/>
+          </a:fillRef>
+          <a:effectRef idx="2">
+            <a:schemeClr val="accent1"/>
+          </a:effectRef>
+          <a:fontRef idx="minor">
+            <a:schemeClr val="lt1"/>
+          </a:fontRef>
+        </p:style>
+        <p:txBody>
+          <a:bodyPr rtlCol="0" anchor="ctr"/>
+          <a:lstStyle/>
+          <a:p>
+            <a:pPr algn="ctr"/>
+          </a:p>
+        </p:txBody>
+      </p:sp>
+      <p:sp>
+        <p:nvSpPr>
+          <p:cNvPr id="30" name="Rectangle 29"/>
+          <p:cNvSpPr/>
+          <p:nvPr/>
+        </p:nvSpPr>
+        <p:spPr>
+          <a:xfrm>
+            <a:off x="4599432" y="2487168"/>
+            <a:ext cx="4160520" cy="18000"/>
+          </a:xfrm>
+          <a:prstGeom prst="rect">
+            <a:avLst/>
+          </a:prstGeom>
+          <a:solidFill>
+            <a:srgbClr val="B44030"/>
+          </a:solidFill>
+          <a:ln>
+            <a:noFill/>
+          </a:ln>
+        </p:spPr>
+        <p:style>
+          <a:lnRef idx="1">
+            <a:schemeClr val="accent1"/>
+          </a:lnRef>
+          <a:fillRef idx="3">
+            <a:schemeClr val="accent1"/>
+          </a:fillRef>
+          <a:effectRef idx="2">
+            <a:schemeClr val="accent1"/>
+          </a:effectRef>
+          <a:fontRef idx="minor">
+            <a:schemeClr val="lt1"/>
+          </a:fontRef>
+        </p:style>
+        <p:txBody>
+          <a:bodyPr rtlCol="0" anchor="ctr"/>
+          <a:lstStyle/>
+          <a:p>
+            <a:pPr algn="ctr"/>
+          </a:p>
+        </p:txBody>
+      </p:sp>
+      <p:sp>
+        <p:nvSpPr>
+          <p:cNvPr id="31" name="TextBox 30"/>
+          <p:cNvSpPr txBox="1"/>
+          <p:nvPr/>
+        </p:nvSpPr>
+        <p:spPr>
+          <a:xfrm>
+            <a:off x="4736592" y="2560320"/>
+            <a:ext cx="3886200" cy="292608"/>
+          </a:xfrm>
+          <a:prstGeom prst="rect">
+            <a:avLst/>
+          </a:prstGeom>
+          <a:noFill/>
+        </p:spPr>
+        <p:txBody>
+          <a:bodyPr wrap="square">
+            <a:spAutoFit/>
+          </a:bodyPr>
+          <a:lstStyle/>
+          <a:p>
+            <a:pPr algn="l"/>
+            <a:r>
+              <a:rPr sz="1000" b="1" i="0">
+                <a:solidFill>
+                  <a:srgbClr val="0D2B3D"/>
+                </a:solidFill>
+                <a:latin typeface="Georgia"/>
+              </a:rPr>
+              <a:t>Scale &amp; Capacity</a:t>
+            </a:r>
+          </a:p>
+        </p:txBody>
+      </p:sp>
+      <p:sp>
+        <p:nvSpPr>
+          <p:cNvPr id="32" name="Rectangle 31"/>
+          <p:cNvSpPr/>
+          <p:nvPr/>
+        </p:nvSpPr>
+        <p:spPr>
+          <a:xfrm>
+            <a:off x="4736592" y="2889504"/>
+            <a:ext cx="3886200" cy="9200"/>
+          </a:xfrm>
+          <a:prstGeom prst="rect">
+            <a:avLst/>
+          </a:prstGeom>
+          <a:solidFill>
+            <a:srgbClr val="DDD5C8"/>
+          </a:solidFill>
+          <a:ln>
+            <a:noFill/>
+          </a:ln>
+        </p:spPr>
+        <p:style>
+          <a:lnRef idx="1">
+            <a:schemeClr val="accent1"/>
+          </a:lnRef>
+          <a:fillRef idx="3">
+            <a:schemeClr val="accent1"/>
+          </a:fillRef>
+          <a:effectRef idx="2">
+            <a:schemeClr val="accent1"/>
+          </a:effectRef>
+          <a:fontRef idx="minor">
+            <a:schemeClr val="lt1"/>
+          </a:fontRef>
+        </p:style>
+        <p:txBody>
+          <a:bodyPr rtlCol="0" anchor="ctr"/>
+          <a:lstStyle/>
+          <a:p>
+            <a:pPr algn="ctr"/>
+          </a:p>
+        </p:txBody>
+      </p:sp>
+      <p:sp>
+        <p:nvSpPr>
+          <p:cNvPr id="33" name="TextBox 32"/>
+          <p:cNvSpPr txBox="1"/>
+          <p:nvPr/>
+        </p:nvSpPr>
+        <p:spPr>
+          <a:xfrm>
+            <a:off x="4736592" y="2962656"/>
+            <a:ext cx="3886200" cy="1572768"/>
+          </a:xfrm>
+          <a:prstGeom prst="rect">
+            <a:avLst/>
+          </a:prstGeom>
+          <a:noFill/>
+        </p:spPr>
+        <p:txBody>
+          <a:bodyPr wrap="square">
+            <a:spAutoFit/>
+          </a:bodyPr>
+          <a:lstStyle/>
+          <a:p>
+            <a:pPr algn="l">
+              <a:spcBef>
+                <a:spcPts val="300"/>
+              </a:spcBef>
+            </a:pPr>
+            <a:r>
+              <a:rPr sz="850">
+                <a:solidFill>
+                  <a:srgbClr val="5A6A78"/>
+                </a:solidFill>
+                <a:latin typeface="Calibri"/>
+              </a:rPr>
+              <a:t>• Flagship: Fakeeh University Hospital, Dubai — 450+ beds, 24/7 emergency &amp; ICU</a:t>
+            </a:r>
+          </a:p>
+          <a:p>
+            <a:pPr algn="l">
+              <a:spcBef>
+                <a:spcPts val="300"/>
+              </a:spcBef>
+            </a:pPr>
+            <a:r>
+              <a:rPr sz="850">
+                <a:solidFill>
+                  <a:srgbClr val="5A6A78"/>
+                </a:solidFill>
+                <a:latin typeface="Calibri"/>
+              </a:rPr>
+              <a:t>• 4 hospitals today → 7 hospitals by 2028 (1,675 beds target)</a:t>
+            </a:r>
+          </a:p>
+          <a:p>
+            <a:pPr algn="l">
+              <a:spcBef>
+                <a:spcPts val="300"/>
+              </a:spcBef>
+            </a:pPr>
+            <a:r>
+              <a:rPr sz="850">
+                <a:solidFill>
+                  <a:srgbClr val="5A6A78"/>
+                </a:solidFill>
+                <a:latin typeface="Calibri"/>
+              </a:rPr>
+              <a:t>• AED 500M+ HEAL Neuroscience Centre under construction</a:t>
+            </a:r>
+          </a:p>
+          <a:p>
+            <a:pPr algn="l">
+              <a:spcBef>
+                <a:spcPts val="300"/>
+              </a:spcBef>
+            </a:pPr>
+            <a:r>
+              <a:rPr sz="850">
+                <a:solidFill>
+                  <a:srgbClr val="5A6A78"/>
+                </a:solidFill>
+                <a:latin typeface="Calibri"/>
+              </a:rPr>
+              <a:t>• JCI Accredited (6th consecutive time) · ANCC Magnet Nursing Recognition</a:t>
+            </a:r>
+          </a:p>
+          <a:p>
+            <a:pPr algn="l">
+              <a:spcBef>
+                <a:spcPts val="300"/>
+              </a:spcBef>
+            </a:pPr>
+            <a:r>
+              <a:rPr sz="850">
+                <a:solidFill>
+                  <a:srgbClr val="5A6A78"/>
+                </a:solidFill>
+                <a:latin typeface="Calibri"/>
+              </a:rPr>
+              <a:t>• Listed on Tadawul (4017/FAKEEHCA) since June 2024 — SAR 3.1B revenue FY2025</a:t>
+            </a:r>
+          </a:p>
+        </p:txBody>
+      </p:sp>
+      <p:sp>
+        <p:nvSpPr>
+          <p:cNvPr id="34" name="TextBox 33"/>
+          <p:cNvSpPr txBox="1"/>
+          <p:nvPr/>
+        </p:nvSpPr>
+        <p:spPr>
+          <a:xfrm>
+            <a:off x="320040" y="4727448"/>
+            <a:ext cx="8503920" cy="329184"/>
+          </a:xfrm>
+          <a:prstGeom prst="rect">
+            <a:avLst/>
+          </a:prstGeom>
+          <a:noFill/>
+        </p:spPr>
+        <p:txBody>
+          <a:bodyPr wrap="square">
+            <a:spAutoFit/>
+          </a:bodyPr>
+          <a:lstStyle/>
+          <a:p>
+            <a:pPr algn="l"/>
+            <a:r>
+              <a:rPr sz="850" b="0" i="1">
+                <a:solidFill>
+                  <a:srgbClr val="5A6A78"/>
+                </a:solidFill>
+                <a:latin typeface="Calibri"/>
+              </a:rPr>
+              <a:t>Fakeeh Care Group is expanding rapidly across Dubai and the GCC — with the patient volume, infrastructure, and ambition to make AI-powered care transformation both timely and impactful.</a:t>
+            </a:r>
+          </a:p>
+        </p:txBody>
+      </p:sp>
+      <p:pic>
+        <p:nvPicPr>
+          <p:cNvPr id="98" name="Google Shape;98;p13" title="download.jfif"/>
+          <p:cNvPicPr preferRelativeResize="0"/>
+          <p:nvPr/>
+        </p:nvPicPr>
+        <p:blipFill>
+          <a:blip r:embed="rId4">
+            <a:alphaModFix/>
+          </a:blip>
+          <a:stretch>
+            <a:fillRect/>
+          </a:stretch>
+        </p:blipFill>
+        <p:spPr>
+          <a:xfrm>
+            <a:off x="7941600" y="4628100"/>
+            <a:ext cx="966625" cy="241650"/>
+          </a:xfrm>
+          <a:prstGeom prst="rect">
+            <a:avLst/>
+          </a:prstGeom>
+          <a:noFill/>
+          <a:ln>
+            <a:noFill/>
+          </a:ln>
+        </p:spPr>
+      </p:pic>
+    </p:spTree>
+  </p:cSld>
+  <p:clrMapOvr>
+    <a:masterClrMapping/>
+  </p:clrMapOvr>
+</p:sld>
+</file>
+
+<file path=ppt/slides/slide3.xml><?xml version="1.0" encoding="utf-8"?>
 <p:sld xmlns:a="http://schemas.openxmlformats.org/drawingml/2006/main" xmlns:r="http://schemas.openxmlformats.org/officeDocument/2006/relationships" xmlns:mc="http://schemas.openxmlformats.org/markup-compatibility/2006" xmlns:mv="urn:schemas-microsoft-com:mac:vml" xmlns:p="http://schemas.openxmlformats.org/presentationml/2006/main" xmlns:c="http://schemas.openxmlformats.org/drawingml/2006/chart" xmlns:dgm="http://schemas.openxmlformats.org/drawingml/2006/diagram" xmlns:o="urn:schemas-microsoft-com:office:office" xmlns:v="urn:schemas-microsoft-com:vml" xmlns:pvml="urn:schemas-microsoft-com:office:powerpoint" xmlns:com="http://schemas.openxmlformats.org/drawingml/2006/compatibility" xmlns:p14="http://schemas.microsoft.com/office/powerpoint/2010/main" xmlns:p15="http://schemas.microsoft.com/office/powerpoint/2012/main" xmlns:ahyp="http://schemas.microsoft.com/office/drawing/2018/hyperlinkcolor">
   <p:cSld>
     <p:spTree>
@@ -14680,7 +16147,7 @@
 </p:sld>
 </file>
 
-<file path=ppt/slides/slide3.xml><?xml version="1.0" encoding="utf-8"?>
+<file path=ppt/slides/slide4.xml><?xml version="1.0" encoding="utf-8"?>
 <p:sld xmlns:a="http://schemas.openxmlformats.org/drawingml/2006/main" xmlns:r="http://schemas.openxmlformats.org/officeDocument/2006/relationships" xmlns:mc="http://schemas.openxmlformats.org/markup-compatibility/2006" xmlns:mv="urn:schemas-microsoft-com:mac:vml" xmlns:p="http://schemas.openxmlformats.org/presentationml/2006/main" xmlns:c="http://schemas.openxmlformats.org/drawingml/2006/chart" xmlns:dgm="http://schemas.openxmlformats.org/drawingml/2006/diagram" xmlns:o="urn:schemas-microsoft-com:office:office" xmlns:v="urn:schemas-microsoft-com:vml" xmlns:pvml="urn:schemas-microsoft-com:office:powerpoint" xmlns:com="http://schemas.openxmlformats.org/drawingml/2006/compatibility" xmlns:p14="http://schemas.microsoft.com/office/powerpoint/2010/main" xmlns:p15="http://schemas.microsoft.com/office/powerpoint/2012/main" xmlns:ahyp="http://schemas.microsoft.com/office/drawing/2018/hyperlinkcolor">
   <p:cSld>
     <p:spTree>
@@ -14857,7 +16324,7 @@
                 <a:cs typeface="Calibri"/>
                 <a:sym typeface="Calibri"/>
               </a:rPr>
-              <a:t>We understand the challenges faced by Fakeeh</a:t>
+              <a:t>Fakeeh faces deep, systemic challenges — and these are just a few</a:t>
             </a:r>
             <a:endParaRPr b="0" sz="2200">
               <a:solidFill>
@@ -14889,7 +16356,7 @@
                 <a:cs typeface="Calibri"/>
                 <a:sym typeface="Calibri"/>
               </a:rPr>
-              <a:t>Healthcare organizations at Fakeeh's scale struggle to efficiently deliver care as demand outpaces capacity.</a:t>
+              <a:t>Beyond capacity constraints, Fakeeh navigates complexity across patient engagement, multilingual care, chronic disease, home health, and rapid multi-site expansion — each requiring a tailored, scalable solution.</a:t>
             </a:r>
             <a:endParaRPr i="1" sz="1000">
               <a:solidFill>
@@ -16302,6 +17769,84 @@
           </a:ln>
         </p:spPr>
       </p:pic>
+      <p:sp>
+        <p:nvSpPr>
+          <p:cNvPr id="196" name="Rectangle 195"/>
+          <p:cNvSpPr/>
+          <p:nvPr/>
+        </p:nvSpPr>
+        <p:spPr>
+          <a:xfrm>
+            <a:off x="0" y="4645152"/>
+            <a:ext cx="9144000" cy="498348"/>
+          </a:xfrm>
+          <a:prstGeom prst="rect">
+            <a:avLst/>
+          </a:prstGeom>
+          <a:solidFill>
+            <a:srgbClr val="B44030"/>
+          </a:solidFill>
+          <a:ln>
+            <a:noFill/>
+          </a:ln>
+        </p:spPr>
+        <p:style>
+          <a:lnRef idx="1">
+            <a:schemeClr val="accent1"/>
+          </a:lnRef>
+          <a:fillRef idx="3">
+            <a:schemeClr val="accent1"/>
+          </a:fillRef>
+          <a:effectRef idx="2">
+            <a:schemeClr val="accent1"/>
+          </a:effectRef>
+          <a:fontRef idx="minor">
+            <a:schemeClr val="lt1"/>
+          </a:fontRef>
+        </p:style>
+        <p:txBody>
+          <a:bodyPr rtlCol="0" anchor="ctr"/>
+          <a:lstStyle/>
+          <a:p>
+            <a:pPr algn="ctr"/>
+          </a:p>
+        </p:txBody>
+      </p:sp>
+      <p:sp>
+        <p:nvSpPr>
+          <p:cNvPr id="197" name="TextBox 196"/>
+          <p:cNvSpPr txBox="1"/>
+          <p:nvPr/>
+        </p:nvSpPr>
+        <p:spPr>
+          <a:xfrm>
+            <a:off x="320040" y="4663440"/>
+            <a:ext cx="8503920" cy="457200"/>
+          </a:xfrm>
+          <a:prstGeom prst="rect">
+            <a:avLst/>
+          </a:prstGeom>
+          <a:noFill/>
+        </p:spPr>
+        <p:txBody>
+          <a:bodyPr wrap="square">
+            <a:spAutoFit/>
+          </a:bodyPr>
+          <a:lstStyle/>
+          <a:p>
+            <a:pPr algn="l"/>
+            <a:r>
+              <a:rPr sz="800" b="0" i="1">
+                <a:solidFill>
+                  <a:srgbClr val="FFFFFF"/>
+                </a:solidFill>
+                <a:latin typeface="Calibri"/>
+              </a:rPr>
+              <a:t>These 6 challenges are the tip of the iceberg — Fakeeh also contends with referral leakage, insurance pre-authorization delays, provider onboarding complexity, and post-discharge readmission risk. Amigo's platform is built to address the full spectrum.</a:t>
+            </a:r>
+          </a:p>
+        </p:txBody>
+      </p:sp>
     </p:spTree>
   </p:cSld>
   <p:clrMapOvr>
@@ -16310,7 +17855,7 @@
 </p:sld>
 </file>
 
-<file path=ppt/slides/slide4.xml><?xml version="1.0" encoding="utf-8"?>
+<file path=ppt/slides/slide5.xml><?xml version="1.0" encoding="utf-8"?>
 <p:sld xmlns:a="http://schemas.openxmlformats.org/drawingml/2006/main" xmlns:r="http://schemas.openxmlformats.org/officeDocument/2006/relationships" xmlns:mc="http://schemas.openxmlformats.org/markup-compatibility/2006" xmlns:mv="urn:schemas-microsoft-com:mac:vml" xmlns:p="http://schemas.openxmlformats.org/presentationml/2006/main" xmlns:c="http://schemas.openxmlformats.org/drawingml/2006/chart" xmlns:dgm="http://schemas.openxmlformats.org/drawingml/2006/diagram" xmlns:o="urn:schemas-microsoft-com:office:office" xmlns:v="urn:schemas-microsoft-com:vml" xmlns:pvml="urn:schemas-microsoft-com:office:powerpoint" xmlns:com="http://schemas.openxmlformats.org/drawingml/2006/compatibility" xmlns:p14="http://schemas.microsoft.com/office/powerpoint/2010/main" xmlns:p15="http://schemas.microsoft.com/office/powerpoint/2012/main" xmlns:ahyp="http://schemas.microsoft.com/office/drawing/2018/hyperlinkcolor">
   <p:cSld>
     <p:bg>
@@ -18486,7 +20031,7 @@
 </p:sld>
 </file>
 
-<file path=ppt/slides/slide5.xml><?xml version="1.0" encoding="utf-8"?>
+<file path=ppt/slides/slide6.xml><?xml version="1.0" encoding="utf-8"?>
 <p:sld xmlns:a="http://schemas.openxmlformats.org/drawingml/2006/main" xmlns:r="http://schemas.openxmlformats.org/officeDocument/2006/relationships" xmlns:mc="http://schemas.openxmlformats.org/markup-compatibility/2006" xmlns:mv="urn:schemas-microsoft-com:mac:vml" xmlns:p="http://schemas.openxmlformats.org/presentationml/2006/main" xmlns:c="http://schemas.openxmlformats.org/drawingml/2006/chart" xmlns:dgm="http://schemas.openxmlformats.org/drawingml/2006/diagram" xmlns:o="urn:schemas-microsoft-com:office:office" xmlns:v="urn:schemas-microsoft-com:vml" xmlns:pvml="urn:schemas-microsoft-com:office:powerpoint" xmlns:com="http://schemas.openxmlformats.org/drawingml/2006/compatibility" xmlns:p14="http://schemas.microsoft.com/office/powerpoint/2010/main" xmlns:p15="http://schemas.microsoft.com/office/powerpoint/2012/main" xmlns:ahyp="http://schemas.microsoft.com/office/drawing/2018/hyperlinkcolor">
   <p:cSld>
     <p:spTree>
@@ -21063,7 +22608,7 @@
 </p:sld>
 </file>
 
-<file path=ppt/slides/slide6.xml><?xml version="1.0" encoding="utf-8"?>
+<file path=ppt/slides/slide7.xml><?xml version="1.0" encoding="utf-8"?>
 <p:sld xmlns:a="http://schemas.openxmlformats.org/drawingml/2006/main" xmlns:r="http://schemas.openxmlformats.org/officeDocument/2006/relationships" xmlns:mc="http://schemas.openxmlformats.org/markup-compatibility/2006" xmlns:mv="urn:schemas-microsoft-com:mac:vml" xmlns:p="http://schemas.openxmlformats.org/presentationml/2006/main" xmlns:c="http://schemas.openxmlformats.org/drawingml/2006/chart" xmlns:dgm="http://schemas.openxmlformats.org/drawingml/2006/diagram" xmlns:o="urn:schemas-microsoft-com:office:office" xmlns:v="urn:schemas-microsoft-com:vml" xmlns:pvml="urn:schemas-microsoft-com:office:powerpoint" xmlns:com="http://schemas.openxmlformats.org/drawingml/2006/compatibility" xmlns:p14="http://schemas.microsoft.com/office/powerpoint/2010/main" xmlns:p15="http://schemas.microsoft.com/office/powerpoint/2012/main" xmlns:ahyp="http://schemas.microsoft.com/office/drawing/2018/hyperlinkcolor">
   <p:cSld>
     <p:spTree>
@@ -24058,7 +25603,7 @@
 </p:sld>
 </file>
 
-<file path=ppt/slides/slide7.xml><?xml version="1.0" encoding="utf-8"?>
+<file path=ppt/slides/slide8.xml><?xml version="1.0" encoding="utf-8"?>
 <p:sld xmlns:a="http://schemas.openxmlformats.org/drawingml/2006/main" xmlns:r="http://schemas.openxmlformats.org/officeDocument/2006/relationships" xmlns:mc="http://schemas.openxmlformats.org/markup-compatibility/2006" xmlns:mv="urn:schemas-microsoft-com:mac:vml" xmlns:p="http://schemas.openxmlformats.org/presentationml/2006/main" xmlns:c="http://schemas.openxmlformats.org/drawingml/2006/chart" xmlns:dgm="http://schemas.openxmlformats.org/drawingml/2006/diagram" xmlns:o="urn:schemas-microsoft-com:office:office" xmlns:v="urn:schemas-microsoft-com:vml" xmlns:pvml="urn:schemas-microsoft-com:office:powerpoint" xmlns:com="http://schemas.openxmlformats.org/drawingml/2006/compatibility" xmlns:p14="http://schemas.microsoft.com/office/powerpoint/2010/main" xmlns:p15="http://schemas.microsoft.com/office/powerpoint/2012/main" xmlns:ahyp="http://schemas.microsoft.com/office/drawing/2018/hyperlinkcolor">
   <p:cSld>
     <p:spTree>
@@ -25630,1473 +27175,6 @@
 </p:sld>
 </file>
 
-<file path=ppt/slides/slide8.xml><?xml version="1.0" encoding="utf-8"?>
-<p:sld xmlns:a="http://schemas.openxmlformats.org/drawingml/2006/main" xmlns:p="http://schemas.openxmlformats.org/presentationml/2006/main" xmlns:r="http://schemas.openxmlformats.org/officeDocument/2006/relationships">
-  <p:cSld>
-    <p:spTree>
-      <p:nvGrpSpPr>
-        <p:cNvPr id="1" name=""/>
-        <p:cNvGrpSpPr/>
-        <p:nvPr/>
-      </p:nvGrpSpPr>
-      <p:grpSpPr/>
-      <p:sp>
-        <p:nvSpPr>
-          <p:cNvPr id="2" name="Title 1"/>
-          <p:cNvSpPr>
-            <a:spLocks noGrp="1"/>
-          </p:cNvSpPr>
-          <p:nvPr>
-            <p:ph type="title"/>
-          </p:nvPr>
-        </p:nvSpPr>
-        <p:spPr/>
-        <p:txBody>
-          <a:bodyPr/>
-          <a:lstStyle/>
-          <a:p/>
-        </p:txBody>
-      </p:sp>
-      <p:sp>
-        <p:nvSpPr>
-          <p:cNvPr id="3" name="Rectangle 2"/>
-          <p:cNvSpPr/>
-          <p:nvPr/>
-        </p:nvSpPr>
-        <p:spPr>
-          <a:xfrm>
-            <a:off x="0" y="0"/>
-            <a:ext cx="9144000" cy="5143500"/>
-          </a:xfrm>
-          <a:prstGeom prst="rect">
-            <a:avLst/>
-          </a:prstGeom>
-          <a:solidFill>
-            <a:srgbClr val="F7F5F0"/>
-          </a:solidFill>
-          <a:ln>
-            <a:noFill/>
-          </a:ln>
-        </p:spPr>
-        <p:style>
-          <a:lnRef idx="1">
-            <a:schemeClr val="accent1"/>
-          </a:lnRef>
-          <a:fillRef idx="3">
-            <a:schemeClr val="accent1"/>
-          </a:fillRef>
-          <a:effectRef idx="2">
-            <a:schemeClr val="accent1"/>
-          </a:effectRef>
-          <a:fontRef idx="minor">
-            <a:schemeClr val="lt1"/>
-          </a:fontRef>
-        </p:style>
-        <p:txBody>
-          <a:bodyPr rtlCol="0" anchor="ctr"/>
-          <a:lstStyle/>
-          <a:p>
-            <a:pPr algn="ctr"/>
-          </a:p>
-        </p:txBody>
-      </p:sp>
-      <p:sp>
-        <p:nvSpPr>
-          <p:cNvPr id="4" name="Rectangle 3"/>
-          <p:cNvSpPr/>
-          <p:nvPr/>
-        </p:nvSpPr>
-        <p:spPr>
-          <a:xfrm>
-            <a:off x="0" y="0"/>
-            <a:ext cx="9144000" cy="41100"/>
-          </a:xfrm>
-          <a:prstGeom prst="rect">
-            <a:avLst/>
-          </a:prstGeom>
-          <a:solidFill>
-            <a:srgbClr val="B44030"/>
-          </a:solidFill>
-          <a:ln>
-            <a:noFill/>
-          </a:ln>
-        </p:spPr>
-        <p:style>
-          <a:lnRef idx="1">
-            <a:schemeClr val="accent1"/>
-          </a:lnRef>
-          <a:fillRef idx="3">
-            <a:schemeClr val="accent1"/>
-          </a:fillRef>
-          <a:effectRef idx="2">
-            <a:schemeClr val="accent1"/>
-          </a:effectRef>
-          <a:fontRef idx="minor">
-            <a:schemeClr val="lt1"/>
-          </a:fontRef>
-        </p:style>
-        <p:txBody>
-          <a:bodyPr rtlCol="0" anchor="ctr"/>
-          <a:lstStyle/>
-          <a:p>
-            <a:pPr algn="ctr"/>
-          </a:p>
-        </p:txBody>
-      </p:sp>
-      <p:sp>
-        <p:nvSpPr>
-          <p:cNvPr id="5" name="TextBox 4"/>
-          <p:cNvSpPr txBox="1"/>
-          <p:nvPr/>
-        </p:nvSpPr>
-        <p:spPr>
-          <a:xfrm>
-            <a:off x="320040" y="201168"/>
-            <a:ext cx="6400800" cy="502920"/>
-          </a:xfrm>
-          <a:prstGeom prst="rect">
-            <a:avLst/>
-          </a:prstGeom>
-          <a:noFill/>
-        </p:spPr>
-        <p:txBody>
-          <a:bodyPr wrap="square">
-            <a:spAutoFit/>
-          </a:bodyPr>
-          <a:lstStyle/>
-          <a:p>
-            <a:pPr algn="l"/>
-            <a:r>
-              <a:rPr sz="2200" b="1" i="0">
-                <a:solidFill>
-                  <a:srgbClr val="0D2B3D"/>
-                </a:solidFill>
-                <a:latin typeface="Georgia"/>
-              </a:rPr>
-              <a:t>Fakeeh Care Group — At a Glance</a:t>
-            </a:r>
-          </a:p>
-        </p:txBody>
-      </p:sp>
-      <p:sp>
-        <p:nvSpPr>
-          <p:cNvPr id="6" name="TextBox 5"/>
-          <p:cNvSpPr txBox="1"/>
-          <p:nvPr/>
-        </p:nvSpPr>
-        <p:spPr>
-          <a:xfrm>
-            <a:off x="320040" y="749808"/>
-            <a:ext cx="8046720" cy="347472"/>
-          </a:xfrm>
-          <a:prstGeom prst="rect">
-            <a:avLst/>
-          </a:prstGeom>
-          <a:noFill/>
-        </p:spPr>
-        <p:txBody>
-          <a:bodyPr wrap="square">
-            <a:spAutoFit/>
-          </a:bodyPr>
-          <a:lstStyle/>
-          <a:p>
-            <a:pPr algn="l"/>
-            <a:r>
-              <a:rPr sz="1100" b="0" i="1">
-                <a:solidFill>
-                  <a:srgbClr val="5A6A78"/>
-                </a:solidFill>
-                <a:latin typeface="Calibri"/>
-              </a:rPr>
-              <a:t>Dubai's leading private healthcare network — delivering world-class care since 1978.</a:t>
-            </a:r>
-          </a:p>
-        </p:txBody>
-      </p:sp>
-      <p:sp>
-        <p:nvSpPr>
-          <p:cNvPr id="7" name="Rectangle 6"/>
-          <p:cNvSpPr/>
-          <p:nvPr/>
-        </p:nvSpPr>
-        <p:spPr>
-          <a:xfrm>
-            <a:off x="320040" y="1152144"/>
-            <a:ext cx="8503920" cy="13800"/>
-          </a:xfrm>
-          <a:prstGeom prst="rect">
-            <a:avLst/>
-          </a:prstGeom>
-          <a:solidFill>
-            <a:srgbClr val="CCC5BB"/>
-          </a:solidFill>
-          <a:ln>
-            <a:noFill/>
-          </a:ln>
-        </p:spPr>
-        <p:style>
-          <a:lnRef idx="1">
-            <a:schemeClr val="accent1"/>
-          </a:lnRef>
-          <a:fillRef idx="3">
-            <a:schemeClr val="accent1"/>
-          </a:fillRef>
-          <a:effectRef idx="2">
-            <a:schemeClr val="accent1"/>
-          </a:effectRef>
-          <a:fontRef idx="minor">
-            <a:schemeClr val="lt1"/>
-          </a:fontRef>
-        </p:style>
-        <p:txBody>
-          <a:bodyPr rtlCol="0" anchor="ctr"/>
-          <a:lstStyle/>
-          <a:p>
-            <a:pPr algn="ctr"/>
-          </a:p>
-        </p:txBody>
-      </p:sp>
-      <p:sp>
-        <p:nvSpPr>
-          <p:cNvPr id="8" name="Rectangle 7"/>
-          <p:cNvSpPr/>
-          <p:nvPr/>
-        </p:nvSpPr>
-        <p:spPr>
-          <a:xfrm>
-            <a:off x="320040" y="1261872"/>
-            <a:ext cx="1993392" cy="1078992"/>
-          </a:xfrm>
-          <a:prstGeom prst="rect">
-            <a:avLst/>
-          </a:prstGeom>
-          <a:solidFill>
-            <a:srgbClr val="FFFFFF"/>
-          </a:solidFill>
-          <a:ln w="9525">
-            <a:solidFill>
-              <a:srgbClr val="DDD5C8"/>
-            </a:solidFill>
-          </a:ln>
-        </p:spPr>
-        <p:style>
-          <a:lnRef idx="1">
-            <a:schemeClr val="accent1"/>
-          </a:lnRef>
-          <a:fillRef idx="3">
-            <a:schemeClr val="accent1"/>
-          </a:fillRef>
-          <a:effectRef idx="2">
-            <a:schemeClr val="accent1"/>
-          </a:effectRef>
-          <a:fontRef idx="minor">
-            <a:schemeClr val="lt1"/>
-          </a:fontRef>
-        </p:style>
-        <p:txBody>
-          <a:bodyPr rtlCol="0" anchor="ctr"/>
-          <a:lstStyle/>
-          <a:p>
-            <a:pPr algn="ctr"/>
-          </a:p>
-        </p:txBody>
-      </p:sp>
-      <p:sp>
-        <p:nvSpPr>
-          <p:cNvPr id="9" name="Rectangle 8"/>
-          <p:cNvSpPr/>
-          <p:nvPr/>
-        </p:nvSpPr>
-        <p:spPr>
-          <a:xfrm>
-            <a:off x="320040" y="1261872"/>
-            <a:ext cx="1993392" cy="18000"/>
-          </a:xfrm>
-          <a:prstGeom prst="rect">
-            <a:avLst/>
-          </a:prstGeom>
-          <a:solidFill>
-            <a:srgbClr val="B44030"/>
-          </a:solidFill>
-          <a:ln>
-            <a:noFill/>
-          </a:ln>
-        </p:spPr>
-        <p:style>
-          <a:lnRef idx="1">
-            <a:schemeClr val="accent1"/>
-          </a:lnRef>
-          <a:fillRef idx="3">
-            <a:schemeClr val="accent1"/>
-          </a:fillRef>
-          <a:effectRef idx="2">
-            <a:schemeClr val="accent1"/>
-          </a:effectRef>
-          <a:fontRef idx="minor">
-            <a:schemeClr val="lt1"/>
-          </a:fontRef>
-        </p:style>
-        <p:txBody>
-          <a:bodyPr rtlCol="0" anchor="ctr"/>
-          <a:lstStyle/>
-          <a:p>
-            <a:pPr algn="ctr"/>
-          </a:p>
-        </p:txBody>
-      </p:sp>
-      <p:sp>
-        <p:nvSpPr>
-          <p:cNvPr id="10" name="TextBox 9"/>
-          <p:cNvSpPr txBox="1"/>
-          <p:nvPr/>
-        </p:nvSpPr>
-        <p:spPr>
-          <a:xfrm>
-            <a:off x="429768" y="1353312"/>
-            <a:ext cx="1773936" cy="457200"/>
-          </a:xfrm>
-          <a:prstGeom prst="rect">
-            <a:avLst/>
-          </a:prstGeom>
-          <a:noFill/>
-        </p:spPr>
-        <p:txBody>
-          <a:bodyPr wrap="square">
-            <a:spAutoFit/>
-          </a:bodyPr>
-          <a:lstStyle/>
-          <a:p>
-            <a:pPr algn="l"/>
-            <a:r>
-              <a:rPr sz="2000" b="1" i="0">
-                <a:solidFill>
-                  <a:srgbClr val="0D2B3D"/>
-                </a:solidFill>
-                <a:latin typeface="Georgia"/>
-              </a:rPr>
-              <a:t>1.89M+</a:t>
-            </a:r>
-          </a:p>
-        </p:txBody>
-      </p:sp>
-      <p:sp>
-        <p:nvSpPr>
-          <p:cNvPr id="11" name="TextBox 10"/>
-          <p:cNvSpPr txBox="1"/>
-          <p:nvPr/>
-        </p:nvSpPr>
-        <p:spPr>
-          <a:xfrm>
-            <a:off x="429768" y="1828800"/>
-            <a:ext cx="1773936" cy="420624"/>
-          </a:xfrm>
-          <a:prstGeom prst="rect">
-            <a:avLst/>
-          </a:prstGeom>
-          <a:noFill/>
-        </p:spPr>
-        <p:txBody>
-          <a:bodyPr wrap="square">
-            <a:spAutoFit/>
-          </a:bodyPr>
-          <a:lstStyle/>
-          <a:p>
-            <a:pPr algn="l"/>
-            <a:r>
-              <a:rPr sz="900" b="0" i="0">
-                <a:solidFill>
-                  <a:srgbClr val="5A6A78"/>
-                </a:solidFill>
-                <a:latin typeface="Calibri"/>
-              </a:rPr>
-              <a:t>Patients/year</a:t>
-            </a:r>
-          </a:p>
-        </p:txBody>
-      </p:sp>
-      <p:sp>
-        <p:nvSpPr>
-          <p:cNvPr id="12" name="Rectangle 11"/>
-          <p:cNvSpPr/>
-          <p:nvPr/>
-        </p:nvSpPr>
-        <p:spPr>
-          <a:xfrm>
-            <a:off x="2432304" y="1261872"/>
-            <a:ext cx="1993392" cy="1078992"/>
-          </a:xfrm>
-          <a:prstGeom prst="rect">
-            <a:avLst/>
-          </a:prstGeom>
-          <a:solidFill>
-            <a:srgbClr val="FFFFFF"/>
-          </a:solidFill>
-          <a:ln w="9525">
-            <a:solidFill>
-              <a:srgbClr val="DDD5C8"/>
-            </a:solidFill>
-          </a:ln>
-        </p:spPr>
-        <p:style>
-          <a:lnRef idx="1">
-            <a:schemeClr val="accent1"/>
-          </a:lnRef>
-          <a:fillRef idx="3">
-            <a:schemeClr val="accent1"/>
-          </a:fillRef>
-          <a:effectRef idx="2">
-            <a:schemeClr val="accent1"/>
-          </a:effectRef>
-          <a:fontRef idx="minor">
-            <a:schemeClr val="lt1"/>
-          </a:fontRef>
-        </p:style>
-        <p:txBody>
-          <a:bodyPr rtlCol="0" anchor="ctr"/>
-          <a:lstStyle/>
-          <a:p>
-            <a:pPr algn="ctr"/>
-          </a:p>
-        </p:txBody>
-      </p:sp>
-      <p:sp>
-        <p:nvSpPr>
-          <p:cNvPr id="13" name="Rectangle 12"/>
-          <p:cNvSpPr/>
-          <p:nvPr/>
-        </p:nvSpPr>
-        <p:spPr>
-          <a:xfrm>
-            <a:off x="2432304" y="1261872"/>
-            <a:ext cx="1993392" cy="18000"/>
-          </a:xfrm>
-          <a:prstGeom prst="rect">
-            <a:avLst/>
-          </a:prstGeom>
-          <a:solidFill>
-            <a:srgbClr val="B44030"/>
-          </a:solidFill>
-          <a:ln>
-            <a:noFill/>
-          </a:ln>
-        </p:spPr>
-        <p:style>
-          <a:lnRef idx="1">
-            <a:schemeClr val="accent1"/>
-          </a:lnRef>
-          <a:fillRef idx="3">
-            <a:schemeClr val="accent1"/>
-          </a:fillRef>
-          <a:effectRef idx="2">
-            <a:schemeClr val="accent1"/>
-          </a:effectRef>
-          <a:fontRef idx="minor">
-            <a:schemeClr val="lt1"/>
-          </a:fontRef>
-        </p:style>
-        <p:txBody>
-          <a:bodyPr rtlCol="0" anchor="ctr"/>
-          <a:lstStyle/>
-          <a:p>
-            <a:pPr algn="ctr"/>
-          </a:p>
-        </p:txBody>
-      </p:sp>
-      <p:sp>
-        <p:nvSpPr>
-          <p:cNvPr id="14" name="TextBox 13"/>
-          <p:cNvSpPr txBox="1"/>
-          <p:nvPr/>
-        </p:nvSpPr>
-        <p:spPr>
-          <a:xfrm>
-            <a:off x="2542032" y="1353312"/>
-            <a:ext cx="1773936" cy="457200"/>
-          </a:xfrm>
-          <a:prstGeom prst="rect">
-            <a:avLst/>
-          </a:prstGeom>
-          <a:noFill/>
-        </p:spPr>
-        <p:txBody>
-          <a:bodyPr wrap="square">
-            <a:spAutoFit/>
-          </a:bodyPr>
-          <a:lstStyle/>
-          <a:p>
-            <a:pPr algn="l"/>
-            <a:r>
-              <a:rPr sz="2000" b="1" i="0">
-                <a:solidFill>
-                  <a:srgbClr val="0D2B3D"/>
-                </a:solidFill>
-                <a:latin typeface="Georgia"/>
-              </a:rPr>
-              <a:t>4,500+</a:t>
-            </a:r>
-          </a:p>
-        </p:txBody>
-      </p:sp>
-      <p:sp>
-        <p:nvSpPr>
-          <p:cNvPr id="15" name="TextBox 14"/>
-          <p:cNvSpPr txBox="1"/>
-          <p:nvPr/>
-        </p:nvSpPr>
-        <p:spPr>
-          <a:xfrm>
-            <a:off x="2542032" y="1828800"/>
-            <a:ext cx="1773936" cy="420624"/>
-          </a:xfrm>
-          <a:prstGeom prst="rect">
-            <a:avLst/>
-          </a:prstGeom>
-          <a:noFill/>
-        </p:spPr>
-        <p:txBody>
-          <a:bodyPr wrap="square">
-            <a:spAutoFit/>
-          </a:bodyPr>
-          <a:lstStyle/>
-          <a:p>
-            <a:pPr algn="l"/>
-            <a:r>
-              <a:rPr sz="900" b="0" i="0">
-                <a:solidFill>
-                  <a:srgbClr val="5A6A78"/>
-                </a:solidFill>
-                <a:latin typeface="Calibri"/>
-              </a:rPr>
-              <a:t>Beds &amp; growing</a:t>
-            </a:r>
-          </a:p>
-        </p:txBody>
-      </p:sp>
-      <p:sp>
-        <p:nvSpPr>
-          <p:cNvPr id="16" name="Rectangle 15"/>
-          <p:cNvSpPr/>
-          <p:nvPr/>
-        </p:nvSpPr>
-        <p:spPr>
-          <a:xfrm>
-            <a:off x="4544568" y="1261872"/>
-            <a:ext cx="1993392" cy="1078992"/>
-          </a:xfrm>
-          <a:prstGeom prst="rect">
-            <a:avLst/>
-          </a:prstGeom>
-          <a:solidFill>
-            <a:srgbClr val="FFFFFF"/>
-          </a:solidFill>
-          <a:ln w="9525">
-            <a:solidFill>
-              <a:srgbClr val="DDD5C8"/>
-            </a:solidFill>
-          </a:ln>
-        </p:spPr>
-        <p:style>
-          <a:lnRef idx="1">
-            <a:schemeClr val="accent1"/>
-          </a:lnRef>
-          <a:fillRef idx="3">
-            <a:schemeClr val="accent1"/>
-          </a:fillRef>
-          <a:effectRef idx="2">
-            <a:schemeClr val="accent1"/>
-          </a:effectRef>
-          <a:fontRef idx="minor">
-            <a:schemeClr val="lt1"/>
-          </a:fontRef>
-        </p:style>
-        <p:txBody>
-          <a:bodyPr rtlCol="0" anchor="ctr"/>
-          <a:lstStyle/>
-          <a:p>
-            <a:pPr algn="ctr"/>
-          </a:p>
-        </p:txBody>
-      </p:sp>
-      <p:sp>
-        <p:nvSpPr>
-          <p:cNvPr id="17" name="Rectangle 16"/>
-          <p:cNvSpPr/>
-          <p:nvPr/>
-        </p:nvSpPr>
-        <p:spPr>
-          <a:xfrm>
-            <a:off x="4544568" y="1261872"/>
-            <a:ext cx="1993392" cy="18000"/>
-          </a:xfrm>
-          <a:prstGeom prst="rect">
-            <a:avLst/>
-          </a:prstGeom>
-          <a:solidFill>
-            <a:srgbClr val="B44030"/>
-          </a:solidFill>
-          <a:ln>
-            <a:noFill/>
-          </a:ln>
-        </p:spPr>
-        <p:style>
-          <a:lnRef idx="1">
-            <a:schemeClr val="accent1"/>
-          </a:lnRef>
-          <a:fillRef idx="3">
-            <a:schemeClr val="accent1"/>
-          </a:fillRef>
-          <a:effectRef idx="2">
-            <a:schemeClr val="accent1"/>
-          </a:effectRef>
-          <a:fontRef idx="minor">
-            <a:schemeClr val="lt1"/>
-          </a:fontRef>
-        </p:style>
-        <p:txBody>
-          <a:bodyPr rtlCol="0" anchor="ctr"/>
-          <a:lstStyle/>
-          <a:p>
-            <a:pPr algn="ctr"/>
-          </a:p>
-        </p:txBody>
-      </p:sp>
-      <p:sp>
-        <p:nvSpPr>
-          <p:cNvPr id="18" name="TextBox 17"/>
-          <p:cNvSpPr txBox="1"/>
-          <p:nvPr/>
-        </p:nvSpPr>
-        <p:spPr>
-          <a:xfrm>
-            <a:off x="4654296" y="1353312"/>
-            <a:ext cx="1773936" cy="457200"/>
-          </a:xfrm>
-          <a:prstGeom prst="rect">
-            <a:avLst/>
-          </a:prstGeom>
-          <a:noFill/>
-        </p:spPr>
-        <p:txBody>
-          <a:bodyPr wrap="square">
-            <a:spAutoFit/>
-          </a:bodyPr>
-          <a:lstStyle/>
-          <a:p>
-            <a:pPr algn="l"/>
-            <a:r>
-              <a:rPr sz="2000" b="1" i="0">
-                <a:solidFill>
-                  <a:srgbClr val="0D2B3D"/>
-                </a:solidFill>
-                <a:latin typeface="Georgia"/>
-              </a:rPr>
-              <a:t>900+</a:t>
-            </a:r>
-          </a:p>
-        </p:txBody>
-      </p:sp>
-      <p:sp>
-        <p:nvSpPr>
-          <p:cNvPr id="19" name="TextBox 18"/>
-          <p:cNvSpPr txBox="1"/>
-          <p:nvPr/>
-        </p:nvSpPr>
-        <p:spPr>
-          <a:xfrm>
-            <a:off x="4654296" y="1828800"/>
-            <a:ext cx="1773936" cy="420624"/>
-          </a:xfrm>
-          <a:prstGeom prst="rect">
-            <a:avLst/>
-          </a:prstGeom>
-          <a:noFill/>
-        </p:spPr>
-        <p:txBody>
-          <a:bodyPr wrap="square">
-            <a:spAutoFit/>
-          </a:bodyPr>
-          <a:lstStyle/>
-          <a:p>
-            <a:pPr algn="l"/>
-            <a:r>
-              <a:rPr sz="900" b="0" i="0">
-                <a:solidFill>
-                  <a:srgbClr val="5A6A78"/>
-                </a:solidFill>
-                <a:latin typeface="Calibri"/>
-              </a:rPr>
-              <a:t>Doctors, 50+ specialties</a:t>
-            </a:r>
-          </a:p>
-        </p:txBody>
-      </p:sp>
-      <p:sp>
-        <p:nvSpPr>
-          <p:cNvPr id="20" name="Rectangle 19"/>
-          <p:cNvSpPr/>
-          <p:nvPr/>
-        </p:nvSpPr>
-        <p:spPr>
-          <a:xfrm>
-            <a:off x="6656832" y="1261872"/>
-            <a:ext cx="1993392" cy="1078992"/>
-          </a:xfrm>
-          <a:prstGeom prst="rect">
-            <a:avLst/>
-          </a:prstGeom>
-          <a:solidFill>
-            <a:srgbClr val="FFFFFF"/>
-          </a:solidFill>
-          <a:ln w="9525">
-            <a:solidFill>
-              <a:srgbClr val="DDD5C8"/>
-            </a:solidFill>
-          </a:ln>
-        </p:spPr>
-        <p:style>
-          <a:lnRef idx="1">
-            <a:schemeClr val="accent1"/>
-          </a:lnRef>
-          <a:fillRef idx="3">
-            <a:schemeClr val="accent1"/>
-          </a:fillRef>
-          <a:effectRef idx="2">
-            <a:schemeClr val="accent1"/>
-          </a:effectRef>
-          <a:fontRef idx="minor">
-            <a:schemeClr val="lt1"/>
-          </a:fontRef>
-        </p:style>
-        <p:txBody>
-          <a:bodyPr rtlCol="0" anchor="ctr"/>
-          <a:lstStyle/>
-          <a:p>
-            <a:pPr algn="ctr"/>
-          </a:p>
-        </p:txBody>
-      </p:sp>
-      <p:sp>
-        <p:nvSpPr>
-          <p:cNvPr id="21" name="Rectangle 20"/>
-          <p:cNvSpPr/>
-          <p:nvPr/>
-        </p:nvSpPr>
-        <p:spPr>
-          <a:xfrm>
-            <a:off x="6656832" y="1261872"/>
-            <a:ext cx="1993392" cy="18000"/>
-          </a:xfrm>
-          <a:prstGeom prst="rect">
-            <a:avLst/>
-          </a:prstGeom>
-          <a:solidFill>
-            <a:srgbClr val="B44030"/>
-          </a:solidFill>
-          <a:ln>
-            <a:noFill/>
-          </a:ln>
-        </p:spPr>
-        <p:style>
-          <a:lnRef idx="1">
-            <a:schemeClr val="accent1"/>
-          </a:lnRef>
-          <a:fillRef idx="3">
-            <a:schemeClr val="accent1"/>
-          </a:fillRef>
-          <a:effectRef idx="2">
-            <a:schemeClr val="accent1"/>
-          </a:effectRef>
-          <a:fontRef idx="minor">
-            <a:schemeClr val="lt1"/>
-          </a:fontRef>
-        </p:style>
-        <p:txBody>
-          <a:bodyPr rtlCol="0" anchor="ctr"/>
-          <a:lstStyle/>
-          <a:p>
-            <a:pPr algn="ctr"/>
-          </a:p>
-        </p:txBody>
-      </p:sp>
-      <p:sp>
-        <p:nvSpPr>
-          <p:cNvPr id="22" name="TextBox 21"/>
-          <p:cNvSpPr txBox="1"/>
-          <p:nvPr/>
-        </p:nvSpPr>
-        <p:spPr>
-          <a:xfrm>
-            <a:off x="6766560" y="1353312"/>
-            <a:ext cx="1773936" cy="457200"/>
-          </a:xfrm>
-          <a:prstGeom prst="rect">
-            <a:avLst/>
-          </a:prstGeom>
-          <a:noFill/>
-        </p:spPr>
-        <p:txBody>
-          <a:bodyPr wrap="square">
-            <a:spAutoFit/>
-          </a:bodyPr>
-          <a:lstStyle/>
-          <a:p>
-            <a:pPr algn="l"/>
-            <a:r>
-              <a:rPr sz="2000" b="1" i="0">
-                <a:solidFill>
-                  <a:srgbClr val="0D2B3D"/>
-                </a:solidFill>
-                <a:latin typeface="Georgia"/>
-              </a:rPr>
-              <a:t>31+</a:t>
-            </a:r>
-          </a:p>
-        </p:txBody>
-      </p:sp>
-      <p:sp>
-        <p:nvSpPr>
-          <p:cNvPr id="23" name="TextBox 22"/>
-          <p:cNvSpPr txBox="1"/>
-          <p:nvPr/>
-        </p:nvSpPr>
-        <p:spPr>
-          <a:xfrm>
-            <a:off x="6766560" y="1828800"/>
-            <a:ext cx="1773936" cy="420624"/>
-          </a:xfrm>
-          <a:prstGeom prst="rect">
-            <a:avLst/>
-          </a:prstGeom>
-          <a:noFill/>
-        </p:spPr>
-        <p:txBody>
-          <a:bodyPr wrap="square">
-            <a:spAutoFit/>
-          </a:bodyPr>
-          <a:lstStyle/>
-          <a:p>
-            <a:pPr algn="l"/>
-            <a:r>
-              <a:rPr sz="900" b="0" i="0">
-                <a:solidFill>
-                  <a:srgbClr val="5A6A78"/>
-                </a:solidFill>
-                <a:latin typeface="Calibri"/>
-              </a:rPr>
-              <a:t>Facilities across UAE &amp; GCC</a:t>
-            </a:r>
-          </a:p>
-        </p:txBody>
-      </p:sp>
-      <p:sp>
-        <p:nvSpPr>
-          <p:cNvPr id="24" name="Rectangle 23"/>
-          <p:cNvSpPr/>
-          <p:nvPr/>
-        </p:nvSpPr>
-        <p:spPr>
-          <a:xfrm>
-            <a:off x="320040" y="2487168"/>
-            <a:ext cx="4160520" cy="2176272"/>
-          </a:xfrm>
-          <a:prstGeom prst="rect">
-            <a:avLst/>
-          </a:prstGeom>
-          <a:solidFill>
-            <a:srgbClr val="FFFFFF"/>
-          </a:solidFill>
-          <a:ln w="9525">
-            <a:solidFill>
-              <a:srgbClr val="DDD5C8"/>
-            </a:solidFill>
-          </a:ln>
-        </p:spPr>
-        <p:style>
-          <a:lnRef idx="1">
-            <a:schemeClr val="accent1"/>
-          </a:lnRef>
-          <a:fillRef idx="3">
-            <a:schemeClr val="accent1"/>
-          </a:fillRef>
-          <a:effectRef idx="2">
-            <a:schemeClr val="accent1"/>
-          </a:effectRef>
-          <a:fontRef idx="minor">
-            <a:schemeClr val="lt1"/>
-          </a:fontRef>
-        </p:style>
-        <p:txBody>
-          <a:bodyPr rtlCol="0" anchor="ctr"/>
-          <a:lstStyle/>
-          <a:p>
-            <a:pPr algn="ctr"/>
-          </a:p>
-        </p:txBody>
-      </p:sp>
-      <p:sp>
-        <p:nvSpPr>
-          <p:cNvPr id="25" name="Rectangle 24"/>
-          <p:cNvSpPr/>
-          <p:nvPr/>
-        </p:nvSpPr>
-        <p:spPr>
-          <a:xfrm>
-            <a:off x="320040" y="2487168"/>
-            <a:ext cx="4160520" cy="18000"/>
-          </a:xfrm>
-          <a:prstGeom prst="rect">
-            <a:avLst/>
-          </a:prstGeom>
-          <a:solidFill>
-            <a:srgbClr val="B44030"/>
-          </a:solidFill>
-          <a:ln>
-            <a:noFill/>
-          </a:ln>
-        </p:spPr>
-        <p:style>
-          <a:lnRef idx="1">
-            <a:schemeClr val="accent1"/>
-          </a:lnRef>
-          <a:fillRef idx="3">
-            <a:schemeClr val="accent1"/>
-          </a:fillRef>
-          <a:effectRef idx="2">
-            <a:schemeClr val="accent1"/>
-          </a:effectRef>
-          <a:fontRef idx="minor">
-            <a:schemeClr val="lt1"/>
-          </a:fontRef>
-        </p:style>
-        <p:txBody>
-          <a:bodyPr rtlCol="0" anchor="ctr"/>
-          <a:lstStyle/>
-          <a:p>
-            <a:pPr algn="ctr"/>
-          </a:p>
-        </p:txBody>
-      </p:sp>
-      <p:sp>
-        <p:nvSpPr>
-          <p:cNvPr id="26" name="TextBox 25"/>
-          <p:cNvSpPr txBox="1"/>
-          <p:nvPr/>
-        </p:nvSpPr>
-        <p:spPr>
-          <a:xfrm>
-            <a:off x="457200" y="2560320"/>
-            <a:ext cx="3886200" cy="292608"/>
-          </a:xfrm>
-          <a:prstGeom prst="rect">
-            <a:avLst/>
-          </a:prstGeom>
-          <a:noFill/>
-        </p:spPr>
-        <p:txBody>
-          <a:bodyPr wrap="square">
-            <a:spAutoFit/>
-          </a:bodyPr>
-          <a:lstStyle/>
-          <a:p>
-            <a:pPr algn="l"/>
-            <a:r>
-              <a:rPr sz="1000" b="1" i="0">
-                <a:solidFill>
-                  <a:srgbClr val="0D2B3D"/>
-                </a:solidFill>
-                <a:latin typeface="Georgia"/>
-              </a:rPr>
-              <a:t>What They Do</a:t>
-            </a:r>
-          </a:p>
-        </p:txBody>
-      </p:sp>
-      <p:sp>
-        <p:nvSpPr>
-          <p:cNvPr id="27" name="Rectangle 26"/>
-          <p:cNvSpPr/>
-          <p:nvPr/>
-        </p:nvSpPr>
-        <p:spPr>
-          <a:xfrm>
-            <a:off x="457200" y="2889504"/>
-            <a:ext cx="3886200" cy="9200"/>
-          </a:xfrm>
-          <a:prstGeom prst="rect">
-            <a:avLst/>
-          </a:prstGeom>
-          <a:solidFill>
-            <a:srgbClr val="DDD5C8"/>
-          </a:solidFill>
-          <a:ln>
-            <a:noFill/>
-          </a:ln>
-        </p:spPr>
-        <p:style>
-          <a:lnRef idx="1">
-            <a:schemeClr val="accent1"/>
-          </a:lnRef>
-          <a:fillRef idx="3">
-            <a:schemeClr val="accent1"/>
-          </a:fillRef>
-          <a:effectRef idx="2">
-            <a:schemeClr val="accent1"/>
-          </a:effectRef>
-          <a:fontRef idx="minor">
-            <a:schemeClr val="lt1"/>
-          </a:fontRef>
-        </p:style>
-        <p:txBody>
-          <a:bodyPr rtlCol="0" anchor="ctr"/>
-          <a:lstStyle/>
-          <a:p>
-            <a:pPr algn="ctr"/>
-          </a:p>
-        </p:txBody>
-      </p:sp>
-      <p:sp>
-        <p:nvSpPr>
-          <p:cNvPr id="28" name="TextBox 27"/>
-          <p:cNvSpPr txBox="1"/>
-          <p:nvPr/>
-        </p:nvSpPr>
-        <p:spPr>
-          <a:xfrm>
-            <a:off x="457200" y="2962656"/>
-            <a:ext cx="3886200" cy="1572768"/>
-          </a:xfrm>
-          <a:prstGeom prst="rect">
-            <a:avLst/>
-          </a:prstGeom>
-          <a:noFill/>
-        </p:spPr>
-        <p:txBody>
-          <a:bodyPr wrap="square">
-            <a:spAutoFit/>
-          </a:bodyPr>
-          <a:lstStyle/>
-          <a:p>
-            <a:pPr algn="l">
-              <a:spcBef>
-                <a:spcPts val="300"/>
-              </a:spcBef>
-            </a:pPr>
-            <a:r>
-              <a:rPr sz="850">
-                <a:solidFill>
-                  <a:srgbClr val="5A6A78"/>
-                </a:solidFill>
-                <a:latin typeface="Calibri"/>
-              </a:rPr>
-              <a:t>• Multi-specialty tertiary &amp; quaternary care across medicine, surgery, oncology, neuroscience, and women's health</a:t>
-            </a:r>
-          </a:p>
-          <a:p>
-            <a:pPr algn="l">
-              <a:spcBef>
-                <a:spcPts val="300"/>
-              </a:spcBef>
-            </a:pPr>
-            <a:r>
-              <a:rPr sz="850">
-                <a:solidFill>
-                  <a:srgbClr val="5A6A78"/>
-                </a:solidFill>
-                <a:latin typeface="Calibri"/>
-              </a:rPr>
-              <a:t>• Primary care network — 22 Medicentres clinics across Dubai and the Northern Emirates</a:t>
-            </a:r>
-          </a:p>
-          <a:p>
-            <a:pPr algn="l">
-              <a:spcBef>
-                <a:spcPts val="300"/>
-              </a:spcBef>
-            </a:pPr>
-            <a:r>
-              <a:rPr sz="850">
-                <a:solidFill>
-                  <a:srgbClr val="5A6A78"/>
-                </a:solidFill>
-                <a:latin typeface="Calibri"/>
-              </a:rPr>
-              <a:t>• Advanced diagnostics: CAP-accredited labs, imaging, and robotic surgery programs</a:t>
-            </a:r>
-          </a:p>
-          <a:p>
-            <a:pPr algn="l">
-              <a:spcBef>
-                <a:spcPts val="300"/>
-              </a:spcBef>
-            </a:pPr>
-            <a:r>
-              <a:rPr sz="850">
-                <a:solidFill>
-                  <a:srgbClr val="5A6A78"/>
-                </a:solidFill>
-                <a:latin typeface="Calibri"/>
-              </a:rPr>
-              <a:t>• Academic &amp; research hospital: Fakeeh University Hospital (Dubai Silicon Oasis) — DHA accredited</a:t>
-            </a:r>
-          </a:p>
-          <a:p>
-            <a:pPr algn="l">
-              <a:spcBef>
-                <a:spcPts val="300"/>
-              </a:spcBef>
-            </a:pPr>
-            <a:r>
-              <a:rPr sz="850">
-                <a:solidFill>
-                  <a:srgbClr val="5A6A78"/>
-                </a:solidFill>
-                <a:latin typeface="Calibri"/>
-              </a:rPr>
-              <a:t>• Telehealth &amp; digital health programs serving remote and expatriate populations</a:t>
-            </a:r>
-          </a:p>
-        </p:txBody>
-      </p:sp>
-      <p:sp>
-        <p:nvSpPr>
-          <p:cNvPr id="29" name="Rectangle 28"/>
-          <p:cNvSpPr/>
-          <p:nvPr/>
-        </p:nvSpPr>
-        <p:spPr>
-          <a:xfrm>
-            <a:off x="4599432" y="2487168"/>
-            <a:ext cx="4160520" cy="2176272"/>
-          </a:xfrm>
-          <a:prstGeom prst="rect">
-            <a:avLst/>
-          </a:prstGeom>
-          <a:solidFill>
-            <a:srgbClr val="FFFFFF"/>
-          </a:solidFill>
-          <a:ln w="9525">
-            <a:solidFill>
-              <a:srgbClr val="DDD5C8"/>
-            </a:solidFill>
-          </a:ln>
-        </p:spPr>
-        <p:style>
-          <a:lnRef idx="1">
-            <a:schemeClr val="accent1"/>
-          </a:lnRef>
-          <a:fillRef idx="3">
-            <a:schemeClr val="accent1"/>
-          </a:fillRef>
-          <a:effectRef idx="2">
-            <a:schemeClr val="accent1"/>
-          </a:effectRef>
-          <a:fontRef idx="minor">
-            <a:schemeClr val="lt1"/>
-          </a:fontRef>
-        </p:style>
-        <p:txBody>
-          <a:bodyPr rtlCol="0" anchor="ctr"/>
-          <a:lstStyle/>
-          <a:p>
-            <a:pPr algn="ctr"/>
-          </a:p>
-        </p:txBody>
-      </p:sp>
-      <p:sp>
-        <p:nvSpPr>
-          <p:cNvPr id="30" name="Rectangle 29"/>
-          <p:cNvSpPr/>
-          <p:nvPr/>
-        </p:nvSpPr>
-        <p:spPr>
-          <a:xfrm>
-            <a:off x="4599432" y="2487168"/>
-            <a:ext cx="4160520" cy="18000"/>
-          </a:xfrm>
-          <a:prstGeom prst="rect">
-            <a:avLst/>
-          </a:prstGeom>
-          <a:solidFill>
-            <a:srgbClr val="B44030"/>
-          </a:solidFill>
-          <a:ln>
-            <a:noFill/>
-          </a:ln>
-        </p:spPr>
-        <p:style>
-          <a:lnRef idx="1">
-            <a:schemeClr val="accent1"/>
-          </a:lnRef>
-          <a:fillRef idx="3">
-            <a:schemeClr val="accent1"/>
-          </a:fillRef>
-          <a:effectRef idx="2">
-            <a:schemeClr val="accent1"/>
-          </a:effectRef>
-          <a:fontRef idx="minor">
-            <a:schemeClr val="lt1"/>
-          </a:fontRef>
-        </p:style>
-        <p:txBody>
-          <a:bodyPr rtlCol="0" anchor="ctr"/>
-          <a:lstStyle/>
-          <a:p>
-            <a:pPr algn="ctr"/>
-          </a:p>
-        </p:txBody>
-      </p:sp>
-      <p:sp>
-        <p:nvSpPr>
-          <p:cNvPr id="31" name="TextBox 30"/>
-          <p:cNvSpPr txBox="1"/>
-          <p:nvPr/>
-        </p:nvSpPr>
-        <p:spPr>
-          <a:xfrm>
-            <a:off x="4736592" y="2560320"/>
-            <a:ext cx="3886200" cy="292608"/>
-          </a:xfrm>
-          <a:prstGeom prst="rect">
-            <a:avLst/>
-          </a:prstGeom>
-          <a:noFill/>
-        </p:spPr>
-        <p:txBody>
-          <a:bodyPr wrap="square">
-            <a:spAutoFit/>
-          </a:bodyPr>
-          <a:lstStyle/>
-          <a:p>
-            <a:pPr algn="l"/>
-            <a:r>
-              <a:rPr sz="1000" b="1" i="0">
-                <a:solidFill>
-                  <a:srgbClr val="0D2B3D"/>
-                </a:solidFill>
-                <a:latin typeface="Georgia"/>
-              </a:rPr>
-              <a:t>Scale &amp; Capacity</a:t>
-            </a:r>
-          </a:p>
-        </p:txBody>
-      </p:sp>
-      <p:sp>
-        <p:nvSpPr>
-          <p:cNvPr id="32" name="Rectangle 31"/>
-          <p:cNvSpPr/>
-          <p:nvPr/>
-        </p:nvSpPr>
-        <p:spPr>
-          <a:xfrm>
-            <a:off x="4736592" y="2889504"/>
-            <a:ext cx="3886200" cy="9200"/>
-          </a:xfrm>
-          <a:prstGeom prst="rect">
-            <a:avLst/>
-          </a:prstGeom>
-          <a:solidFill>
-            <a:srgbClr val="DDD5C8"/>
-          </a:solidFill>
-          <a:ln>
-            <a:noFill/>
-          </a:ln>
-        </p:spPr>
-        <p:style>
-          <a:lnRef idx="1">
-            <a:schemeClr val="accent1"/>
-          </a:lnRef>
-          <a:fillRef idx="3">
-            <a:schemeClr val="accent1"/>
-          </a:fillRef>
-          <a:effectRef idx="2">
-            <a:schemeClr val="accent1"/>
-          </a:effectRef>
-          <a:fontRef idx="minor">
-            <a:schemeClr val="lt1"/>
-          </a:fontRef>
-        </p:style>
-        <p:txBody>
-          <a:bodyPr rtlCol="0" anchor="ctr"/>
-          <a:lstStyle/>
-          <a:p>
-            <a:pPr algn="ctr"/>
-          </a:p>
-        </p:txBody>
-      </p:sp>
-      <p:sp>
-        <p:nvSpPr>
-          <p:cNvPr id="33" name="TextBox 32"/>
-          <p:cNvSpPr txBox="1"/>
-          <p:nvPr/>
-        </p:nvSpPr>
-        <p:spPr>
-          <a:xfrm>
-            <a:off x="4736592" y="2962656"/>
-            <a:ext cx="3886200" cy="1572768"/>
-          </a:xfrm>
-          <a:prstGeom prst="rect">
-            <a:avLst/>
-          </a:prstGeom>
-          <a:noFill/>
-        </p:spPr>
-        <p:txBody>
-          <a:bodyPr wrap="square">
-            <a:spAutoFit/>
-          </a:bodyPr>
-          <a:lstStyle/>
-          <a:p>
-            <a:pPr algn="l">
-              <a:spcBef>
-                <a:spcPts val="300"/>
-              </a:spcBef>
-            </a:pPr>
-            <a:r>
-              <a:rPr sz="850">
-                <a:solidFill>
-                  <a:srgbClr val="5A6A78"/>
-                </a:solidFill>
-                <a:latin typeface="Calibri"/>
-              </a:rPr>
-              <a:t>• Flagship: Fakeeh University Hospital, Dubai — 450+ beds, 24/7 emergency &amp; ICU</a:t>
-            </a:r>
-          </a:p>
-          <a:p>
-            <a:pPr algn="l">
-              <a:spcBef>
-                <a:spcPts val="300"/>
-              </a:spcBef>
-            </a:pPr>
-            <a:r>
-              <a:rPr sz="850">
-                <a:solidFill>
-                  <a:srgbClr val="5A6A78"/>
-                </a:solidFill>
-                <a:latin typeface="Calibri"/>
-              </a:rPr>
-              <a:t>• 4 hospitals today → 7 hospitals by 2028 (1,675 beds target)</a:t>
-            </a:r>
-          </a:p>
-          <a:p>
-            <a:pPr algn="l">
-              <a:spcBef>
-                <a:spcPts val="300"/>
-              </a:spcBef>
-            </a:pPr>
-            <a:r>
-              <a:rPr sz="850">
-                <a:solidFill>
-                  <a:srgbClr val="5A6A78"/>
-                </a:solidFill>
-                <a:latin typeface="Calibri"/>
-              </a:rPr>
-              <a:t>• AED 500M+ HEAL Neuroscience Centre under construction</a:t>
-            </a:r>
-          </a:p>
-          <a:p>
-            <a:pPr algn="l">
-              <a:spcBef>
-                <a:spcPts val="300"/>
-              </a:spcBef>
-            </a:pPr>
-            <a:r>
-              <a:rPr sz="850">
-                <a:solidFill>
-                  <a:srgbClr val="5A6A78"/>
-                </a:solidFill>
-                <a:latin typeface="Calibri"/>
-              </a:rPr>
-              <a:t>• JCI Accredited (6th consecutive time) · ANCC Magnet Nursing Recognition</a:t>
-            </a:r>
-          </a:p>
-          <a:p>
-            <a:pPr algn="l">
-              <a:spcBef>
-                <a:spcPts val="300"/>
-              </a:spcBef>
-            </a:pPr>
-            <a:r>
-              <a:rPr sz="850">
-                <a:solidFill>
-                  <a:srgbClr val="5A6A78"/>
-                </a:solidFill>
-                <a:latin typeface="Calibri"/>
-              </a:rPr>
-              <a:t>• Listed on Tadawul (4017/FAKEEHCA) since June 2024 — SAR 3.1B revenue FY2025</a:t>
-            </a:r>
-          </a:p>
-        </p:txBody>
-      </p:sp>
-      <p:sp>
-        <p:nvSpPr>
-          <p:cNvPr id="34" name="TextBox 33"/>
-          <p:cNvSpPr txBox="1"/>
-          <p:nvPr/>
-        </p:nvSpPr>
-        <p:spPr>
-          <a:xfrm>
-            <a:off x="320040" y="4727448"/>
-            <a:ext cx="8503920" cy="329184"/>
-          </a:xfrm>
-          <a:prstGeom prst="rect">
-            <a:avLst/>
-          </a:prstGeom>
-          <a:noFill/>
-        </p:spPr>
-        <p:txBody>
-          <a:bodyPr wrap="square">
-            <a:spAutoFit/>
-          </a:bodyPr>
-          <a:lstStyle/>
-          <a:p>
-            <a:pPr algn="l"/>
-            <a:r>
-              <a:rPr sz="850" b="0" i="1">
-                <a:solidFill>
-                  <a:srgbClr val="5A6A78"/>
-                </a:solidFill>
-                <a:latin typeface="Calibri"/>
-              </a:rPr>
-              <a:t>Fakeeh Care Group is expanding rapidly across Dubai and the GCC — with the patient volume, infrastructure, and ambition to make AI-powered care transformation both timely and impactful.</a:t>
-            </a:r>
-          </a:p>
-        </p:txBody>
-      </p:sp>
-      <p:pic>
-        <p:nvPicPr>
-          <p:cNvPr id="98" name="Google Shape;98;p13" title="download.jfif"/>
-          <p:cNvPicPr preferRelativeResize="0"/>
-          <p:nvPr/>
-        </p:nvPicPr>
-        <p:blipFill>
-          <a:blip r:embed="rId4">
-            <a:alphaModFix/>
-          </a:blip>
-          <a:stretch>
-            <a:fillRect/>
-          </a:stretch>
-        </p:blipFill>
-        <p:spPr>
-          <a:xfrm>
-            <a:off x="7941600" y="4628100"/>
-            <a:ext cx="966625" cy="241650"/>
-          </a:xfrm>
-          <a:prstGeom prst="rect">
-            <a:avLst/>
-          </a:prstGeom>
-          <a:noFill/>
-          <a:ln>
-            <a:noFill/>
-          </a:ln>
-        </p:spPr>
-      </p:pic>
-    </p:spTree>
-  </p:cSld>
-  <p:clrMapOvr>
-    <a:masterClrMapping/>
-  </p:clrMapOvr>
-</p:sld>
-</file>
-
 <file path=ppt/theme/theme1.xml><?xml version="1.0" encoding="utf-8"?>
 <a:theme xmlns:a="http://schemas.openxmlformats.org/drawingml/2006/main" xmlns:r="http://schemas.openxmlformats.org/officeDocument/2006/relationships">
   <a:themeElements>

</xml_diff>

<commit_message>
Personalize slide 5 as direct solution to slide 4 challenges
</commit_message>
<xml_diff>
--- a/Fakeeh_Care_Group_v2.pptx
+++ b/Fakeeh_Care_Group_v2.pptx
@@ -17971,7 +17971,7 @@
                 <a:cs typeface="Calibri"/>
                 <a:sym typeface="Calibri"/>
               </a:rPr>
-              <a:t>How Amigo transforms the patient care journey at Fakeeh</a:t>
+              <a:t>Amigo's answer to every Fakeeh challenge</a:t>
             </a:r>
             <a:endParaRPr b="0" sz="2100">
               <a:solidFill>
@@ -18003,7 +18003,7 @@
                 <a:cs typeface="Calibri"/>
                 <a:sym typeface="Calibri"/>
               </a:rPr>
-              <a:t>8 AI-powered touchpoints across the complete patient journey</a:t>
+              <a:t>Each AI agent is purpose-built to solve a specific operational or clinical pain point identified at Fakeeh.</a:t>
             </a:r>
             <a:endParaRPr i="1" sz="1000">
               <a:solidFill>
@@ -18221,7 +18221,7 @@
                     <a:cs typeface="Calibri"/>
                     <a:sym typeface="Calibri"/>
                   </a:rPr>
-                  <a:t>Proactive Patient Outreach</a:t>
+                  <a:t>Proactive Outreach</a:t>
                 </a:r>
                 <a:endParaRPr b="1" i="0" sz="1100">
                   <a:solidFill>
@@ -18253,7 +18253,7 @@
                     <a:cs typeface="Calibri"/>
                     <a:sym typeface="Calibri"/>
                   </a:rPr>
-                  <a:t>Reactivate dormant patients, fill schedule gaps, outbound appointment booking</a:t>
+                  <a:t>Solves: Lost Revenue &amp; Unfilled Schedules — AI reactivates dormant patients, fills gaps, and books appointments without front-desk involvement.</a:t>
                 </a:r>
                 <a:endParaRPr b="1" i="0" sz="950">
                   <a:solidFill>
@@ -18490,7 +18490,7 @@
                     <a:cs typeface="Calibri"/>
                     <a:sym typeface="Calibri"/>
                   </a:rPr>
-                  <a:t>Cut no-shows by 50% and free up front-desk staff across 120+ Fakeeh clinics</a:t>
+                  <a:t>Solves: Explosive Volume Growth — cuts no-shows by 50% and absorbs 1.89M+ annual patients without adding headcount.</a:t>
                 </a:r>
                 <a:endParaRPr b="1" i="0" sz="950">
                   <a:solidFill>
@@ -18727,7 +18727,7 @@
                     <a:cs typeface="Calibri"/>
                     <a:sym typeface="Calibri"/>
                   </a:rPr>
-                  <a:t>Eliminate wait times and route Fakeeh patients to the right specialty in seconds</a:t>
+                  <a:t>Solves: High Costs &amp; Inefficiency — eliminates 2 hrs of admin waste per patient hour; routes to the right specialty in seconds.</a:t>
                 </a:r>
                 <a:endParaRPr b="1" i="0" sz="950">
                   <a:solidFill>
@@ -18932,7 +18932,7 @@
                     <a:cs typeface="Calibri"/>
                     <a:sym typeface="Calibri"/>
                   </a:rPr>
-                  <a:t>Patient Education</a:t>
+                  <a:t>Multilingual Patient Education</a:t>
                 </a:r>
                 <a:endParaRPr b="1" i="0" sz="1100">
                   <a:solidFill>
@@ -18964,7 +18964,7 @@
                     <a:cs typeface="Calibri"/>
                     <a:sym typeface="Calibri"/>
                   </a:rPr>
-                  <a:t>Prep patients before arrival; cut visit times by 30% across all hospitals</a:t>
+                  <a:t>Solves: Multi-Language Population — delivers pre-visit prep in Arabic, English, Urdu, Tagalog, Hindi and 100+ languages.</a:t>
                 </a:r>
                 <a:endParaRPr b="1" i="0" sz="950">
                   <a:solidFill>
@@ -19216,7 +19216,7 @@
                     <a:cs typeface="Calibri"/>
                     <a:sym typeface="Calibri"/>
                   </a:rPr>
-                  <a:t>Deliver clinical decision support and elevate patient outcomes for 900+ Fakeeh doctors</a:t>
+                  <a:t>Solves: High Turnover &amp; Burnout — arms 900+ Fakeeh doctors with AI clinical decision support, cutting cognitive load and reducing 43% burnout rate.</a:t>
                 </a:r>
                 <a:endParaRPr b="1" i="0" sz="950">
                   <a:solidFill>
@@ -19421,7 +19421,7 @@
                     <a:cs typeface="Calibri"/>
                     <a:sym typeface="Calibri"/>
                   </a:rPr>
-                  <a:t>Post-Visit Follow-ups</a:t>
+                  <a:t>Post-Visit Follow-Up</a:t>
                 </a:r>
                 <a:endParaRPr b="1" i="0" sz="1100">
                   <a:solidFill>
@@ -19453,7 +19453,7 @@
                     <a:cs typeface="Calibri"/>
                     <a:sym typeface="Calibri"/>
                   </a:rPr>
-                  <a:t>Answer patient questions and free providers from callbacks — 1.89M patients annually</a:t>
+                  <a:t>Solves: Patient Drop-Off &amp; Referral Leakage — automated follow-ups capture the $15K LTV lost per drop-off and close referral loops.</a:t>
                 </a:r>
                 <a:endParaRPr b="1" i="0" sz="950">
                   <a:solidFill>
@@ -19658,7 +19658,7 @@
                     <a:cs typeface="Calibri"/>
                     <a:sym typeface="Calibri"/>
                   </a:rPr>
-                  <a:t>Ongoing 24/7 Virtual Care</a:t>
+                  <a:t>24/7 Chronic Disease Care</a:t>
                 </a:r>
                 <a:endParaRPr b="1" i="0" sz="1100">
                   <a:solidFill>
@@ -19690,7 +19690,7 @@
                     <a:cs typeface="Calibri"/>
                     <a:sym typeface="Calibri"/>
                   </a:rPr>
-                  <a:t>Engage Fakeeh patients beyond their visit to improve chronic disease adherence</a:t>
+                  <a:t>Solves: Chronic Disease Management — continuous engagement for high-volume chronic patients across 50+ specialties without consuming provider bandwidth.</a:t>
                 </a:r>
                 <a:endParaRPr b="1" i="0" sz="950">
                   <a:solidFill>
@@ -19889,7 +19889,7 @@
                     <a:cs typeface="Calibri"/>
                     <a:sym typeface="Calibri"/>
                   </a:rPr>
-                  <a:t>RPM &amp; Patient Insights</a:t>
+                  <a:t>RPM &amp; Home Health AI</a:t>
                 </a:r>
                 <a:endParaRPr b="1" i="0" sz="1100">
                   <a:solidFill>
@@ -19921,7 +19921,7 @@
                     <a:cs typeface="Calibri"/>
                     <a:sym typeface="Calibri"/>
                   </a:rPr>
-                  <a:t>Flag at-risk patients and gain visibility into population health across all 6 home health cities</a:t>
+                  <a:t>Solves: Home Healthcare Coordination &amp; Readmission Risk — remote monitoring across 6 cities with proactive flagging of at-risk patients.</a:t>
                 </a:r>
                 <a:endParaRPr b="1" i="0" sz="950">
                   <a:solidFill>

</xml_diff>

<commit_message>
Personalize slide 6 journey to map directly to slide 4 challenges and slide 5 agents
</commit_message>
<xml_diff>
--- a/Fakeeh_Care_Group_v2.pptx
+++ b/Fakeeh_Care_Group_v2.pptx
@@ -20254,7 +20254,7 @@
                   <a:cs typeface="Calibri"/>
                   <a:sym typeface="Calibri"/>
                 </a:rPr>
-                <a:t>One patient, every touchpoint.</a:t>
+                <a:t>One patient. Six slide-4 challenges. Resolved at every touchpoint.</a:t>
               </a:r>
               <a:endParaRPr b="1" sz="2300">
                 <a:solidFill>
@@ -20363,7 +20363,7 @@
                   <a:cs typeface="Calibri"/>
                   <a:sym typeface="Calibri"/>
                 </a:rPr>
-                <a:t>Ahmed's chronic care journey at Fakeeh University Hospital, Dubai</a:t>
+                <a:t>Ahmed's journey shows Amigo's agents eliminating Fakeeh's exact pain points — step by step.</a:t>
               </a:r>
               <a:endParaRPr b="1" sz="900">
                 <a:solidFill>
@@ -20500,7 +20500,7 @@
                   <a:cs typeface="Calibri"/>
                   <a:sym typeface="Calibri"/>
                 </a:rPr>
-                <a:t>01 / Onboarding</a:t>
+                <a:t>01 / Outreach</a:t>
               </a:r>
               <a:endParaRPr b="1" sz="1000">
                 <a:solidFill>
@@ -20684,7 +20684,7 @@
                   <a:cs typeface="Calibri"/>
                   <a:sym typeface="Calibri"/>
                 </a:rPr>
-                <a:t>"Ahmed, you're overdue for a diabetes check. I've found a slot Thursday at Fakeeh. Want me to book it?"</a:t>
+                <a:t>"Ahmed, you're overdue for a diabetes check. I've found a Thursday slot at Fakeeh University Hospital — want me to book it?"</a:t>
               </a:r>
               <a:endParaRPr i="1" sz="850">
                 <a:solidFill>
@@ -20742,7 +20742,7 @@
                   <a:cs typeface="Calibri"/>
                   <a:sym typeface="Calibri"/>
                 </a:rPr>
-                <a:t>Key Touchpoints</a:t>
+                <a:t>Challenge Solved</a:t>
               </a:r>
               <a:endParaRPr b="1" sz="750">
                 <a:solidFill>
@@ -20779,7 +20779,7 @@
                   <a:cs typeface="Calibri"/>
                   <a:sym typeface="Calibri"/>
                 </a:rPr>
-                <a:t>Overdue visit flagged</a:t>
+                <a:t>→ Lost Revenue: dormant patient reactivated</a:t>
               </a:r>
               <a:endParaRPr sz="850">
                 <a:solidFill>
@@ -20816,7 +20816,7 @@
                   <a:cs typeface="Calibri"/>
                   <a:sym typeface="Calibri"/>
                 </a:rPr>
-                <a:t>Outbound appt. booked</a:t>
+                <a:t>→ Unfilled Schedules: slot filled with no front-desk effort</a:t>
               </a:r>
               <a:endParaRPr sz="850">
                 <a:solidFill>
@@ -20853,7 +20853,7 @@
                   <a:cs typeface="Calibri"/>
                   <a:sym typeface="Calibri"/>
                 </a:rPr>
-                <a:t>Insurance verified</a:t>
+                <a:t>→ Agent: Proactive Outreach (Slide 5 · #01)</a:t>
               </a:r>
               <a:endParaRPr sz="850">
                 <a:solidFill>
@@ -20926,7 +20926,7 @@
                   <a:cs typeface="Calibri"/>
                   <a:sym typeface="Calibri"/>
                 </a:rPr>
-                <a:t>02 / Pre-visit</a:t>
+                <a:t>02 / Pre-Visit</a:t>
               </a:r>
               <a:endParaRPr b="1" sz="1000">
                 <a:solidFill>
@@ -21110,7 +21110,7 @@
                   <a:cs typeface="Calibri"/>
                   <a:sym typeface="Calibri"/>
                 </a:rPr>
-                <a:t>"Your appointment is tomorrow. Any new symptoms for Dr. Al-Rashidi? Here's what to bring..."</a:t>
+                <a:t>"Your appointment is tomorrow, Ahmed. Any new symptoms? Here's your prep checklist in Arabic — Dr. Al-Mansoori will be ready."</a:t>
               </a:r>
               <a:endParaRPr i="1" sz="850">
                 <a:solidFill>
@@ -21168,7 +21168,7 @@
                   <a:cs typeface="Calibri"/>
                   <a:sym typeface="Calibri"/>
                 </a:rPr>
-                <a:t>Key Touchpoints</a:t>
+                <a:t>Challenge Solved</a:t>
               </a:r>
               <a:endParaRPr b="1" sz="750">
                 <a:solidFill>
@@ -21205,7 +21205,7 @@
                   <a:cs typeface="Calibri"/>
                   <a:sym typeface="Calibri"/>
                 </a:rPr>
-                <a:t>Intake completed</a:t>
+                <a:t>→ Volume Growth: intake automated, front-desk freed</a:t>
               </a:r>
               <a:endParaRPr sz="850">
                 <a:solidFill>
@@ -21242,7 +21242,7 @@
                   <a:cs typeface="Calibri"/>
                   <a:sym typeface="Calibri"/>
                 </a:rPr>
-                <a:t>Appt. reminder sent</a:t>
+                <a:t>→ Multi-Language: prep delivered in Arabic, auto-detected</a:t>
               </a:r>
               <a:endParaRPr sz="850">
                 <a:solidFill>
@@ -21279,7 +21279,7 @@
                   <a:cs typeface="Calibri"/>
                   <a:sym typeface="Calibri"/>
                 </a:rPr>
-                <a:t>Patient prep info shared</a:t>
+                <a:t>→ Agents: Scheduling #02 · Multilingual Education #04</a:t>
               </a:r>
               <a:endParaRPr sz="850">
                 <a:solidFill>
@@ -21536,7 +21536,7 @@
                   <a:cs typeface="Calibri"/>
                   <a:sym typeface="Calibri"/>
                 </a:rPr>
-                <a:t>Dr. Al-Mansoori reviews Ahmed's full history, flagged care gaps, and new HbA1c concerns before entering.</a:t>
+                <a:t>Dr. Al-Mansoori walks in fully briefed — HbA1c trend, flagged care gaps, and suggested next steps already surfaced by Amigo.</a:t>
               </a:r>
               <a:endParaRPr i="1" sz="850">
                 <a:solidFill>
@@ -21594,7 +21594,7 @@
                   <a:cs typeface="Calibri"/>
                   <a:sym typeface="Calibri"/>
                 </a:rPr>
-                <a:t>Key Touchpoints</a:t>
+                <a:t>Challenge Solved</a:t>
               </a:r>
               <a:endParaRPr b="1" sz="750">
                 <a:solidFill>
@@ -21631,7 +21631,7 @@
                   <a:cs typeface="Calibri"/>
                   <a:sym typeface="Calibri"/>
                 </a:rPr>
-                <a:t>Provider fully briefed</a:t>
+                <a:t>→ Burnout: cognitive load offloaded from physician</a:t>
               </a:r>
               <a:endParaRPr sz="850">
                 <a:solidFill>
@@ -21668,7 +21668,7 @@
                   <a:cs typeface="Calibri"/>
                   <a:sym typeface="Calibri"/>
                 </a:rPr>
-                <a:t>Copilot ensures nothing missed</a:t>
+                <a:t>→ High Turnover: new doctors onboard faster with AI support</a:t>
               </a:r>
               <a:endParaRPr sz="850">
                 <a:solidFill>
@@ -21705,7 +21705,7 @@
                   <a:cs typeface="Calibri"/>
                   <a:sym typeface="Calibri"/>
                 </a:rPr>
-                <a:t>Personalized session</a:t>
+                <a:t>→ Agent: Provider Copilot (Slide 5 · #05)</a:t>
               </a:r>
               <a:endParaRPr sz="850">
                 <a:solidFill>
@@ -21778,7 +21778,7 @@
                   <a:cs typeface="Calibri"/>
                   <a:sym typeface="Calibri"/>
                 </a:rPr>
-                <a:t>04 / Post-visit</a:t>
+                <a:t>04 / Post-Visit</a:t>
               </a:r>
               <a:endParaRPr b="1" sz="1000">
                 <a:solidFill>
@@ -21962,7 +21962,7 @@
                   <a:cs typeface="Calibri"/>
                   <a:sym typeface="Calibri"/>
                 </a:rPr>
-                <a:t>"Your A1C is 7.2 — manageable! Dr. Al-Rashidi has started you on adjusted Metformin. Dietitian booked."</a:t>
+                <a:t>"Your A1C is 7.2 — manageable, Ahmed! Dr. Al-Mansoori adjusted your Metformin. Dietitian appointment booked. Reply anytime."</a:t>
               </a:r>
               <a:endParaRPr i="1" sz="850">
                 <a:solidFill>
@@ -22020,7 +22020,7 @@
                   <a:cs typeface="Calibri"/>
                   <a:sym typeface="Calibri"/>
                 </a:rPr>
-                <a:t>Key Touchpoints</a:t>
+                <a:t>Challenge Solved</a:t>
               </a:r>
               <a:endParaRPr b="1" sz="750">
                 <a:solidFill>
@@ -22057,7 +22057,7 @@
                   <a:cs typeface="Calibri"/>
                   <a:sym typeface="Calibri"/>
                 </a:rPr>
-                <a:t>Lab results in plain Arabic</a:t>
+                <a:t>→ Drop-Off: $15K LTV retained per patient</a:t>
               </a:r>
               <a:endParaRPr sz="850">
                 <a:solidFill>
@@ -22094,7 +22094,7 @@
                   <a:cs typeface="Calibri"/>
                   <a:sym typeface="Calibri"/>
                 </a:rPr>
-                <a:t>Metformin Rx drafted</a:t>
+                <a:t>→ Referral Leakage: dietitian referral closed in the same conversation</a:t>
               </a:r>
               <a:endParaRPr sz="850">
                 <a:solidFill>
@@ -22131,7 +22131,7 @@
                   <a:cs typeface="Calibri"/>
                   <a:sym typeface="Calibri"/>
                 </a:rPr>
-                <a:t>Dietitian referred</a:t>
+                <a:t>→ Agent: Post-Visit Follow-Up (Slide 5 · #06)</a:t>
               </a:r>
               <a:endParaRPr sz="850">
                 <a:solidFill>
@@ -22204,7 +22204,7 @@
                   <a:cs typeface="Calibri"/>
                   <a:sym typeface="Calibri"/>
                 </a:rPr>
-                <a:t>05 / Ongoing care</a:t>
+                <a:t>05 / Ongoing &amp; Remote Care</a:t>
               </a:r>
               <a:endParaRPr b="1" sz="1000">
                 <a:solidFill>
@@ -22388,7 +22388,7 @@
                   <a:cs typeface="Calibri"/>
                   <a:sym typeface="Calibri"/>
                 </a:rPr>
-                <a:t>"You hit your 8,000 steps goal yesterday! How's the new Metformin dose feeling? Any stomach issues?"</a:t>
+                <a:t>"Great week, Ahmed — steps goal hit! HbA1c trending down. Any issues with the new dose? Your home-monitoring data looks stable."</a:t>
               </a:r>
               <a:endParaRPr i="1" sz="850">
                 <a:solidFill>
@@ -22446,7 +22446,7 @@
                   <a:cs typeface="Calibri"/>
                   <a:sym typeface="Calibri"/>
                 </a:rPr>
-                <a:t>Key Touchpoints</a:t>
+                <a:t>Challenge Solved</a:t>
               </a:r>
               <a:endParaRPr b="1" sz="750">
                 <a:solidFill>
@@ -22483,7 +22483,7 @@
                   <a:cs typeface="Calibri"/>
                   <a:sym typeface="Calibri"/>
                 </a:rPr>
-                <a:t>24/7 health coaching</a:t>
+                <a:t>→ Chronic Disease: continuous engagement without provider bandwidth</a:t>
               </a:r>
               <a:endParaRPr sz="850">
                 <a:solidFill>
@@ -22520,7 +22520,7 @@
                   <a:cs typeface="Calibri"/>
                   <a:sym typeface="Calibri"/>
                 </a:rPr>
-                <a:t>Progress check-ins</a:t>
+                <a:t>→ Home Health: RPM data from 6 cities monitored, at-risk flagged early</a:t>
               </a:r>
               <a:endParaRPr sz="850">
                 <a:solidFill>
@@ -22557,7 +22557,7 @@
                   <a:cs typeface="Calibri"/>
                   <a:sym typeface="Calibri"/>
                 </a:rPr>
-                <a:t>Medication adherence</a:t>
+                <a:t>→ Agents: 24/7 Chronic Care #07 · RPM &amp; Home Health AI #08</a:t>
               </a:r>
               <a:endParaRPr sz="850">
                 <a:solidFill>

</xml_diff>

<commit_message>
Rebuild slide 8 to match reference image — 2-col layout + rust geometric panel
</commit_message>
<xml_diff>
--- a/Fakeeh_Care_Group_v2.pptx
+++ b/Fakeeh_Care_Group_v2.pptx
@@ -25721,10 +25721,10 @@
         </p:nvGrpSpPr>
         <p:grpSpPr>
           <a:xfrm>
-            <a:off x="476250" y="1333500"/>
-            <a:ext cx="2571900" cy="1095300"/>
+            <a:off x="347472" y="914400"/>
+            <a:ext cx="2395728" cy="1115568"/>
             <a:chOff x="0" y="0"/>
-            <a:chExt cx="2571900" cy="1095300"/>
+            <a:chExt cx="2395728" cy="1115568"/>
           </a:xfrm>
         </p:grpSpPr>
         <p:sp>
@@ -25736,7 +25736,7 @@
           <p:spPr>
             <a:xfrm>
               <a:off x="0" y="0"/>
-              <a:ext cx="2571900" cy="1095300"/>
+              <a:ext cx="2395728" cy="1115568"/>
             </a:xfrm>
             <a:prstGeom prst="roundRect">
               <a:avLst>
@@ -25787,7 +25787,7 @@
           <p:spPr>
             <a:xfrm>
               <a:off x="0" y="0"/>
-              <a:ext cx="38100" cy="1095300"/>
+              <a:ext cx="35490" cy="1115568"/>
             </a:xfrm>
             <a:prstGeom prst="roundRect">
               <a:avLst>
@@ -25831,8 +25831,8 @@
           </p:nvSpPr>
           <p:spPr>
             <a:xfrm>
-              <a:off x="142875" y="114300"/>
-              <a:ext cx="2286000" cy="857400"/>
+              <a:off x="133088" y="116415"/>
+              <a:ext cx="2129411" cy="873265"/>
             </a:xfrm>
             <a:prstGeom prst="rect">
               <a:avLst/>
@@ -25938,10 +25938,10 @@
         </p:nvGrpSpPr>
         <p:grpSpPr>
           <a:xfrm>
-            <a:off x="3286125" y="1333500"/>
-            <a:ext cx="2571900" cy="1095300"/>
+            <a:off x="347472" y="2148840"/>
+            <a:ext cx="2395728" cy="1115568"/>
             <a:chOff x="0" y="0"/>
-            <a:chExt cx="2571900" cy="1095300"/>
+            <a:chExt cx="2395728" cy="1115568"/>
           </a:xfrm>
         </p:grpSpPr>
         <p:sp>
@@ -25953,7 +25953,7 @@
           <p:spPr>
             <a:xfrm>
               <a:off x="0" y="0"/>
-              <a:ext cx="2571900" cy="1095300"/>
+              <a:ext cx="2395728" cy="1115568"/>
             </a:xfrm>
             <a:prstGeom prst="roundRect">
               <a:avLst>
@@ -26004,7 +26004,7 @@
           <p:spPr>
             <a:xfrm>
               <a:off x="0" y="0"/>
-              <a:ext cx="38100" cy="1095300"/>
+              <a:ext cx="35490" cy="1115568"/>
             </a:xfrm>
             <a:prstGeom prst="roundRect">
               <a:avLst>
@@ -26048,8 +26048,8 @@
           </p:nvSpPr>
           <p:spPr>
             <a:xfrm>
-              <a:off x="142875" y="114300"/>
-              <a:ext cx="2286000" cy="857400"/>
+              <a:off x="133088" y="116415"/>
+              <a:ext cx="2129411" cy="873265"/>
             </a:xfrm>
             <a:prstGeom prst="rect">
               <a:avLst/>
@@ -26155,10 +26155,10 @@
         </p:nvGrpSpPr>
         <p:grpSpPr>
           <a:xfrm>
-            <a:off x="6096000" y="1333500"/>
-            <a:ext cx="2571900" cy="1095300"/>
+            <a:off x="347472" y="3383280"/>
+            <a:ext cx="2395728" cy="1115568"/>
             <a:chOff x="0" y="0"/>
-            <a:chExt cx="2571900" cy="1095300"/>
+            <a:chExt cx="2395728" cy="1115568"/>
           </a:xfrm>
         </p:grpSpPr>
         <p:sp>
@@ -26170,7 +26170,7 @@
           <p:spPr>
             <a:xfrm>
               <a:off x="0" y="0"/>
-              <a:ext cx="2571900" cy="1095300"/>
+              <a:ext cx="2395728" cy="1115568"/>
             </a:xfrm>
             <a:prstGeom prst="roundRect">
               <a:avLst>
@@ -26221,7 +26221,7 @@
           <p:spPr>
             <a:xfrm>
               <a:off x="0" y="0"/>
-              <a:ext cx="38100" cy="1095300"/>
+              <a:ext cx="35490" cy="1115568"/>
             </a:xfrm>
             <a:prstGeom prst="roundRect">
               <a:avLst>
@@ -26265,8 +26265,8 @@
           </p:nvSpPr>
           <p:spPr>
             <a:xfrm>
-              <a:off x="142875" y="114300"/>
-              <a:ext cx="2286000" cy="857400"/>
+              <a:off x="133088" y="116415"/>
+              <a:ext cx="2129411" cy="873265"/>
             </a:xfrm>
             <a:prstGeom prst="rect">
               <a:avLst/>
@@ -26372,10 +26372,10 @@
         </p:nvGrpSpPr>
         <p:grpSpPr>
           <a:xfrm>
-            <a:off x="476250" y="2619375"/>
-            <a:ext cx="2571900" cy="1095300"/>
+            <a:off x="2907792" y="914400"/>
+            <a:ext cx="2395728" cy="1115568"/>
             <a:chOff x="0" y="0"/>
-            <a:chExt cx="2571900" cy="1095300"/>
+            <a:chExt cx="2395728" cy="1115568"/>
           </a:xfrm>
         </p:grpSpPr>
         <p:sp>
@@ -26387,7 +26387,7 @@
           <p:spPr>
             <a:xfrm>
               <a:off x="0" y="0"/>
-              <a:ext cx="2571900" cy="1095300"/>
+              <a:ext cx="2395728" cy="1115568"/>
             </a:xfrm>
             <a:prstGeom prst="roundRect">
               <a:avLst>
@@ -26438,7 +26438,7 @@
           <p:spPr>
             <a:xfrm>
               <a:off x="0" y="0"/>
-              <a:ext cx="38100" cy="1095300"/>
+              <a:ext cx="35490" cy="1115568"/>
             </a:xfrm>
             <a:prstGeom prst="roundRect">
               <a:avLst>
@@ -26482,8 +26482,8 @@
           </p:nvSpPr>
           <p:spPr>
             <a:xfrm>
-              <a:off x="142875" y="114300"/>
-              <a:ext cx="2286000" cy="857400"/>
+              <a:off x="133088" y="116415"/>
+              <a:ext cx="2129411" cy="873265"/>
             </a:xfrm>
             <a:prstGeom prst="rect">
               <a:avLst/>
@@ -26589,10 +26589,10 @@
         </p:nvGrpSpPr>
         <p:grpSpPr>
           <a:xfrm>
-            <a:off x="3286125" y="2619375"/>
-            <a:ext cx="2571900" cy="1095300"/>
+            <a:off x="2907792" y="2148840"/>
+            <a:ext cx="2395728" cy="1115568"/>
             <a:chOff x="0" y="0"/>
-            <a:chExt cx="2571900" cy="1095300"/>
+            <a:chExt cx="2395728" cy="1115568"/>
           </a:xfrm>
         </p:grpSpPr>
         <p:sp>
@@ -26604,7 +26604,7 @@
           <p:spPr>
             <a:xfrm>
               <a:off x="0" y="0"/>
-              <a:ext cx="2571900" cy="1095300"/>
+              <a:ext cx="2395728" cy="1115568"/>
             </a:xfrm>
             <a:prstGeom prst="roundRect">
               <a:avLst>
@@ -26655,7 +26655,7 @@
           <p:spPr>
             <a:xfrm>
               <a:off x="0" y="0"/>
-              <a:ext cx="38100" cy="1095300"/>
+              <a:ext cx="35490" cy="1115568"/>
             </a:xfrm>
             <a:prstGeom prst="roundRect">
               <a:avLst>
@@ -26699,8 +26699,8 @@
           </p:nvSpPr>
           <p:spPr>
             <a:xfrm>
-              <a:off x="142875" y="114300"/>
-              <a:ext cx="2286000" cy="857400"/>
+              <a:off x="133088" y="116415"/>
+              <a:ext cx="2129411" cy="873265"/>
             </a:xfrm>
             <a:prstGeom prst="rect">
               <a:avLst/>
@@ -26806,10 +26806,10 @@
         </p:nvGrpSpPr>
         <p:grpSpPr>
           <a:xfrm>
-            <a:off x="6096000" y="2619375"/>
-            <a:ext cx="2571900" cy="1095300"/>
+            <a:off x="2907792" y="3383280"/>
+            <a:ext cx="2395728" cy="1115568"/>
             <a:chOff x="0" y="0"/>
-            <a:chExt cx="2571900" cy="1095300"/>
+            <a:chExt cx="2395728" cy="1115568"/>
           </a:xfrm>
         </p:grpSpPr>
         <p:sp>
@@ -26821,7 +26821,7 @@
           <p:spPr>
             <a:xfrm>
               <a:off x="0" y="0"/>
-              <a:ext cx="2571900" cy="1095300"/>
+              <a:ext cx="2395728" cy="1115568"/>
             </a:xfrm>
             <a:prstGeom prst="roundRect">
               <a:avLst>
@@ -26872,7 +26872,7 @@
           <p:spPr>
             <a:xfrm>
               <a:off x="0" y="0"/>
-              <a:ext cx="38100" cy="1095300"/>
+              <a:ext cx="35490" cy="1115568"/>
             </a:xfrm>
             <a:prstGeom prst="roundRect">
               <a:avLst>
@@ -26916,8 +26916,8 @@
           </p:nvSpPr>
           <p:spPr>
             <a:xfrm>
-              <a:off x="142875" y="114300"/>
-              <a:ext cx="2286000" cy="857400"/>
+              <a:off x="133088" y="116415"/>
+              <a:ext cx="2129411" cy="873265"/>
             </a:xfrm>
             <a:prstGeom prst="rect">
               <a:avLst/>
@@ -27125,7 +27125,7 @@
                 <a:cs typeface="Calibri"/>
                 <a:sym typeface="Calibri"/>
               </a:rPr>
-              <a:t>From discovery to post-development, our team handles the complexity so Fakeeh can stay focused on care.</a:t>
+              <a:t>From discovery to post-development, our team handles the complexity so you can stay focused on care.</a:t>
             </a:r>
             <a:endParaRPr b="0" i="1" sz="1100">
               <a:solidFill>
@@ -27167,6 +27167,209 @@
           </a:ln>
         </p:spPr>
       </p:pic>
+      <p:sp>
+        <p:nvSpPr>
+          <p:cNvPr id="95623560" name="deco_5623560_0"/>
+          <p:cNvSpPr>
+            <a:spLocks noGrp="1"/>
+          </p:cNvSpPr>
+          <p:nvPr/>
+        </p:nvSpPr>
+        <p:spPr>
+          <a:xfrm>
+            <a:off x="5623560" y="0"/>
+            <a:ext cx="3520440" cy="5143500"/>
+          </a:xfrm>
+          <a:prstGeom prst="rect">
+            <a:avLst/>
+          </a:prstGeom>
+          <a:solidFill>
+            <a:srgbClr val="F0EAE6"/>
+          </a:solidFill>
+          <a:ln>
+            <a:noFill/>
+          </a:ln>
+        </p:spPr>
+        <p:txBody>
+          <a:bodyPr/>
+          <a:lstStyle/>
+          <a:p/>
+        </p:txBody>
+      </p:sp>
+      <p:sp>
+        <p:nvSpPr>
+          <p:cNvPr id="96583680" name="deco_6583680_182880"/>
+          <p:cNvSpPr>
+            <a:spLocks noGrp="1"/>
+          </p:cNvSpPr>
+          <p:nvPr/>
+        </p:nvSpPr>
+        <p:spPr>
+          <a:xfrm>
+            <a:off x="6583680" y="182880"/>
+            <a:ext cx="2377440" cy="2286000"/>
+          </a:xfrm>
+          <a:prstGeom prst="rect">
+            <a:avLst/>
+          </a:prstGeom>
+          <a:solidFill>
+            <a:srgbClr val="B44030"/>
+          </a:solidFill>
+          <a:ln>
+            <a:noFill/>
+          </a:ln>
+        </p:spPr>
+        <p:txBody>
+          <a:bodyPr/>
+          <a:lstStyle/>
+          <a:p/>
+        </p:txBody>
+      </p:sp>
+      <p:sp>
+        <p:nvSpPr>
+          <p:cNvPr id="95989320" name="deco_5989320_1097280"/>
+          <p:cNvSpPr>
+            <a:spLocks noGrp="1"/>
+          </p:cNvSpPr>
+          <p:nvPr/>
+        </p:nvSpPr>
+        <p:spPr>
+          <a:xfrm>
+            <a:off x="5989320" y="1097280"/>
+            <a:ext cx="2011680" cy="1828800"/>
+          </a:xfrm>
+          <a:prstGeom prst="rect">
+            <a:avLst/>
+          </a:prstGeom>
+          <a:solidFill>
+            <a:srgbClr val="C85040"/>
+          </a:solidFill>
+          <a:ln>
+            <a:noFill/>
+          </a:ln>
+        </p:spPr>
+        <p:txBody>
+          <a:bodyPr/>
+          <a:lstStyle/>
+          <a:p/>
+        </p:txBody>
+      </p:sp>
+      <p:sp>
+        <p:nvSpPr>
+          <p:cNvPr id="95623560" name="deco_5623560_2194560"/>
+          <p:cNvSpPr>
+            <a:spLocks noGrp="1"/>
+          </p:cNvSpPr>
+          <p:nvPr/>
+        </p:nvSpPr>
+        <p:spPr>
+          <a:xfrm>
+            <a:off x="5623560" y="2194560"/>
+            <a:ext cx="1737360" cy="1645920"/>
+          </a:xfrm>
+          <a:prstGeom prst="rect">
+            <a:avLst/>
+          </a:prstGeom>
+          <a:solidFill>
+            <a:srgbClr val="8A2E22"/>
+          </a:solidFill>
+          <a:ln>
+            <a:noFill/>
+          </a:ln>
+        </p:spPr>
+        <p:txBody>
+          <a:bodyPr/>
+          <a:lstStyle/>
+          <a:p/>
+        </p:txBody>
+      </p:sp>
+      <p:sp>
+        <p:nvSpPr>
+          <p:cNvPr id="95623560" name="deco_5623560_182880"/>
+          <p:cNvSpPr>
+            <a:spLocks noGrp="1"/>
+          </p:cNvSpPr>
+          <p:nvPr/>
+        </p:nvSpPr>
+        <p:spPr>
+          <a:xfrm>
+            <a:off x="5623560" y="182880"/>
+            <a:ext cx="822960" cy="1005840"/>
+          </a:xfrm>
+          <a:prstGeom prst="rect">
+            <a:avLst/>
+          </a:prstGeom>
+          <a:solidFill>
+            <a:srgbClr val="C85040"/>
+          </a:solidFill>
+          <a:ln>
+            <a:noFill/>
+          </a:ln>
+        </p:spPr>
+        <p:txBody>
+          <a:bodyPr/>
+          <a:lstStyle/>
+          <a:p/>
+        </p:txBody>
+      </p:sp>
+      <p:sp>
+        <p:nvSpPr>
+          <p:cNvPr id="95623560" name="deco_5623560_3840480"/>
+          <p:cNvSpPr>
+            <a:spLocks noGrp="1"/>
+          </p:cNvSpPr>
+          <p:nvPr/>
+        </p:nvSpPr>
+        <p:spPr>
+          <a:xfrm>
+            <a:off x="5623560" y="3840480"/>
+            <a:ext cx="3520440" cy="1280160"/>
+          </a:xfrm>
+          <a:prstGeom prst="rect">
+            <a:avLst/>
+          </a:prstGeom>
+          <a:solidFill>
+            <a:srgbClr val="8A2E22"/>
+          </a:solidFill>
+          <a:ln>
+            <a:noFill/>
+          </a:ln>
+        </p:spPr>
+        <p:txBody>
+          <a:bodyPr/>
+          <a:lstStyle/>
+          <a:p/>
+        </p:txBody>
+      </p:sp>
+      <p:sp>
+        <p:nvSpPr>
+          <p:cNvPr id="96858000" name="deco_6858000_2926080"/>
+          <p:cNvSpPr>
+            <a:spLocks noGrp="1"/>
+          </p:cNvSpPr>
+          <p:nvPr/>
+        </p:nvSpPr>
+        <p:spPr>
+          <a:xfrm>
+            <a:off x="6858000" y="2926080"/>
+            <a:ext cx="2286000" cy="1828800"/>
+          </a:xfrm>
+          <a:prstGeom prst="rect">
+            <a:avLst/>
+          </a:prstGeom>
+          <a:solidFill>
+            <a:srgbClr val="D4604E"/>
+          </a:solidFill>
+          <a:ln>
+            <a:noFill/>
+          </a:ln>
+        </p:spPr>
+        <p:txBody>
+          <a:bodyPr/>
+          <a:lstStyle/>
+          <a:p/>
+        </p:txBody>
+      </p:sp>
     </p:spTree>
   </p:cSld>
   <p:clrMapOvr>

</xml_diff>

<commit_message>
Add slide 9: copy of Your AI partner slide with F7F5F0 background
</commit_message>
<xml_diff>
--- a/Fakeeh_Care_Group_v2.pptx
+++ b/Fakeeh_Care_Group_v2.pptx
@@ -16,6 +16,7 @@
     <p:sldId id="260" r:id="rId10"/>
     <p:sldId id="261" r:id="rId11"/>
     <p:sldId id="262" r:id="rId12"/>
+    <p:sldId id="264" r:id="rId14"/>
   </p:sldIdLst>
   <p:sldSz cy="5143500" cx="9144000"/>
   <p:notesSz cx="6858000" cy="9144000"/>
@@ -27378,6 +27379,1791 @@
 </p:sld>
 </file>
 
+<file path=ppt/slides/slide9.xml><?xml version="1.0" encoding="utf-8"?>
+<p:sld xmlns:a="http://schemas.openxmlformats.org/drawingml/2006/main" xmlns:p="http://schemas.openxmlformats.org/presentationml/2006/main" xmlns:r="http://schemas.openxmlformats.org/officeDocument/2006/relationships">
+  <p:cSld>
+    <p:spTree>
+      <p:nvGrpSpPr>
+        <p:cNvPr id="1" name=""/>
+        <p:cNvGrpSpPr/>
+        <p:nvPr/>
+      </p:nvGrpSpPr>
+      <p:grpSpPr/>
+      <p:sp>
+        <p:nvSpPr>
+          <p:cNvPr id="2" name="Title 1"/>
+          <p:cNvSpPr>
+            <a:spLocks noGrp="1"/>
+          </p:cNvSpPr>
+          <p:nvPr>
+            <p:ph type="title"/>
+          </p:nvPr>
+        </p:nvSpPr>
+        <p:spPr/>
+        <p:txBody>
+          <a:bodyPr/>
+          <a:lstStyle/>
+          <a:p/>
+        </p:txBody>
+      </p:sp>
+      <p:sp>
+        <p:nvSpPr>
+          <p:cNvPr id="351" name="Google Shape;351;p19"/>
+          <p:cNvSpPr/>
+          <p:nvPr/>
+        </p:nvSpPr>
+        <p:spPr>
+          <a:xfrm>
+            <a:off x="0" y="0"/>
+            <a:ext cx="9144000" cy="41100"/>
+          </a:xfrm>
+          <a:prstGeom prst="rect">
+            <a:avLst/>
+          </a:prstGeom>
+          <a:solidFill>
+            <a:srgbClr val="B44030"/>
+          </a:solidFill>
+          <a:ln>
+            <a:noFill/>
+          </a:ln>
+        </p:spPr>
+        <p:txBody>
+          <a:bodyPr anchorCtr="0" anchor="ctr" bIns="0" lIns="0" spcFirstLastPara="1" rIns="0" wrap="square" tIns="0">
+            <a:noAutofit/>
+          </a:bodyPr>
+          <a:lstStyle/>
+          <a:p>
+            <a:pPr indent="0" lvl="0" marL="0" rtl="0" algn="l">
+              <a:spcBef>
+                <a:spcPts val="0"/>
+              </a:spcBef>
+              <a:spcAft>
+                <a:spcPts val="0"/>
+              </a:spcAft>
+              <a:buNone/>
+            </a:pPr>
+            <a:r>
+              <a:t/>
+            </a:r>
+            <a:endParaRPr/>
+          </a:p>
+        </p:txBody>
+      </p:sp>
+      <p:sp>
+        <p:nvSpPr>
+          <p:cNvPr id="352" name="Google Shape;352;p19"/>
+          <p:cNvSpPr/>
+          <p:nvPr/>
+        </p:nvSpPr>
+        <p:spPr>
+          <a:xfrm>
+            <a:off x="0" y="0"/>
+            <a:ext cx="9144000" cy="5143500"/>
+          </a:xfrm>
+          <a:prstGeom prst="rect">
+            <a:avLst/>
+          </a:prstGeom>
+          <a:solidFill>
+            <a:srgbClr val="F7F5F0"/>
+          </a:solidFill>
+          <a:ln>
+            <a:noFill/>
+          </a:ln>
+          <a:effectLst>
+            <a:outerShdw blurRad="40000" rotWithShape="0" dir="5400000" dist="23000">
+              <a:srgbClr val="F7F5F0">
+                <a:alpha val="34901"/>
+              </a:srgbClr>
+            </a:outerShdw>
+          </a:effectLst>
+        </p:spPr>
+        <p:txBody>
+          <a:bodyPr anchorCtr="0" anchor="ctr" bIns="0" lIns="0" spcFirstLastPara="1" rIns="0" wrap="square" tIns="0">
+            <a:noAutofit/>
+          </a:bodyPr>
+          <a:lstStyle/>
+          <a:p>
+            <a:pPr indent="0" lvl="0" marL="0" rtl="0" algn="l">
+              <a:spcBef>
+                <a:spcPts val="0"/>
+              </a:spcBef>
+              <a:spcAft>
+                <a:spcPts val="0"/>
+              </a:spcAft>
+              <a:buNone/>
+            </a:pPr>
+            <a:r>
+              <a:t/>
+            </a:r>
+            <a:endParaRPr/>
+          </a:p>
+        </p:txBody>
+      </p:sp>
+      <p:grpSp>
+        <p:nvGrpSpPr>
+          <p:cNvPr id="353" name="Google Shape;353;p19"/>
+          <p:cNvGrpSpPr/>
+          <p:nvPr/>
+        </p:nvGrpSpPr>
+        <p:grpSpPr>
+          <a:xfrm>
+            <a:off x="347472" y="914400"/>
+            <a:ext cx="2395728" cy="1115568"/>
+            <a:chOff x="0" y="0"/>
+            <a:chExt cx="2395728" cy="1115568"/>
+          </a:xfrm>
+        </p:grpSpPr>
+        <p:sp>
+          <p:nvSpPr>
+            <p:cNvPr id="354" name="Google Shape;354;p19"/>
+            <p:cNvSpPr/>
+            <p:nvPr/>
+          </p:nvSpPr>
+          <p:spPr>
+            <a:xfrm>
+              <a:off x="0" y="0"/>
+              <a:ext cx="2395728" cy="1115568"/>
+            </a:xfrm>
+            <a:prstGeom prst="roundRect">
+              <a:avLst>
+                <a:gd fmla="val 5217" name="adj"/>
+              </a:avLst>
+            </a:prstGeom>
+            <a:solidFill>
+              <a:srgbClr val="FFFFFF"/>
+            </a:solidFill>
+            <a:ln cap="flat" cmpd="sng" w="9525">
+              <a:solidFill>
+                <a:srgbClr val="C8D0D8"/>
+              </a:solidFill>
+              <a:prstDash val="solid"/>
+              <a:round/>
+              <a:headEnd len="sm" w="sm" type="none"/>
+              <a:tailEnd len="sm" w="sm" type="none"/>
+            </a:ln>
+          </p:spPr>
+          <p:txBody>
+            <a:bodyPr anchorCtr="0" anchor="ctr" bIns="0" lIns="0" spcFirstLastPara="1" rIns="0" wrap="square" tIns="0">
+              <a:noAutofit/>
+            </a:bodyPr>
+            <a:lstStyle/>
+            <a:p>
+              <a:pPr indent="0" lvl="0" marL="0" rtl="0" algn="l">
+                <a:spcBef>
+                  <a:spcPts val="0"/>
+                </a:spcBef>
+                <a:spcAft>
+                  <a:spcPts val="0"/>
+                </a:spcAft>
+                <a:buNone/>
+              </a:pPr>
+              <a:r>
+                <a:t/>
+              </a:r>
+              <a:endParaRPr/>
+            </a:p>
+          </p:txBody>
+        </p:sp>
+        <p:sp>
+          <p:nvSpPr>
+            <p:cNvPr id="355" name="Google Shape;355;p19"/>
+            <p:cNvSpPr/>
+            <p:nvPr/>
+          </p:nvSpPr>
+          <p:spPr>
+            <a:xfrm>
+              <a:off x="0" y="0"/>
+              <a:ext cx="35490" cy="1115568"/>
+            </a:xfrm>
+            <a:prstGeom prst="roundRect">
+              <a:avLst>
+                <a:gd fmla="val 50000" name="adj"/>
+              </a:avLst>
+            </a:prstGeom>
+            <a:solidFill>
+              <a:srgbClr val="0D2B3D"/>
+            </a:solidFill>
+            <a:ln>
+              <a:noFill/>
+            </a:ln>
+          </p:spPr>
+          <p:txBody>
+            <a:bodyPr anchorCtr="0" anchor="ctr" bIns="0" lIns="0" spcFirstLastPara="1" rIns="0" wrap="square" tIns="0">
+              <a:noAutofit/>
+            </a:bodyPr>
+            <a:lstStyle/>
+            <a:p>
+              <a:pPr indent="0" lvl="0" marL="0" rtl="0" algn="l">
+                <a:spcBef>
+                  <a:spcPts val="0"/>
+                </a:spcBef>
+                <a:spcAft>
+                  <a:spcPts val="0"/>
+                </a:spcAft>
+                <a:buNone/>
+              </a:pPr>
+              <a:r>
+                <a:t/>
+              </a:r>
+              <a:endParaRPr/>
+            </a:p>
+          </p:txBody>
+        </p:sp>
+        <p:sp>
+          <p:nvSpPr>
+            <p:cNvPr id="356" name="Google Shape;356;p19"/>
+            <p:cNvSpPr txBox="1"/>
+            <p:nvPr/>
+          </p:nvSpPr>
+          <p:spPr>
+            <a:xfrm>
+              <a:off x="133088" y="116415"/>
+              <a:ext cx="2129411" cy="873265"/>
+            </a:xfrm>
+            <a:prstGeom prst="rect">
+              <a:avLst/>
+            </a:prstGeom>
+            <a:solidFill>
+              <a:srgbClr val="000000">
+                <a:alpha val="0"/>
+              </a:srgbClr>
+            </a:solidFill>
+            <a:ln>
+              <a:noFill/>
+            </a:ln>
+          </p:spPr>
+          <p:txBody>
+            <a:bodyPr anchorCtr="0" anchor="t" bIns="0" lIns="0" spcFirstLastPara="1" rIns="0" wrap="square" tIns="0">
+              <a:noAutofit/>
+            </a:bodyPr>
+            <a:lstStyle/>
+            <a:p>
+              <a:pPr indent="0" lvl="0" marL="0" rtl="0" algn="l">
+                <a:spcBef>
+                  <a:spcPts val="0"/>
+                </a:spcBef>
+                <a:spcAft>
+                  <a:spcPts val="0"/>
+                </a:spcAft>
+                <a:buNone/>
+              </a:pPr>
+              <a:r>
+                <a:rPr b="1" lang="en" sz="1300">
+                  <a:solidFill>
+                    <a:srgbClr val="0D2B3D"/>
+                  </a:solidFill>
+                  <a:latin typeface="Calibri"/>
+                  <a:ea typeface="Calibri"/>
+                  <a:cs typeface="Calibri"/>
+                  <a:sym typeface="Calibri"/>
+                </a:rPr>
+                <a:t>01 </a:t>
+              </a:r>
+              <a:r>
+                <a:rPr b="1" lang="en" sz="1200">
+                  <a:solidFill>
+                    <a:srgbClr val="1A1A1A"/>
+                  </a:solidFill>
+                  <a:latin typeface="Calibri"/>
+                  <a:ea typeface="Calibri"/>
+                  <a:cs typeface="Calibri"/>
+                  <a:sym typeface="Calibri"/>
+                </a:rPr>
+                <a:t>Discovery</a:t>
+              </a:r>
+              <a:endParaRPr b="1" sz="1300">
+                <a:solidFill>
+                  <a:srgbClr val="0D2B3D"/>
+                </a:solidFill>
+                <a:latin typeface="Calibri"/>
+                <a:ea typeface="Calibri"/>
+                <a:cs typeface="Calibri"/>
+                <a:sym typeface="Calibri"/>
+              </a:endParaRPr>
+            </a:p>
+            <a:p>
+              <a:pPr indent="0" lvl="0" marL="0" rtl="0" algn="l">
+                <a:spcBef>
+                  <a:spcPts val="450"/>
+                </a:spcBef>
+                <a:spcAft>
+                  <a:spcPts val="450"/>
+                </a:spcAft>
+                <a:buNone/>
+              </a:pPr>
+              <a:r>
+                <a:rPr b="0" lang="en" sz="950">
+                  <a:solidFill>
+                    <a:srgbClr val="5A6A7A"/>
+                  </a:solidFill>
+                  <a:latin typeface="Calibri"/>
+                  <a:ea typeface="Calibri"/>
+                  <a:cs typeface="Calibri"/>
+                  <a:sym typeface="Calibri"/>
+                </a:rPr>
+                <a:t>We deeply understand Fakeeh's unique workflows and goals — not pre-built templates.</a:t>
+              </a:r>
+              <a:endParaRPr b="0" sz="950">
+                <a:solidFill>
+                  <a:srgbClr val="5A6A7A"/>
+                </a:solidFill>
+                <a:latin typeface="Calibri"/>
+                <a:ea typeface="Calibri"/>
+                <a:cs typeface="Calibri"/>
+                <a:sym typeface="Calibri"/>
+              </a:endParaRPr>
+            </a:p>
+          </p:txBody>
+        </p:sp>
+      </p:grpSp>
+      <p:grpSp>
+        <p:nvGrpSpPr>
+          <p:cNvPr id="357" name="Google Shape;357;p19"/>
+          <p:cNvGrpSpPr/>
+          <p:nvPr/>
+        </p:nvGrpSpPr>
+        <p:grpSpPr>
+          <a:xfrm>
+            <a:off x="347472" y="2148840"/>
+            <a:ext cx="2395728" cy="1115568"/>
+            <a:chOff x="0" y="0"/>
+            <a:chExt cx="2395728" cy="1115568"/>
+          </a:xfrm>
+        </p:grpSpPr>
+        <p:sp>
+          <p:nvSpPr>
+            <p:cNvPr id="358" name="Google Shape;358;p19"/>
+            <p:cNvSpPr/>
+            <p:nvPr/>
+          </p:nvSpPr>
+          <p:spPr>
+            <a:xfrm>
+              <a:off x="0" y="0"/>
+              <a:ext cx="2395728" cy="1115568"/>
+            </a:xfrm>
+            <a:prstGeom prst="roundRect">
+              <a:avLst>
+                <a:gd fmla="val 5217" name="adj"/>
+              </a:avLst>
+            </a:prstGeom>
+            <a:solidFill>
+              <a:srgbClr val="FFFFFF"/>
+            </a:solidFill>
+            <a:ln cap="flat" cmpd="sng" w="9525">
+              <a:solidFill>
+                <a:srgbClr val="C8D0D8"/>
+              </a:solidFill>
+              <a:prstDash val="solid"/>
+              <a:round/>
+              <a:headEnd len="sm" w="sm" type="none"/>
+              <a:tailEnd len="sm" w="sm" type="none"/>
+            </a:ln>
+          </p:spPr>
+          <p:txBody>
+            <a:bodyPr anchorCtr="0" anchor="ctr" bIns="0" lIns="0" spcFirstLastPara="1" rIns="0" wrap="square" tIns="0">
+              <a:noAutofit/>
+            </a:bodyPr>
+            <a:lstStyle/>
+            <a:p>
+              <a:pPr indent="0" lvl="0" marL="0" rtl="0" algn="l">
+                <a:spcBef>
+                  <a:spcPts val="0"/>
+                </a:spcBef>
+                <a:spcAft>
+                  <a:spcPts val="0"/>
+                </a:spcAft>
+                <a:buNone/>
+              </a:pPr>
+              <a:r>
+                <a:t/>
+              </a:r>
+              <a:endParaRPr/>
+            </a:p>
+          </p:txBody>
+        </p:sp>
+        <p:sp>
+          <p:nvSpPr>
+            <p:cNvPr id="359" name="Google Shape;359;p19"/>
+            <p:cNvSpPr/>
+            <p:nvPr/>
+          </p:nvSpPr>
+          <p:spPr>
+            <a:xfrm>
+              <a:off x="0" y="0"/>
+              <a:ext cx="35490" cy="1115568"/>
+            </a:xfrm>
+            <a:prstGeom prst="roundRect">
+              <a:avLst>
+                <a:gd fmla="val 50000" name="adj"/>
+              </a:avLst>
+            </a:prstGeom>
+            <a:solidFill>
+              <a:srgbClr val="0D2B3D"/>
+            </a:solidFill>
+            <a:ln>
+              <a:noFill/>
+            </a:ln>
+          </p:spPr>
+          <p:txBody>
+            <a:bodyPr anchorCtr="0" anchor="ctr" bIns="0" lIns="0" spcFirstLastPara="1" rIns="0" wrap="square" tIns="0">
+              <a:noAutofit/>
+            </a:bodyPr>
+            <a:lstStyle/>
+            <a:p>
+              <a:pPr indent="0" lvl="0" marL="0" rtl="0" algn="l">
+                <a:spcBef>
+                  <a:spcPts val="0"/>
+                </a:spcBef>
+                <a:spcAft>
+                  <a:spcPts val="0"/>
+                </a:spcAft>
+                <a:buNone/>
+              </a:pPr>
+              <a:r>
+                <a:t/>
+              </a:r>
+              <a:endParaRPr/>
+            </a:p>
+          </p:txBody>
+        </p:sp>
+        <p:sp>
+          <p:nvSpPr>
+            <p:cNvPr id="360" name="Google Shape;360;p19"/>
+            <p:cNvSpPr txBox="1"/>
+            <p:nvPr/>
+          </p:nvSpPr>
+          <p:spPr>
+            <a:xfrm>
+              <a:off x="133088" y="116415"/>
+              <a:ext cx="2129411" cy="873265"/>
+            </a:xfrm>
+            <a:prstGeom prst="rect">
+              <a:avLst/>
+            </a:prstGeom>
+            <a:solidFill>
+              <a:srgbClr val="000000">
+                <a:alpha val="0"/>
+              </a:srgbClr>
+            </a:solidFill>
+            <a:ln>
+              <a:noFill/>
+            </a:ln>
+          </p:spPr>
+          <p:txBody>
+            <a:bodyPr anchorCtr="0" anchor="t" bIns="0" lIns="0" spcFirstLastPara="1" rIns="0" wrap="square" tIns="0">
+              <a:noAutofit/>
+            </a:bodyPr>
+            <a:lstStyle/>
+            <a:p>
+              <a:pPr indent="0" lvl="0" marL="0" rtl="0" algn="l">
+                <a:spcBef>
+                  <a:spcPts val="0"/>
+                </a:spcBef>
+                <a:spcAft>
+                  <a:spcPts val="0"/>
+                </a:spcAft>
+                <a:buNone/>
+              </a:pPr>
+              <a:r>
+                <a:rPr b="1" lang="en" sz="1300">
+                  <a:solidFill>
+                    <a:srgbClr val="0D2B3D"/>
+                  </a:solidFill>
+                  <a:latin typeface="Calibri"/>
+                  <a:ea typeface="Calibri"/>
+                  <a:cs typeface="Calibri"/>
+                  <a:sym typeface="Calibri"/>
+                </a:rPr>
+                <a:t>02 </a:t>
+              </a:r>
+              <a:r>
+                <a:rPr b="1" lang="en" sz="1200">
+                  <a:solidFill>
+                    <a:srgbClr val="1A1A1A"/>
+                  </a:solidFill>
+                  <a:latin typeface="Calibri"/>
+                  <a:ea typeface="Calibri"/>
+                  <a:cs typeface="Calibri"/>
+                  <a:sym typeface="Calibri"/>
+                </a:rPr>
+                <a:t>Custom Agent Build</a:t>
+              </a:r>
+              <a:endParaRPr b="1" sz="1300">
+                <a:solidFill>
+                  <a:srgbClr val="0D2B3D"/>
+                </a:solidFill>
+                <a:latin typeface="Calibri"/>
+                <a:ea typeface="Calibri"/>
+                <a:cs typeface="Calibri"/>
+                <a:sym typeface="Calibri"/>
+              </a:endParaRPr>
+            </a:p>
+            <a:p>
+              <a:pPr indent="0" lvl="0" marL="0" rtl="0" algn="l">
+                <a:spcBef>
+                  <a:spcPts val="450"/>
+                </a:spcBef>
+                <a:spcAft>
+                  <a:spcPts val="450"/>
+                </a:spcAft>
+                <a:buNone/>
+              </a:pPr>
+              <a:r>
+                <a:rPr b="0" lang="en" sz="950">
+                  <a:solidFill>
+                    <a:srgbClr val="5A6A7A"/>
+                  </a:solidFill>
+                  <a:latin typeface="Calibri"/>
+                  <a:ea typeface="Calibri"/>
+                  <a:cs typeface="Calibri"/>
+                  <a:sym typeface="Calibri"/>
+                </a:rPr>
+                <a:t>Tailor agents for your needs: Arabic intake, post-visit follow-up, chronic care, home health.</a:t>
+              </a:r>
+              <a:endParaRPr b="0" sz="950">
+                <a:solidFill>
+                  <a:srgbClr val="5A6A7A"/>
+                </a:solidFill>
+                <a:latin typeface="Calibri"/>
+                <a:ea typeface="Calibri"/>
+                <a:cs typeface="Calibri"/>
+                <a:sym typeface="Calibri"/>
+              </a:endParaRPr>
+            </a:p>
+          </p:txBody>
+        </p:sp>
+      </p:grpSp>
+      <p:grpSp>
+        <p:nvGrpSpPr>
+          <p:cNvPr id="361" name="Google Shape;361;p19"/>
+          <p:cNvGrpSpPr/>
+          <p:nvPr/>
+        </p:nvGrpSpPr>
+        <p:grpSpPr>
+          <a:xfrm>
+            <a:off x="347472" y="3383280"/>
+            <a:ext cx="2395728" cy="1115568"/>
+            <a:chOff x="0" y="0"/>
+            <a:chExt cx="2395728" cy="1115568"/>
+          </a:xfrm>
+        </p:grpSpPr>
+        <p:sp>
+          <p:nvSpPr>
+            <p:cNvPr id="362" name="Google Shape;362;p19"/>
+            <p:cNvSpPr/>
+            <p:nvPr/>
+          </p:nvSpPr>
+          <p:spPr>
+            <a:xfrm>
+              <a:off x="0" y="0"/>
+              <a:ext cx="2395728" cy="1115568"/>
+            </a:xfrm>
+            <a:prstGeom prst="roundRect">
+              <a:avLst>
+                <a:gd fmla="val 5217" name="adj"/>
+              </a:avLst>
+            </a:prstGeom>
+            <a:solidFill>
+              <a:srgbClr val="FFFFFF"/>
+            </a:solidFill>
+            <a:ln cap="flat" cmpd="sng" w="9525">
+              <a:solidFill>
+                <a:srgbClr val="C8D0D8"/>
+              </a:solidFill>
+              <a:prstDash val="solid"/>
+              <a:round/>
+              <a:headEnd len="sm" w="sm" type="none"/>
+              <a:tailEnd len="sm" w="sm" type="none"/>
+            </a:ln>
+          </p:spPr>
+          <p:txBody>
+            <a:bodyPr anchorCtr="0" anchor="ctr" bIns="0" lIns="0" spcFirstLastPara="1" rIns="0" wrap="square" tIns="0">
+              <a:noAutofit/>
+            </a:bodyPr>
+            <a:lstStyle/>
+            <a:p>
+              <a:pPr indent="0" lvl="0" marL="0" rtl="0" algn="l">
+                <a:spcBef>
+                  <a:spcPts val="0"/>
+                </a:spcBef>
+                <a:spcAft>
+                  <a:spcPts val="0"/>
+                </a:spcAft>
+                <a:buNone/>
+              </a:pPr>
+              <a:r>
+                <a:t/>
+              </a:r>
+              <a:endParaRPr/>
+            </a:p>
+          </p:txBody>
+        </p:sp>
+        <p:sp>
+          <p:nvSpPr>
+            <p:cNvPr id="363" name="Google Shape;363;p19"/>
+            <p:cNvSpPr/>
+            <p:nvPr/>
+          </p:nvSpPr>
+          <p:spPr>
+            <a:xfrm>
+              <a:off x="0" y="0"/>
+              <a:ext cx="35490" cy="1115568"/>
+            </a:xfrm>
+            <a:prstGeom prst="roundRect">
+              <a:avLst>
+                <a:gd fmla="val 50000" name="adj"/>
+              </a:avLst>
+            </a:prstGeom>
+            <a:solidFill>
+              <a:srgbClr val="0D2B3D"/>
+            </a:solidFill>
+            <a:ln>
+              <a:noFill/>
+            </a:ln>
+          </p:spPr>
+          <p:txBody>
+            <a:bodyPr anchorCtr="0" anchor="ctr" bIns="0" lIns="0" spcFirstLastPara="1" rIns="0" wrap="square" tIns="0">
+              <a:noAutofit/>
+            </a:bodyPr>
+            <a:lstStyle/>
+            <a:p>
+              <a:pPr indent="0" lvl="0" marL="0" rtl="0" algn="l">
+                <a:spcBef>
+                  <a:spcPts val="0"/>
+                </a:spcBef>
+                <a:spcAft>
+                  <a:spcPts val="0"/>
+                </a:spcAft>
+                <a:buNone/>
+              </a:pPr>
+              <a:r>
+                <a:t/>
+              </a:r>
+              <a:endParaRPr/>
+            </a:p>
+          </p:txBody>
+        </p:sp>
+        <p:sp>
+          <p:nvSpPr>
+            <p:cNvPr id="364" name="Google Shape;364;p19"/>
+            <p:cNvSpPr txBox="1"/>
+            <p:nvPr/>
+          </p:nvSpPr>
+          <p:spPr>
+            <a:xfrm>
+              <a:off x="133088" y="116415"/>
+              <a:ext cx="2129411" cy="873265"/>
+            </a:xfrm>
+            <a:prstGeom prst="rect">
+              <a:avLst/>
+            </a:prstGeom>
+            <a:solidFill>
+              <a:srgbClr val="000000">
+                <a:alpha val="0"/>
+              </a:srgbClr>
+            </a:solidFill>
+            <a:ln>
+              <a:noFill/>
+            </a:ln>
+          </p:spPr>
+          <p:txBody>
+            <a:bodyPr anchorCtr="0" anchor="t" bIns="0" lIns="0" spcFirstLastPara="1" rIns="0" wrap="square" tIns="0">
+              <a:noAutofit/>
+            </a:bodyPr>
+            <a:lstStyle/>
+            <a:p>
+              <a:pPr indent="0" lvl="0" marL="0" rtl="0" algn="l">
+                <a:spcBef>
+                  <a:spcPts val="0"/>
+                </a:spcBef>
+                <a:spcAft>
+                  <a:spcPts val="0"/>
+                </a:spcAft>
+                <a:buNone/>
+              </a:pPr>
+              <a:r>
+                <a:rPr b="1" lang="en" sz="1300">
+                  <a:solidFill>
+                    <a:srgbClr val="0D2B3D"/>
+                  </a:solidFill>
+                  <a:latin typeface="Calibri"/>
+                  <a:ea typeface="Calibri"/>
+                  <a:cs typeface="Calibri"/>
+                  <a:sym typeface="Calibri"/>
+                </a:rPr>
+                <a:t>03 </a:t>
+              </a:r>
+              <a:r>
+                <a:rPr b="1" lang="en" sz="1200">
+                  <a:solidFill>
+                    <a:srgbClr val="1A1A1A"/>
+                  </a:solidFill>
+                  <a:latin typeface="Calibri"/>
+                  <a:ea typeface="Calibri"/>
+                  <a:cs typeface="Calibri"/>
+                  <a:sym typeface="Calibri"/>
+                </a:rPr>
+                <a:t>Rigorous Testing</a:t>
+              </a:r>
+              <a:endParaRPr b="1" sz="1300">
+                <a:solidFill>
+                  <a:srgbClr val="0D2B3D"/>
+                </a:solidFill>
+                <a:latin typeface="Calibri"/>
+                <a:ea typeface="Calibri"/>
+                <a:cs typeface="Calibri"/>
+                <a:sym typeface="Calibri"/>
+              </a:endParaRPr>
+            </a:p>
+            <a:p>
+              <a:pPr indent="0" lvl="0" marL="0" rtl="0" algn="l">
+                <a:spcBef>
+                  <a:spcPts val="450"/>
+                </a:spcBef>
+                <a:spcAft>
+                  <a:spcPts val="450"/>
+                </a:spcAft>
+                <a:buNone/>
+              </a:pPr>
+              <a:r>
+                <a:rPr b="0" lang="en" sz="950">
+                  <a:solidFill>
+                    <a:srgbClr val="5A6A7A"/>
+                  </a:solidFill>
+                  <a:latin typeface="Calibri"/>
+                  <a:ea typeface="Calibri"/>
+                  <a:cs typeface="Calibri"/>
+                  <a:sym typeface="Calibri"/>
+                </a:rPr>
+                <a:t>Millions of simulated sessions before launch — accuracy, brand consistency, edge case handling.</a:t>
+              </a:r>
+              <a:endParaRPr b="0" sz="950">
+                <a:solidFill>
+                  <a:srgbClr val="5A6A7A"/>
+                </a:solidFill>
+                <a:latin typeface="Calibri"/>
+                <a:ea typeface="Calibri"/>
+                <a:cs typeface="Calibri"/>
+                <a:sym typeface="Calibri"/>
+              </a:endParaRPr>
+            </a:p>
+          </p:txBody>
+        </p:sp>
+      </p:grpSp>
+      <p:grpSp>
+        <p:nvGrpSpPr>
+          <p:cNvPr id="365" name="Google Shape;365;p19"/>
+          <p:cNvGrpSpPr/>
+          <p:nvPr/>
+        </p:nvGrpSpPr>
+        <p:grpSpPr>
+          <a:xfrm>
+            <a:off x="2907792" y="914400"/>
+            <a:ext cx="2395728" cy="1115568"/>
+            <a:chOff x="0" y="0"/>
+            <a:chExt cx="2395728" cy="1115568"/>
+          </a:xfrm>
+        </p:grpSpPr>
+        <p:sp>
+          <p:nvSpPr>
+            <p:cNvPr id="366" name="Google Shape;366;p19"/>
+            <p:cNvSpPr/>
+            <p:nvPr/>
+          </p:nvSpPr>
+          <p:spPr>
+            <a:xfrm>
+              <a:off x="0" y="0"/>
+              <a:ext cx="2395728" cy="1115568"/>
+            </a:xfrm>
+            <a:prstGeom prst="roundRect">
+              <a:avLst>
+                <a:gd fmla="val 5217" name="adj"/>
+              </a:avLst>
+            </a:prstGeom>
+            <a:solidFill>
+              <a:srgbClr val="FFFFFF"/>
+            </a:solidFill>
+            <a:ln cap="flat" cmpd="sng" w="9525">
+              <a:solidFill>
+                <a:srgbClr val="C8D0D8"/>
+              </a:solidFill>
+              <a:prstDash val="solid"/>
+              <a:round/>
+              <a:headEnd len="sm" w="sm" type="none"/>
+              <a:tailEnd len="sm" w="sm" type="none"/>
+            </a:ln>
+          </p:spPr>
+          <p:txBody>
+            <a:bodyPr anchorCtr="0" anchor="ctr" bIns="0" lIns="0" spcFirstLastPara="1" rIns="0" wrap="square" tIns="0">
+              <a:noAutofit/>
+            </a:bodyPr>
+            <a:lstStyle/>
+            <a:p>
+              <a:pPr indent="0" lvl="0" marL="0" rtl="0" algn="l">
+                <a:spcBef>
+                  <a:spcPts val="0"/>
+                </a:spcBef>
+                <a:spcAft>
+                  <a:spcPts val="0"/>
+                </a:spcAft>
+                <a:buNone/>
+              </a:pPr>
+              <a:r>
+                <a:t/>
+              </a:r>
+              <a:endParaRPr/>
+            </a:p>
+          </p:txBody>
+        </p:sp>
+        <p:sp>
+          <p:nvSpPr>
+            <p:cNvPr id="367" name="Google Shape;367;p19"/>
+            <p:cNvSpPr/>
+            <p:nvPr/>
+          </p:nvSpPr>
+          <p:spPr>
+            <a:xfrm>
+              <a:off x="0" y="0"/>
+              <a:ext cx="35490" cy="1115568"/>
+            </a:xfrm>
+            <a:prstGeom prst="roundRect">
+              <a:avLst>
+                <a:gd fmla="val 50000" name="adj"/>
+              </a:avLst>
+            </a:prstGeom>
+            <a:solidFill>
+              <a:srgbClr val="0D2B3D"/>
+            </a:solidFill>
+            <a:ln>
+              <a:noFill/>
+            </a:ln>
+          </p:spPr>
+          <p:txBody>
+            <a:bodyPr anchorCtr="0" anchor="ctr" bIns="0" lIns="0" spcFirstLastPara="1" rIns="0" wrap="square" tIns="0">
+              <a:noAutofit/>
+            </a:bodyPr>
+            <a:lstStyle/>
+            <a:p>
+              <a:pPr indent="0" lvl="0" marL="0" rtl="0" algn="l">
+                <a:spcBef>
+                  <a:spcPts val="0"/>
+                </a:spcBef>
+                <a:spcAft>
+                  <a:spcPts val="0"/>
+                </a:spcAft>
+                <a:buNone/>
+              </a:pPr>
+              <a:r>
+                <a:t/>
+              </a:r>
+              <a:endParaRPr/>
+            </a:p>
+          </p:txBody>
+        </p:sp>
+        <p:sp>
+          <p:nvSpPr>
+            <p:cNvPr id="368" name="Google Shape;368;p19"/>
+            <p:cNvSpPr txBox="1"/>
+            <p:nvPr/>
+          </p:nvSpPr>
+          <p:spPr>
+            <a:xfrm>
+              <a:off x="133088" y="116415"/>
+              <a:ext cx="2129411" cy="873265"/>
+            </a:xfrm>
+            <a:prstGeom prst="rect">
+              <a:avLst/>
+            </a:prstGeom>
+            <a:solidFill>
+              <a:srgbClr val="000000">
+                <a:alpha val="0"/>
+              </a:srgbClr>
+            </a:solidFill>
+            <a:ln>
+              <a:noFill/>
+            </a:ln>
+          </p:spPr>
+          <p:txBody>
+            <a:bodyPr anchorCtr="0" anchor="t" bIns="0" lIns="0" spcFirstLastPara="1" rIns="0" wrap="square" tIns="0">
+              <a:noAutofit/>
+            </a:bodyPr>
+            <a:lstStyle/>
+            <a:p>
+              <a:pPr indent="0" lvl="0" marL="0" rtl="0" algn="l">
+                <a:spcBef>
+                  <a:spcPts val="0"/>
+                </a:spcBef>
+                <a:spcAft>
+                  <a:spcPts val="0"/>
+                </a:spcAft>
+                <a:buNone/>
+              </a:pPr>
+              <a:r>
+                <a:rPr b="1" lang="en" sz="1300">
+                  <a:solidFill>
+                    <a:srgbClr val="0D2B3D"/>
+                  </a:solidFill>
+                  <a:latin typeface="Calibri"/>
+                  <a:ea typeface="Calibri"/>
+                  <a:cs typeface="Calibri"/>
+                  <a:sym typeface="Calibri"/>
+                </a:rPr>
+                <a:t>04 </a:t>
+              </a:r>
+              <a:r>
+                <a:rPr b="1" lang="en" sz="1200">
+                  <a:solidFill>
+                    <a:srgbClr val="1A1A1A"/>
+                  </a:solidFill>
+                  <a:latin typeface="Calibri"/>
+                  <a:ea typeface="Calibri"/>
+                  <a:cs typeface="Calibri"/>
+                  <a:sym typeface="Calibri"/>
+                </a:rPr>
+                <a:t>Development in 6 Weeks</a:t>
+              </a:r>
+              <a:endParaRPr b="1" sz="1300">
+                <a:solidFill>
+                  <a:srgbClr val="0D2B3D"/>
+                </a:solidFill>
+                <a:latin typeface="Calibri"/>
+                <a:ea typeface="Calibri"/>
+                <a:cs typeface="Calibri"/>
+                <a:sym typeface="Calibri"/>
+              </a:endParaRPr>
+            </a:p>
+            <a:p>
+              <a:pPr indent="0" lvl="0" marL="0" rtl="0" algn="l">
+                <a:spcBef>
+                  <a:spcPts val="450"/>
+                </a:spcBef>
+                <a:spcAft>
+                  <a:spcPts val="450"/>
+                </a:spcAft>
+                <a:buNone/>
+              </a:pPr>
+              <a:r>
+                <a:rPr b="0" lang="en" sz="950">
+                  <a:solidFill>
+                    <a:srgbClr val="5A6A7A"/>
+                  </a:solidFill>
+                  <a:latin typeface="Calibri"/>
+                  <a:ea typeface="Calibri"/>
+                  <a:cs typeface="Calibri"/>
+                  <a:sym typeface="Calibri"/>
+                </a:rPr>
+                <a:t>Full engineering and IT support. Integrate with Fakeeh's YASASII HIS &amp; EHRs. Go live in 6 weeks.</a:t>
+              </a:r>
+              <a:endParaRPr b="0" sz="950">
+                <a:solidFill>
+                  <a:srgbClr val="5A6A7A"/>
+                </a:solidFill>
+                <a:latin typeface="Calibri"/>
+                <a:ea typeface="Calibri"/>
+                <a:cs typeface="Calibri"/>
+                <a:sym typeface="Calibri"/>
+              </a:endParaRPr>
+            </a:p>
+          </p:txBody>
+        </p:sp>
+      </p:grpSp>
+      <p:grpSp>
+        <p:nvGrpSpPr>
+          <p:cNvPr id="369" name="Google Shape;369;p19"/>
+          <p:cNvGrpSpPr/>
+          <p:nvPr/>
+        </p:nvGrpSpPr>
+        <p:grpSpPr>
+          <a:xfrm>
+            <a:off x="2907792" y="2148840"/>
+            <a:ext cx="2395728" cy="1115568"/>
+            <a:chOff x="0" y="0"/>
+            <a:chExt cx="2395728" cy="1115568"/>
+          </a:xfrm>
+        </p:grpSpPr>
+        <p:sp>
+          <p:nvSpPr>
+            <p:cNvPr id="370" name="Google Shape;370;p19"/>
+            <p:cNvSpPr/>
+            <p:nvPr/>
+          </p:nvSpPr>
+          <p:spPr>
+            <a:xfrm>
+              <a:off x="0" y="0"/>
+              <a:ext cx="2395728" cy="1115568"/>
+            </a:xfrm>
+            <a:prstGeom prst="roundRect">
+              <a:avLst>
+                <a:gd fmla="val 5217" name="adj"/>
+              </a:avLst>
+            </a:prstGeom>
+            <a:solidFill>
+              <a:srgbClr val="FFFFFF"/>
+            </a:solidFill>
+            <a:ln cap="flat" cmpd="sng" w="9525">
+              <a:solidFill>
+                <a:srgbClr val="C8D0D8"/>
+              </a:solidFill>
+              <a:prstDash val="solid"/>
+              <a:round/>
+              <a:headEnd len="sm" w="sm" type="none"/>
+              <a:tailEnd len="sm" w="sm" type="none"/>
+            </a:ln>
+          </p:spPr>
+          <p:txBody>
+            <a:bodyPr anchorCtr="0" anchor="ctr" bIns="0" lIns="0" spcFirstLastPara="1" rIns="0" wrap="square" tIns="0">
+              <a:noAutofit/>
+            </a:bodyPr>
+            <a:lstStyle/>
+            <a:p>
+              <a:pPr indent="0" lvl="0" marL="0" rtl="0" algn="l">
+                <a:spcBef>
+                  <a:spcPts val="0"/>
+                </a:spcBef>
+                <a:spcAft>
+                  <a:spcPts val="0"/>
+                </a:spcAft>
+                <a:buNone/>
+              </a:pPr>
+              <a:r>
+                <a:t/>
+              </a:r>
+              <a:endParaRPr/>
+            </a:p>
+          </p:txBody>
+        </p:sp>
+        <p:sp>
+          <p:nvSpPr>
+            <p:cNvPr id="371" name="Google Shape;371;p19"/>
+            <p:cNvSpPr/>
+            <p:nvPr/>
+          </p:nvSpPr>
+          <p:spPr>
+            <a:xfrm>
+              <a:off x="0" y="0"/>
+              <a:ext cx="35490" cy="1115568"/>
+            </a:xfrm>
+            <a:prstGeom prst="roundRect">
+              <a:avLst>
+                <a:gd fmla="val 50000" name="adj"/>
+              </a:avLst>
+            </a:prstGeom>
+            <a:solidFill>
+              <a:srgbClr val="0D2B3D"/>
+            </a:solidFill>
+            <a:ln>
+              <a:noFill/>
+            </a:ln>
+          </p:spPr>
+          <p:txBody>
+            <a:bodyPr anchorCtr="0" anchor="ctr" bIns="0" lIns="0" spcFirstLastPara="1" rIns="0" wrap="square" tIns="0">
+              <a:noAutofit/>
+            </a:bodyPr>
+            <a:lstStyle/>
+            <a:p>
+              <a:pPr indent="0" lvl="0" marL="0" rtl="0" algn="l">
+                <a:spcBef>
+                  <a:spcPts val="0"/>
+                </a:spcBef>
+                <a:spcAft>
+                  <a:spcPts val="0"/>
+                </a:spcAft>
+                <a:buNone/>
+              </a:pPr>
+              <a:r>
+                <a:t/>
+              </a:r>
+              <a:endParaRPr/>
+            </a:p>
+          </p:txBody>
+        </p:sp>
+        <p:sp>
+          <p:nvSpPr>
+            <p:cNvPr id="372" name="Google Shape;372;p19"/>
+            <p:cNvSpPr txBox="1"/>
+            <p:nvPr/>
+          </p:nvSpPr>
+          <p:spPr>
+            <a:xfrm>
+              <a:off x="133088" y="116415"/>
+              <a:ext cx="2129411" cy="873265"/>
+            </a:xfrm>
+            <a:prstGeom prst="rect">
+              <a:avLst/>
+            </a:prstGeom>
+            <a:solidFill>
+              <a:srgbClr val="000000">
+                <a:alpha val="0"/>
+              </a:srgbClr>
+            </a:solidFill>
+            <a:ln>
+              <a:noFill/>
+            </a:ln>
+          </p:spPr>
+          <p:txBody>
+            <a:bodyPr anchorCtr="0" anchor="t" bIns="0" lIns="0" spcFirstLastPara="1" rIns="0" wrap="square" tIns="0">
+              <a:noAutofit/>
+            </a:bodyPr>
+            <a:lstStyle/>
+            <a:p>
+              <a:pPr indent="0" lvl="0" marL="0" rtl="0" algn="l">
+                <a:spcBef>
+                  <a:spcPts val="0"/>
+                </a:spcBef>
+                <a:spcAft>
+                  <a:spcPts val="0"/>
+                </a:spcAft>
+                <a:buNone/>
+              </a:pPr>
+              <a:r>
+                <a:rPr b="1" lang="en" sz="1300">
+                  <a:solidFill>
+                    <a:srgbClr val="0D2B3D"/>
+                  </a:solidFill>
+                  <a:latin typeface="Calibri"/>
+                  <a:ea typeface="Calibri"/>
+                  <a:cs typeface="Calibri"/>
+                  <a:sym typeface="Calibri"/>
+                </a:rPr>
+                <a:t>05 </a:t>
+              </a:r>
+              <a:r>
+                <a:rPr b="1" lang="en" sz="1200">
+                  <a:solidFill>
+                    <a:srgbClr val="1A1A1A"/>
+                  </a:solidFill>
+                  <a:latin typeface="Calibri"/>
+                  <a:ea typeface="Calibri"/>
+                  <a:cs typeface="Calibri"/>
+                  <a:sym typeface="Calibri"/>
+                </a:rPr>
+                <a:t>Monitoring</a:t>
+              </a:r>
+              <a:endParaRPr b="1" sz="1300">
+                <a:solidFill>
+                  <a:srgbClr val="0D2B3D"/>
+                </a:solidFill>
+                <a:latin typeface="Calibri"/>
+                <a:ea typeface="Calibri"/>
+                <a:cs typeface="Calibri"/>
+                <a:sym typeface="Calibri"/>
+              </a:endParaRPr>
+            </a:p>
+            <a:p>
+              <a:pPr indent="0" lvl="0" marL="0" rtl="0" algn="l">
+                <a:spcBef>
+                  <a:spcPts val="450"/>
+                </a:spcBef>
+                <a:spcAft>
+                  <a:spcPts val="450"/>
+                </a:spcAft>
+                <a:buNone/>
+              </a:pPr>
+              <a:r>
+                <a:rPr b="0" lang="en" sz="950">
+                  <a:solidFill>
+                    <a:srgbClr val="5A6A7A"/>
+                  </a:solidFill>
+                  <a:latin typeface="Calibri"/>
+                  <a:ea typeface="Calibri"/>
+                  <a:cs typeface="Calibri"/>
+                  <a:sym typeface="Calibri"/>
+                </a:rPr>
+                <a:t>Continuous monitoring with real-time risk flags, full visibility into agent performance and ROI.</a:t>
+              </a:r>
+              <a:endParaRPr b="0" sz="950">
+                <a:solidFill>
+                  <a:srgbClr val="5A6A7A"/>
+                </a:solidFill>
+                <a:latin typeface="Calibri"/>
+                <a:ea typeface="Calibri"/>
+                <a:cs typeface="Calibri"/>
+                <a:sym typeface="Calibri"/>
+              </a:endParaRPr>
+            </a:p>
+          </p:txBody>
+        </p:sp>
+      </p:grpSp>
+      <p:grpSp>
+        <p:nvGrpSpPr>
+          <p:cNvPr id="373" name="Google Shape;373;p19"/>
+          <p:cNvGrpSpPr/>
+          <p:nvPr/>
+        </p:nvGrpSpPr>
+        <p:grpSpPr>
+          <a:xfrm>
+            <a:off x="2907792" y="3383280"/>
+            <a:ext cx="2395728" cy="1115568"/>
+            <a:chOff x="0" y="0"/>
+            <a:chExt cx="2395728" cy="1115568"/>
+          </a:xfrm>
+        </p:grpSpPr>
+        <p:sp>
+          <p:nvSpPr>
+            <p:cNvPr id="374" name="Google Shape;374;p19"/>
+            <p:cNvSpPr/>
+            <p:nvPr/>
+          </p:nvSpPr>
+          <p:spPr>
+            <a:xfrm>
+              <a:off x="0" y="0"/>
+              <a:ext cx="2395728" cy="1115568"/>
+            </a:xfrm>
+            <a:prstGeom prst="roundRect">
+              <a:avLst>
+                <a:gd fmla="val 5217" name="adj"/>
+              </a:avLst>
+            </a:prstGeom>
+            <a:solidFill>
+              <a:srgbClr val="FFFFFF"/>
+            </a:solidFill>
+            <a:ln cap="flat" cmpd="sng" w="9525">
+              <a:solidFill>
+                <a:srgbClr val="C8D0D8"/>
+              </a:solidFill>
+              <a:prstDash val="solid"/>
+              <a:round/>
+              <a:headEnd len="sm" w="sm" type="none"/>
+              <a:tailEnd len="sm" w="sm" type="none"/>
+            </a:ln>
+          </p:spPr>
+          <p:txBody>
+            <a:bodyPr anchorCtr="0" anchor="ctr" bIns="0" lIns="0" spcFirstLastPara="1" rIns="0" wrap="square" tIns="0">
+              <a:noAutofit/>
+            </a:bodyPr>
+            <a:lstStyle/>
+            <a:p>
+              <a:pPr indent="0" lvl="0" marL="0" rtl="0" algn="l">
+                <a:spcBef>
+                  <a:spcPts val="0"/>
+                </a:spcBef>
+                <a:spcAft>
+                  <a:spcPts val="0"/>
+                </a:spcAft>
+                <a:buNone/>
+              </a:pPr>
+              <a:r>
+                <a:t/>
+              </a:r>
+              <a:endParaRPr/>
+            </a:p>
+          </p:txBody>
+        </p:sp>
+        <p:sp>
+          <p:nvSpPr>
+            <p:cNvPr id="375" name="Google Shape;375;p19"/>
+            <p:cNvSpPr/>
+            <p:nvPr/>
+          </p:nvSpPr>
+          <p:spPr>
+            <a:xfrm>
+              <a:off x="0" y="0"/>
+              <a:ext cx="35490" cy="1115568"/>
+            </a:xfrm>
+            <a:prstGeom prst="roundRect">
+              <a:avLst>
+                <a:gd fmla="val 50000" name="adj"/>
+              </a:avLst>
+            </a:prstGeom>
+            <a:solidFill>
+              <a:srgbClr val="0D2B3D"/>
+            </a:solidFill>
+            <a:ln>
+              <a:noFill/>
+            </a:ln>
+          </p:spPr>
+          <p:txBody>
+            <a:bodyPr anchorCtr="0" anchor="ctr" bIns="0" lIns="0" spcFirstLastPara="1" rIns="0" wrap="square" tIns="0">
+              <a:noAutofit/>
+            </a:bodyPr>
+            <a:lstStyle/>
+            <a:p>
+              <a:pPr indent="0" lvl="0" marL="0" rtl="0" algn="l">
+                <a:spcBef>
+                  <a:spcPts val="0"/>
+                </a:spcBef>
+                <a:spcAft>
+                  <a:spcPts val="0"/>
+                </a:spcAft>
+                <a:buNone/>
+              </a:pPr>
+              <a:r>
+                <a:t/>
+              </a:r>
+              <a:endParaRPr/>
+            </a:p>
+          </p:txBody>
+        </p:sp>
+        <p:sp>
+          <p:nvSpPr>
+            <p:cNvPr id="376" name="Google Shape;376;p19"/>
+            <p:cNvSpPr txBox="1"/>
+            <p:nvPr/>
+          </p:nvSpPr>
+          <p:spPr>
+            <a:xfrm>
+              <a:off x="133088" y="116415"/>
+              <a:ext cx="2129411" cy="873265"/>
+            </a:xfrm>
+            <a:prstGeom prst="rect">
+              <a:avLst/>
+            </a:prstGeom>
+            <a:solidFill>
+              <a:srgbClr val="000000">
+                <a:alpha val="0"/>
+              </a:srgbClr>
+            </a:solidFill>
+            <a:ln>
+              <a:noFill/>
+            </a:ln>
+          </p:spPr>
+          <p:txBody>
+            <a:bodyPr anchorCtr="0" anchor="t" bIns="0" lIns="0" spcFirstLastPara="1" rIns="0" wrap="square" tIns="0">
+              <a:noAutofit/>
+            </a:bodyPr>
+            <a:lstStyle/>
+            <a:p>
+              <a:pPr indent="0" lvl="0" marL="0" rtl="0" algn="l">
+                <a:spcBef>
+                  <a:spcPts val="0"/>
+                </a:spcBef>
+                <a:spcAft>
+                  <a:spcPts val="0"/>
+                </a:spcAft>
+                <a:buNone/>
+              </a:pPr>
+              <a:r>
+                <a:rPr b="1" lang="en" sz="1300">
+                  <a:solidFill>
+                    <a:srgbClr val="0D2B3D"/>
+                  </a:solidFill>
+                  <a:latin typeface="Calibri"/>
+                  <a:ea typeface="Calibri"/>
+                  <a:cs typeface="Calibri"/>
+                  <a:sym typeface="Calibri"/>
+                </a:rPr>
+                <a:t>06 </a:t>
+              </a:r>
+              <a:r>
+                <a:rPr b="1" lang="en" sz="1200">
+                  <a:solidFill>
+                    <a:srgbClr val="1A1A1A"/>
+                  </a:solidFill>
+                  <a:latin typeface="Calibri"/>
+                  <a:ea typeface="Calibri"/>
+                  <a:cs typeface="Calibri"/>
+                  <a:sym typeface="Calibri"/>
+                </a:rPr>
+                <a:t>Continuous Improvement</a:t>
+              </a:r>
+              <a:endParaRPr b="1" sz="1300">
+                <a:solidFill>
+                  <a:srgbClr val="0D2B3D"/>
+                </a:solidFill>
+                <a:latin typeface="Calibri"/>
+                <a:ea typeface="Calibri"/>
+                <a:cs typeface="Calibri"/>
+                <a:sym typeface="Calibri"/>
+              </a:endParaRPr>
+            </a:p>
+            <a:p>
+              <a:pPr indent="0" lvl="0" marL="0" rtl="0" algn="l">
+                <a:spcBef>
+                  <a:spcPts val="450"/>
+                </a:spcBef>
+                <a:spcAft>
+                  <a:spcPts val="450"/>
+                </a:spcAft>
+                <a:buNone/>
+              </a:pPr>
+              <a:r>
+                <a:rPr b="0" lang="en" sz="950">
+                  <a:solidFill>
+                    <a:srgbClr val="5A6A7A"/>
+                  </a:solidFill>
+                  <a:latin typeface="Calibri"/>
+                  <a:ea typeface="Calibri"/>
+                  <a:cs typeface="Calibri"/>
+                  <a:sym typeface="Calibri"/>
+                </a:rPr>
+                <a:t>We refine your agents based on real Fakeeh patient interactions so they get smarter over time.</a:t>
+              </a:r>
+              <a:endParaRPr b="0" sz="950">
+                <a:solidFill>
+                  <a:srgbClr val="5A6A7A"/>
+                </a:solidFill>
+                <a:latin typeface="Calibri"/>
+                <a:ea typeface="Calibri"/>
+                <a:cs typeface="Calibri"/>
+                <a:sym typeface="Calibri"/>
+              </a:endParaRPr>
+            </a:p>
+          </p:txBody>
+        </p:sp>
+      </p:grpSp>
+      <p:sp>
+        <p:nvSpPr>
+          <p:cNvPr id="377" name="Google Shape;377;p19"/>
+          <p:cNvSpPr txBox="1"/>
+          <p:nvPr/>
+        </p:nvSpPr>
+        <p:spPr>
+          <a:xfrm>
+            <a:off x="476250" y="428625"/>
+            <a:ext cx="5715000" cy="400200"/>
+          </a:xfrm>
+          <a:prstGeom prst="rect">
+            <a:avLst/>
+          </a:prstGeom>
+          <a:solidFill>
+            <a:srgbClr val="000000">
+              <a:alpha val="0"/>
+            </a:srgbClr>
+          </a:solidFill>
+          <a:ln>
+            <a:noFill/>
+          </a:ln>
+        </p:spPr>
+        <p:txBody>
+          <a:bodyPr anchorCtr="0" anchor="ctr" bIns="0" lIns="0" spcFirstLastPara="1" rIns="0" wrap="square" tIns="0">
+            <a:spAutoFit/>
+          </a:bodyPr>
+          <a:lstStyle/>
+          <a:p>
+            <a:pPr indent="0" lvl="0" marL="0" rtl="0" algn="l">
+              <a:spcBef>
+                <a:spcPts val="0"/>
+              </a:spcBef>
+              <a:spcAft>
+                <a:spcPts val="0"/>
+              </a:spcAft>
+              <a:buNone/>
+            </a:pPr>
+            <a:r>
+              <a:rPr b="1" lang="en" sz="2600">
+                <a:solidFill>
+                  <a:srgbClr val="0D2B3D"/>
+                </a:solidFill>
+                <a:latin typeface="Calibri"/>
+                <a:ea typeface="Calibri"/>
+                <a:cs typeface="Calibri"/>
+                <a:sym typeface="Calibri"/>
+              </a:rPr>
+              <a:t>Your AI partner, end to end.</a:t>
+            </a:r>
+            <a:endParaRPr b="1" sz="2600">
+              <a:solidFill>
+                <a:srgbClr val="0D2B3D"/>
+              </a:solidFill>
+              <a:latin typeface="Calibri"/>
+              <a:ea typeface="Calibri"/>
+              <a:cs typeface="Calibri"/>
+              <a:sym typeface="Calibri"/>
+            </a:endParaRPr>
+          </a:p>
+        </p:txBody>
+      </p:sp>
+      <p:sp>
+        <p:nvSpPr>
+          <p:cNvPr id="378" name="Google Shape;378;p19"/>
+          <p:cNvSpPr txBox="1"/>
+          <p:nvPr/>
+        </p:nvSpPr>
+        <p:spPr>
+          <a:xfrm>
+            <a:off x="476250" y="857250"/>
+            <a:ext cx="6191400" cy="169200"/>
+          </a:xfrm>
+          <a:prstGeom prst="rect">
+            <a:avLst/>
+          </a:prstGeom>
+          <a:solidFill>
+            <a:srgbClr val="000000">
+              <a:alpha val="0"/>
+            </a:srgbClr>
+          </a:solidFill>
+          <a:ln>
+            <a:noFill/>
+          </a:ln>
+        </p:spPr>
+        <p:txBody>
+          <a:bodyPr anchorCtr="0" anchor="ctr" bIns="0" lIns="0" spcFirstLastPara="1" rIns="0" wrap="square" tIns="0">
+            <a:spAutoFit/>
+          </a:bodyPr>
+          <a:lstStyle/>
+          <a:p>
+            <a:pPr indent="0" lvl="0" marL="0" rtl="0" algn="l">
+              <a:spcBef>
+                <a:spcPts val="0"/>
+              </a:spcBef>
+              <a:spcAft>
+                <a:spcPts val="0"/>
+              </a:spcAft>
+              <a:buNone/>
+            </a:pPr>
+            <a:r>
+              <a:rPr b="0" i="1" lang="en" sz="1100">
+                <a:solidFill>
+                  <a:srgbClr val="5A6A7A"/>
+                </a:solidFill>
+                <a:latin typeface="Calibri"/>
+                <a:ea typeface="Calibri"/>
+                <a:cs typeface="Calibri"/>
+                <a:sym typeface="Calibri"/>
+              </a:rPr>
+              <a:t>From discovery to post-development, our team handles the complexity so you can stay focused on care.</a:t>
+            </a:r>
+            <a:endParaRPr b="0" i="1" sz="1100">
+              <a:solidFill>
+                <a:srgbClr val="5A6A7A"/>
+              </a:solidFill>
+              <a:latin typeface="Calibri"/>
+              <a:ea typeface="Calibri"/>
+              <a:cs typeface="Calibri"/>
+              <a:sym typeface="Calibri"/>
+            </a:endParaRPr>
+          </a:p>
+        </p:txBody>
+      </p:sp>
+      <p:pic>
+        <p:nvPicPr>
+          <p:cNvPr id="379" name="Google Shape;379;p19" title="download.jfif"/>
+          <p:cNvPicPr preferRelativeResize="0"/>
+          <p:nvPr/>
+        </p:nvPicPr>
+        <p:blipFill>
+          <a:blip r:embed="rId2">
+            <a:alphaModFix/>
+          </a:blip>
+          <a:stretch>
+            <a:fillRect/>
+          </a:stretch>
+        </p:blipFill>
+        <p:spPr>
+          <a:xfrm>
+            <a:off x="7941600" y="4628100"/>
+            <a:ext cx="966625" cy="241650"/>
+          </a:xfrm>
+          <a:prstGeom prst="rect">
+            <a:avLst/>
+          </a:prstGeom>
+          <a:noFill/>
+          <a:ln>
+            <a:noFill/>
+          </a:ln>
+        </p:spPr>
+      </p:pic>
+      <p:sp>
+        <p:nvSpPr>
+          <p:cNvPr id="95623560" name="deco_5623560_0"/>
+          <p:cNvSpPr>
+            <a:spLocks noGrp="1"/>
+          </p:cNvSpPr>
+          <p:nvPr/>
+        </p:nvSpPr>
+        <p:spPr>
+          <a:xfrm>
+            <a:off x="5623560" y="0"/>
+            <a:ext cx="3520440" cy="5143500"/>
+          </a:xfrm>
+          <a:prstGeom prst="rect">
+            <a:avLst/>
+          </a:prstGeom>
+          <a:solidFill>
+            <a:srgbClr val="F7F5F0"/>
+          </a:solidFill>
+          <a:ln>
+            <a:noFill/>
+          </a:ln>
+        </p:spPr>
+        <p:txBody>
+          <a:bodyPr/>
+          <a:lstStyle/>
+          <a:p/>
+        </p:txBody>
+      </p:sp>
+      <p:sp>
+        <p:nvSpPr>
+          <p:cNvPr id="96583680" name="deco_6583680_182880"/>
+          <p:cNvSpPr>
+            <a:spLocks noGrp="1"/>
+          </p:cNvSpPr>
+          <p:nvPr/>
+        </p:nvSpPr>
+        <p:spPr>
+          <a:xfrm>
+            <a:off x="6583680" y="182880"/>
+            <a:ext cx="2377440" cy="2286000"/>
+          </a:xfrm>
+          <a:prstGeom prst="rect">
+            <a:avLst/>
+          </a:prstGeom>
+          <a:solidFill>
+            <a:srgbClr val="B44030"/>
+          </a:solidFill>
+          <a:ln>
+            <a:noFill/>
+          </a:ln>
+        </p:spPr>
+        <p:txBody>
+          <a:bodyPr/>
+          <a:lstStyle/>
+          <a:p/>
+        </p:txBody>
+      </p:sp>
+      <p:sp>
+        <p:nvSpPr>
+          <p:cNvPr id="95989320" name="deco_5989320_1097280"/>
+          <p:cNvSpPr>
+            <a:spLocks noGrp="1"/>
+          </p:cNvSpPr>
+          <p:nvPr/>
+        </p:nvSpPr>
+        <p:spPr>
+          <a:xfrm>
+            <a:off x="5989320" y="1097280"/>
+            <a:ext cx="2011680" cy="1828800"/>
+          </a:xfrm>
+          <a:prstGeom prst="rect">
+            <a:avLst/>
+          </a:prstGeom>
+          <a:solidFill>
+            <a:srgbClr val="C85040"/>
+          </a:solidFill>
+          <a:ln>
+            <a:noFill/>
+          </a:ln>
+        </p:spPr>
+        <p:txBody>
+          <a:bodyPr/>
+          <a:lstStyle/>
+          <a:p/>
+        </p:txBody>
+      </p:sp>
+      <p:sp>
+        <p:nvSpPr>
+          <p:cNvPr id="95623560" name="deco_5623560_2194560"/>
+          <p:cNvSpPr>
+            <a:spLocks noGrp="1"/>
+          </p:cNvSpPr>
+          <p:nvPr/>
+        </p:nvSpPr>
+        <p:spPr>
+          <a:xfrm>
+            <a:off x="5623560" y="2194560"/>
+            <a:ext cx="1737360" cy="1645920"/>
+          </a:xfrm>
+          <a:prstGeom prst="rect">
+            <a:avLst/>
+          </a:prstGeom>
+          <a:solidFill>
+            <a:srgbClr val="8A2E22"/>
+          </a:solidFill>
+          <a:ln>
+            <a:noFill/>
+          </a:ln>
+        </p:spPr>
+        <p:txBody>
+          <a:bodyPr/>
+          <a:lstStyle/>
+          <a:p/>
+        </p:txBody>
+      </p:sp>
+      <p:sp>
+        <p:nvSpPr>
+          <p:cNvPr id="95623560" name="deco_5623560_182880"/>
+          <p:cNvSpPr>
+            <a:spLocks noGrp="1"/>
+          </p:cNvSpPr>
+          <p:nvPr/>
+        </p:nvSpPr>
+        <p:spPr>
+          <a:xfrm>
+            <a:off x="5623560" y="182880"/>
+            <a:ext cx="822960" cy="1005840"/>
+          </a:xfrm>
+          <a:prstGeom prst="rect">
+            <a:avLst/>
+          </a:prstGeom>
+          <a:solidFill>
+            <a:srgbClr val="C85040"/>
+          </a:solidFill>
+          <a:ln>
+            <a:noFill/>
+          </a:ln>
+        </p:spPr>
+        <p:txBody>
+          <a:bodyPr/>
+          <a:lstStyle/>
+          <a:p/>
+        </p:txBody>
+      </p:sp>
+      <p:sp>
+        <p:nvSpPr>
+          <p:cNvPr id="95623560" name="deco_5623560_3840480"/>
+          <p:cNvSpPr>
+            <a:spLocks noGrp="1"/>
+          </p:cNvSpPr>
+          <p:nvPr/>
+        </p:nvSpPr>
+        <p:spPr>
+          <a:xfrm>
+            <a:off x="5623560" y="3840480"/>
+            <a:ext cx="3520440" cy="1280160"/>
+          </a:xfrm>
+          <a:prstGeom prst="rect">
+            <a:avLst/>
+          </a:prstGeom>
+          <a:solidFill>
+            <a:srgbClr val="8A2E22"/>
+          </a:solidFill>
+          <a:ln>
+            <a:noFill/>
+          </a:ln>
+        </p:spPr>
+        <p:txBody>
+          <a:bodyPr/>
+          <a:lstStyle/>
+          <a:p/>
+        </p:txBody>
+      </p:sp>
+      <p:sp>
+        <p:nvSpPr>
+          <p:cNvPr id="96858000" name="deco_6858000_2926080"/>
+          <p:cNvSpPr>
+            <a:spLocks noGrp="1"/>
+          </p:cNvSpPr>
+          <p:nvPr/>
+        </p:nvSpPr>
+        <p:spPr>
+          <a:xfrm>
+            <a:off x="6858000" y="2926080"/>
+            <a:ext cx="2286000" cy="1828800"/>
+          </a:xfrm>
+          <a:prstGeom prst="rect">
+            <a:avLst/>
+          </a:prstGeom>
+          <a:solidFill>
+            <a:srgbClr val="D4604E"/>
+          </a:solidFill>
+          <a:ln>
+            <a:noFill/>
+          </a:ln>
+        </p:spPr>
+        <p:txBody>
+          <a:bodyPr/>
+          <a:lstStyle/>
+          <a:p/>
+        </p:txBody>
+      </p:sp>
+    </p:spTree>
+  </p:cSld>
+  <p:clrMapOvr>
+    <a:masterClrMapping/>
+  </p:clrMapOvr>
+</p:sld>
+</file>
+
 <file path=ppt/theme/theme1.xml><?xml version="1.0" encoding="utf-8"?>
 <a:theme xmlns:a="http://schemas.openxmlformats.org/drawingml/2006/main" xmlns:r="http://schemas.openxmlformats.org/officeDocument/2006/relationships">
   <a:themeElements>

</xml_diff>

<commit_message>
Add original slide 7 from source PPTX unchanged as slide 9
</commit_message>
<xml_diff>
--- a/Fakeeh_Care_Group_v2.pptx
+++ b/Fakeeh_Care_Group_v2.pptx
@@ -16,7 +16,7 @@
     <p:sldId id="260" r:id="rId10"/>
     <p:sldId id="261" r:id="rId11"/>
     <p:sldId id="262" r:id="rId12"/>
-    <p:sldId id="264" r:id="rId14"/>
+    <p:sldId id="264" r:id="rId15"/>
   </p:sldIdLst>
   <p:sldSz cy="5143500" cx="9144000"/>
   <p:notesSz cx="6858000" cy="9144000"/>
@@ -27383,29 +27383,6 @@
 <p:sld xmlns:a="http://schemas.openxmlformats.org/drawingml/2006/main" xmlns:p="http://schemas.openxmlformats.org/presentationml/2006/main" xmlns:r="http://schemas.openxmlformats.org/officeDocument/2006/relationships">
   <p:cSld>
     <p:spTree>
-      <p:nvGrpSpPr>
-        <p:cNvPr id="1" name=""/>
-        <p:cNvGrpSpPr/>
-        <p:nvPr/>
-      </p:nvGrpSpPr>
-      <p:grpSpPr/>
-      <p:sp>
-        <p:nvSpPr>
-          <p:cNvPr id="2" name="Title 1"/>
-          <p:cNvSpPr>
-            <a:spLocks noGrp="1"/>
-          </p:cNvSpPr>
-          <p:nvPr>
-            <p:ph type="title"/>
-          </p:nvPr>
-        </p:nvSpPr>
-        <p:spPr/>
-        <p:txBody>
-          <a:bodyPr/>
-          <a:lstStyle/>
-          <a:p/>
-        </p:txBody>
-      </p:sp>
       <p:sp>
         <p:nvSpPr>
           <p:cNvPr id="351" name="Google Shape;351;p19"/>
@@ -27471,7 +27448,7 @@
           </a:ln>
           <a:effectLst>
             <a:outerShdw blurRad="40000" rotWithShape="0" dir="5400000" dist="23000">
-              <a:srgbClr val="F7F5F0">
+              <a:srgbClr val="000000">
                 <a:alpha val="34901"/>
               </a:srgbClr>
             </a:outerShdw>
@@ -27507,10 +27484,10 @@
         </p:nvGrpSpPr>
         <p:grpSpPr>
           <a:xfrm>
-            <a:off x="347472" y="914400"/>
-            <a:ext cx="2395728" cy="1115568"/>
+            <a:off x="476250" y="1333500"/>
+            <a:ext cx="2571900" cy="1095300"/>
             <a:chOff x="0" y="0"/>
-            <a:chExt cx="2395728" cy="1115568"/>
+            <a:chExt cx="2571900" cy="1095300"/>
           </a:xfrm>
         </p:grpSpPr>
         <p:sp>
@@ -27522,7 +27499,7 @@
           <p:spPr>
             <a:xfrm>
               <a:off x="0" y="0"/>
-              <a:ext cx="2395728" cy="1115568"/>
+              <a:ext cx="2571900" cy="1095300"/>
             </a:xfrm>
             <a:prstGeom prst="roundRect">
               <a:avLst>
@@ -27573,7 +27550,7 @@
           <p:spPr>
             <a:xfrm>
               <a:off x="0" y="0"/>
-              <a:ext cx="35490" cy="1115568"/>
+              <a:ext cx="38100" cy="1095300"/>
             </a:xfrm>
             <a:prstGeom prst="roundRect">
               <a:avLst>
@@ -27617,8 +27594,8 @@
           </p:nvSpPr>
           <p:spPr>
             <a:xfrm>
-              <a:off x="133088" y="116415"/>
-              <a:ext cx="2129411" cy="873265"/>
+              <a:off x="142875" y="114300"/>
+              <a:ext cx="2286000" cy="857400"/>
             </a:xfrm>
             <a:prstGeom prst="rect">
               <a:avLst/>
@@ -27724,10 +27701,10 @@
         </p:nvGrpSpPr>
         <p:grpSpPr>
           <a:xfrm>
-            <a:off x="347472" y="2148840"/>
-            <a:ext cx="2395728" cy="1115568"/>
+            <a:off x="3286125" y="1333500"/>
+            <a:ext cx="2571900" cy="1095300"/>
             <a:chOff x="0" y="0"/>
-            <a:chExt cx="2395728" cy="1115568"/>
+            <a:chExt cx="2571900" cy="1095300"/>
           </a:xfrm>
         </p:grpSpPr>
         <p:sp>
@@ -27739,7 +27716,7 @@
           <p:spPr>
             <a:xfrm>
               <a:off x="0" y="0"/>
-              <a:ext cx="2395728" cy="1115568"/>
+              <a:ext cx="2571900" cy="1095300"/>
             </a:xfrm>
             <a:prstGeom prst="roundRect">
               <a:avLst>
@@ -27790,7 +27767,7 @@
           <p:spPr>
             <a:xfrm>
               <a:off x="0" y="0"/>
-              <a:ext cx="35490" cy="1115568"/>
+              <a:ext cx="38100" cy="1095300"/>
             </a:xfrm>
             <a:prstGeom prst="roundRect">
               <a:avLst>
@@ -27834,8 +27811,8 @@
           </p:nvSpPr>
           <p:spPr>
             <a:xfrm>
-              <a:off x="133088" y="116415"/>
-              <a:ext cx="2129411" cy="873265"/>
+              <a:off x="142875" y="114300"/>
+              <a:ext cx="2286000" cy="857400"/>
             </a:xfrm>
             <a:prstGeom prst="rect">
               <a:avLst/>
@@ -27941,10 +27918,10 @@
         </p:nvGrpSpPr>
         <p:grpSpPr>
           <a:xfrm>
-            <a:off x="347472" y="3383280"/>
-            <a:ext cx="2395728" cy="1115568"/>
+            <a:off x="6096000" y="1333500"/>
+            <a:ext cx="2571900" cy="1095300"/>
             <a:chOff x="0" y="0"/>
-            <a:chExt cx="2395728" cy="1115568"/>
+            <a:chExt cx="2571900" cy="1095300"/>
           </a:xfrm>
         </p:grpSpPr>
         <p:sp>
@@ -27956,7 +27933,7 @@
           <p:spPr>
             <a:xfrm>
               <a:off x="0" y="0"/>
-              <a:ext cx="2395728" cy="1115568"/>
+              <a:ext cx="2571900" cy="1095300"/>
             </a:xfrm>
             <a:prstGeom prst="roundRect">
               <a:avLst>
@@ -28007,7 +27984,7 @@
           <p:spPr>
             <a:xfrm>
               <a:off x="0" y="0"/>
-              <a:ext cx="35490" cy="1115568"/>
+              <a:ext cx="38100" cy="1095300"/>
             </a:xfrm>
             <a:prstGeom prst="roundRect">
               <a:avLst>
@@ -28051,8 +28028,8 @@
           </p:nvSpPr>
           <p:spPr>
             <a:xfrm>
-              <a:off x="133088" y="116415"/>
-              <a:ext cx="2129411" cy="873265"/>
+              <a:off x="142875" y="114300"/>
+              <a:ext cx="2286000" cy="857400"/>
             </a:xfrm>
             <a:prstGeom prst="rect">
               <a:avLst/>
@@ -28158,10 +28135,10 @@
         </p:nvGrpSpPr>
         <p:grpSpPr>
           <a:xfrm>
-            <a:off x="2907792" y="914400"/>
-            <a:ext cx="2395728" cy="1115568"/>
+            <a:off x="476250" y="2619375"/>
+            <a:ext cx="2571900" cy="1095300"/>
             <a:chOff x="0" y="0"/>
-            <a:chExt cx="2395728" cy="1115568"/>
+            <a:chExt cx="2571900" cy="1095300"/>
           </a:xfrm>
         </p:grpSpPr>
         <p:sp>
@@ -28173,7 +28150,7 @@
           <p:spPr>
             <a:xfrm>
               <a:off x="0" y="0"/>
-              <a:ext cx="2395728" cy="1115568"/>
+              <a:ext cx="2571900" cy="1095300"/>
             </a:xfrm>
             <a:prstGeom prst="roundRect">
               <a:avLst>
@@ -28224,7 +28201,7 @@
           <p:spPr>
             <a:xfrm>
               <a:off x="0" y="0"/>
-              <a:ext cx="35490" cy="1115568"/>
+              <a:ext cx="38100" cy="1095300"/>
             </a:xfrm>
             <a:prstGeom prst="roundRect">
               <a:avLst>
@@ -28268,8 +28245,8 @@
           </p:nvSpPr>
           <p:spPr>
             <a:xfrm>
-              <a:off x="133088" y="116415"/>
-              <a:ext cx="2129411" cy="873265"/>
+              <a:off x="142875" y="114300"/>
+              <a:ext cx="2286000" cy="857400"/>
             </a:xfrm>
             <a:prstGeom prst="rect">
               <a:avLst/>
@@ -28375,10 +28352,10 @@
         </p:nvGrpSpPr>
         <p:grpSpPr>
           <a:xfrm>
-            <a:off x="2907792" y="2148840"/>
-            <a:ext cx="2395728" cy="1115568"/>
+            <a:off x="3286125" y="2619375"/>
+            <a:ext cx="2571900" cy="1095300"/>
             <a:chOff x="0" y="0"/>
-            <a:chExt cx="2395728" cy="1115568"/>
+            <a:chExt cx="2571900" cy="1095300"/>
           </a:xfrm>
         </p:grpSpPr>
         <p:sp>
@@ -28390,7 +28367,7 @@
           <p:spPr>
             <a:xfrm>
               <a:off x="0" y="0"/>
-              <a:ext cx="2395728" cy="1115568"/>
+              <a:ext cx="2571900" cy="1095300"/>
             </a:xfrm>
             <a:prstGeom prst="roundRect">
               <a:avLst>
@@ -28441,7 +28418,7 @@
           <p:spPr>
             <a:xfrm>
               <a:off x="0" y="0"/>
-              <a:ext cx="35490" cy="1115568"/>
+              <a:ext cx="38100" cy="1095300"/>
             </a:xfrm>
             <a:prstGeom prst="roundRect">
               <a:avLst>
@@ -28485,8 +28462,8 @@
           </p:nvSpPr>
           <p:spPr>
             <a:xfrm>
-              <a:off x="133088" y="116415"/>
-              <a:ext cx="2129411" cy="873265"/>
+              <a:off x="142875" y="114300"/>
+              <a:ext cx="2286000" cy="857400"/>
             </a:xfrm>
             <a:prstGeom prst="rect">
               <a:avLst/>
@@ -28592,10 +28569,10 @@
         </p:nvGrpSpPr>
         <p:grpSpPr>
           <a:xfrm>
-            <a:off x="2907792" y="3383280"/>
-            <a:ext cx="2395728" cy="1115568"/>
+            <a:off x="6096000" y="2619375"/>
+            <a:ext cx="2571900" cy="1095300"/>
             <a:chOff x="0" y="0"/>
-            <a:chExt cx="2395728" cy="1115568"/>
+            <a:chExt cx="2571900" cy="1095300"/>
           </a:xfrm>
         </p:grpSpPr>
         <p:sp>
@@ -28607,7 +28584,7 @@
           <p:spPr>
             <a:xfrm>
               <a:off x="0" y="0"/>
-              <a:ext cx="2395728" cy="1115568"/>
+              <a:ext cx="2571900" cy="1095300"/>
             </a:xfrm>
             <a:prstGeom prst="roundRect">
               <a:avLst>
@@ -28658,7 +28635,7 @@
           <p:spPr>
             <a:xfrm>
               <a:off x="0" y="0"/>
-              <a:ext cx="35490" cy="1115568"/>
+              <a:ext cx="38100" cy="1095300"/>
             </a:xfrm>
             <a:prstGeom prst="roundRect">
               <a:avLst>
@@ -28702,8 +28679,8 @@
           </p:nvSpPr>
           <p:spPr>
             <a:xfrm>
-              <a:off x="133088" y="116415"/>
-              <a:ext cx="2129411" cy="873265"/>
+              <a:off x="142875" y="114300"/>
+              <a:ext cx="2286000" cy="857400"/>
             </a:xfrm>
             <a:prstGeom prst="rect">
               <a:avLst/>
@@ -28911,7 +28888,7 @@
                 <a:cs typeface="Calibri"/>
                 <a:sym typeface="Calibri"/>
               </a:rPr>
-              <a:t>From discovery to post-development, our team handles the complexity so you can stay focused on care.</a:t>
+              <a:t>From discovery to post-development, our team handles the complexity so Fakeeh can stay focused on care.</a:t>
             </a:r>
             <a:endParaRPr b="0" i="1" sz="1100">
               <a:solidFill>
@@ -28953,47 +28930,28 @@
           </a:ln>
         </p:spPr>
       </p:pic>
+    </p:spTree>
+  </p:cSld>
+  <p:clrMapOvr>
+    <a:masterClrMapping/>
+  </p:clrMapOvr>
+</p:sld>
+</file>
+
+<file path=ppt/slides/slide9.xml><?xml version="1.0" encoding="utf-8"?>
+<p:sld xmlns:a="http://schemas.openxmlformats.org/drawingml/2006/main" xmlns:p="http://schemas.openxmlformats.org/presentationml/2006/main" xmlns:r="http://schemas.openxmlformats.org/officeDocument/2006/relationships">
+  <p:cSld>
+    <p:spTree>
       <p:sp>
         <p:nvSpPr>
-          <p:cNvPr id="95623560" name="deco_5623560_0"/>
-          <p:cNvSpPr>
-            <a:spLocks noGrp="1"/>
-          </p:cNvSpPr>
+          <p:cNvPr id="351" name="Google Shape;351;p19"/>
+          <p:cNvSpPr/>
           <p:nvPr/>
         </p:nvSpPr>
         <p:spPr>
           <a:xfrm>
-            <a:off x="5623560" y="0"/>
-            <a:ext cx="3520440" cy="5143500"/>
-          </a:xfrm>
-          <a:prstGeom prst="rect">
-            <a:avLst/>
-          </a:prstGeom>
-          <a:solidFill>
-            <a:srgbClr val="F7F5F0"/>
-          </a:solidFill>
-          <a:ln>
-            <a:noFill/>
-          </a:ln>
-        </p:spPr>
-        <p:txBody>
-          <a:bodyPr/>
-          <a:lstStyle/>
-          <a:p/>
-        </p:txBody>
-      </p:sp>
-      <p:sp>
-        <p:nvSpPr>
-          <p:cNvPr id="96583680" name="deco_6583680_182880"/>
-          <p:cNvSpPr>
-            <a:spLocks noGrp="1"/>
-          </p:cNvSpPr>
-          <p:nvPr/>
-        </p:nvSpPr>
-        <p:spPr>
-          <a:xfrm>
-            <a:off x="6583680" y="182880"/>
-            <a:ext cx="2377440" cy="2286000"/>
+            <a:off x="0" y="0"/>
+            <a:ext cx="9144000" cy="41100"/>
           </a:xfrm>
           <a:prstGeom prst="rect">
             <a:avLst/>
@@ -29006,156 +28964,1531 @@
           </a:ln>
         </p:spPr>
         <p:txBody>
-          <a:bodyPr/>
+          <a:bodyPr anchorCtr="0" anchor="ctr" bIns="0" lIns="0" spcFirstLastPara="1" rIns="0" wrap="square" tIns="0">
+            <a:noAutofit/>
+          </a:bodyPr>
           <a:lstStyle/>
-          <a:p/>
+          <a:p>
+            <a:pPr indent="0" lvl="0" marL="0" rtl="0" algn="l">
+              <a:spcBef>
+                <a:spcPts val="0"/>
+              </a:spcBef>
+              <a:spcAft>
+                <a:spcPts val="0"/>
+              </a:spcAft>
+              <a:buNone/>
+            </a:pPr>
+            <a:r>
+              <a:t/>
+            </a:r>
+            <a:endParaRPr/>
+          </a:p>
         </p:txBody>
       </p:sp>
       <p:sp>
         <p:nvSpPr>
-          <p:cNvPr id="95989320" name="deco_5989320_1097280"/>
-          <p:cNvSpPr>
-            <a:spLocks noGrp="1"/>
-          </p:cNvSpPr>
+          <p:cNvPr id="352" name="Google Shape;352;p19"/>
+          <p:cNvSpPr/>
           <p:nvPr/>
         </p:nvSpPr>
         <p:spPr>
           <a:xfrm>
-            <a:off x="5989320" y="1097280"/>
-            <a:ext cx="2011680" cy="1828800"/>
+            <a:off x="0" y="0"/>
+            <a:ext cx="9144000" cy="5143500"/>
           </a:xfrm>
           <a:prstGeom prst="rect">
             <a:avLst/>
           </a:prstGeom>
           <a:solidFill>
-            <a:srgbClr val="C85040"/>
+            <a:srgbClr val="F7F5F0"/>
+          </a:solidFill>
+          <a:ln>
+            <a:noFill/>
+          </a:ln>
+          <a:effectLst>
+            <a:outerShdw blurRad="40000" rotWithShape="0" dir="5400000" dist="23000">
+              <a:srgbClr val="000000">
+                <a:alpha val="34901"/>
+              </a:srgbClr>
+            </a:outerShdw>
+          </a:effectLst>
+        </p:spPr>
+        <p:txBody>
+          <a:bodyPr anchorCtr="0" anchor="ctr" bIns="0" lIns="0" spcFirstLastPara="1" rIns="0" wrap="square" tIns="0">
+            <a:noAutofit/>
+          </a:bodyPr>
+          <a:lstStyle/>
+          <a:p>
+            <a:pPr indent="0" lvl="0" marL="0" rtl="0" algn="l">
+              <a:spcBef>
+                <a:spcPts val="0"/>
+              </a:spcBef>
+              <a:spcAft>
+                <a:spcPts val="0"/>
+              </a:spcAft>
+              <a:buNone/>
+            </a:pPr>
+            <a:r>
+              <a:t/>
+            </a:r>
+            <a:endParaRPr/>
+          </a:p>
+        </p:txBody>
+      </p:sp>
+      <p:grpSp>
+        <p:nvGrpSpPr>
+          <p:cNvPr id="353" name="Google Shape;353;p19"/>
+          <p:cNvGrpSpPr/>
+          <p:nvPr/>
+        </p:nvGrpSpPr>
+        <p:grpSpPr>
+          <a:xfrm>
+            <a:off x="476250" y="1333500"/>
+            <a:ext cx="2571900" cy="1095300"/>
+            <a:chOff x="0" y="0"/>
+            <a:chExt cx="2571900" cy="1095300"/>
+          </a:xfrm>
+        </p:grpSpPr>
+        <p:sp>
+          <p:nvSpPr>
+            <p:cNvPr id="354" name="Google Shape;354;p19"/>
+            <p:cNvSpPr/>
+            <p:nvPr/>
+          </p:nvSpPr>
+          <p:spPr>
+            <a:xfrm>
+              <a:off x="0" y="0"/>
+              <a:ext cx="2571900" cy="1095300"/>
+            </a:xfrm>
+            <a:prstGeom prst="roundRect">
+              <a:avLst>
+                <a:gd fmla="val 5217" name="adj"/>
+              </a:avLst>
+            </a:prstGeom>
+            <a:solidFill>
+              <a:srgbClr val="FFFFFF"/>
+            </a:solidFill>
+            <a:ln cap="flat" cmpd="sng" w="9525">
+              <a:solidFill>
+                <a:srgbClr val="C8D0D8"/>
+              </a:solidFill>
+              <a:prstDash val="solid"/>
+              <a:round/>
+              <a:headEnd len="sm" w="sm" type="none"/>
+              <a:tailEnd len="sm" w="sm" type="none"/>
+            </a:ln>
+          </p:spPr>
+          <p:txBody>
+            <a:bodyPr anchorCtr="0" anchor="ctr" bIns="0" lIns="0" spcFirstLastPara="1" rIns="0" wrap="square" tIns="0">
+              <a:noAutofit/>
+            </a:bodyPr>
+            <a:lstStyle/>
+            <a:p>
+              <a:pPr indent="0" lvl="0" marL="0" rtl="0" algn="l">
+                <a:spcBef>
+                  <a:spcPts val="0"/>
+                </a:spcBef>
+                <a:spcAft>
+                  <a:spcPts val="0"/>
+                </a:spcAft>
+                <a:buNone/>
+              </a:pPr>
+              <a:r>
+                <a:t/>
+              </a:r>
+              <a:endParaRPr/>
+            </a:p>
+          </p:txBody>
+        </p:sp>
+        <p:sp>
+          <p:nvSpPr>
+            <p:cNvPr id="355" name="Google Shape;355;p19"/>
+            <p:cNvSpPr/>
+            <p:nvPr/>
+          </p:nvSpPr>
+          <p:spPr>
+            <a:xfrm>
+              <a:off x="0" y="0"/>
+              <a:ext cx="38100" cy="1095300"/>
+            </a:xfrm>
+            <a:prstGeom prst="roundRect">
+              <a:avLst>
+                <a:gd fmla="val 50000" name="adj"/>
+              </a:avLst>
+            </a:prstGeom>
+            <a:solidFill>
+              <a:srgbClr val="0D2B3D"/>
+            </a:solidFill>
+            <a:ln>
+              <a:noFill/>
+            </a:ln>
+          </p:spPr>
+          <p:txBody>
+            <a:bodyPr anchorCtr="0" anchor="ctr" bIns="0" lIns="0" spcFirstLastPara="1" rIns="0" wrap="square" tIns="0">
+              <a:noAutofit/>
+            </a:bodyPr>
+            <a:lstStyle/>
+            <a:p>
+              <a:pPr indent="0" lvl="0" marL="0" rtl="0" algn="l">
+                <a:spcBef>
+                  <a:spcPts val="0"/>
+                </a:spcBef>
+                <a:spcAft>
+                  <a:spcPts val="0"/>
+                </a:spcAft>
+                <a:buNone/>
+              </a:pPr>
+              <a:r>
+                <a:t/>
+              </a:r>
+              <a:endParaRPr/>
+            </a:p>
+          </p:txBody>
+        </p:sp>
+        <p:sp>
+          <p:nvSpPr>
+            <p:cNvPr id="356" name="Google Shape;356;p19"/>
+            <p:cNvSpPr txBox="1"/>
+            <p:nvPr/>
+          </p:nvSpPr>
+          <p:spPr>
+            <a:xfrm>
+              <a:off x="142875" y="114300"/>
+              <a:ext cx="2286000" cy="857400"/>
+            </a:xfrm>
+            <a:prstGeom prst="rect">
+              <a:avLst/>
+            </a:prstGeom>
+            <a:solidFill>
+              <a:srgbClr val="000000">
+                <a:alpha val="0"/>
+              </a:srgbClr>
+            </a:solidFill>
+            <a:ln>
+              <a:noFill/>
+            </a:ln>
+          </p:spPr>
+          <p:txBody>
+            <a:bodyPr anchorCtr="0" anchor="t" bIns="0" lIns="0" spcFirstLastPara="1" rIns="0" wrap="square" tIns="0">
+              <a:noAutofit/>
+            </a:bodyPr>
+            <a:lstStyle/>
+            <a:p>
+              <a:pPr indent="0" lvl="0" marL="0" rtl="0" algn="l">
+                <a:spcBef>
+                  <a:spcPts val="0"/>
+                </a:spcBef>
+                <a:spcAft>
+                  <a:spcPts val="0"/>
+                </a:spcAft>
+                <a:buNone/>
+              </a:pPr>
+              <a:r>
+                <a:rPr b="1" lang="en" sz="1300">
+                  <a:solidFill>
+                    <a:srgbClr val="0D2B3D"/>
+                  </a:solidFill>
+                  <a:latin typeface="Calibri"/>
+                  <a:ea typeface="Calibri"/>
+                  <a:cs typeface="Calibri"/>
+                  <a:sym typeface="Calibri"/>
+                </a:rPr>
+                <a:t>01 </a:t>
+              </a:r>
+              <a:r>
+                <a:rPr b="1" lang="en" sz="1200">
+                  <a:solidFill>
+                    <a:srgbClr val="1A1A1A"/>
+                  </a:solidFill>
+                  <a:latin typeface="Calibri"/>
+                  <a:ea typeface="Calibri"/>
+                  <a:cs typeface="Calibri"/>
+                  <a:sym typeface="Calibri"/>
+                </a:rPr>
+                <a:t>Discovery</a:t>
+              </a:r>
+              <a:endParaRPr b="1" sz="1300">
+                <a:solidFill>
+                  <a:srgbClr val="0D2B3D"/>
+                </a:solidFill>
+                <a:latin typeface="Calibri"/>
+                <a:ea typeface="Calibri"/>
+                <a:cs typeface="Calibri"/>
+                <a:sym typeface="Calibri"/>
+              </a:endParaRPr>
+            </a:p>
+            <a:p>
+              <a:pPr indent="0" lvl="0" marL="0" rtl="0" algn="l">
+                <a:spcBef>
+                  <a:spcPts val="450"/>
+                </a:spcBef>
+                <a:spcAft>
+                  <a:spcPts val="450"/>
+                </a:spcAft>
+                <a:buNone/>
+              </a:pPr>
+              <a:r>
+                <a:rPr b="0" lang="en" sz="950">
+                  <a:solidFill>
+                    <a:srgbClr val="5A6A7A"/>
+                  </a:solidFill>
+                  <a:latin typeface="Calibri"/>
+                  <a:ea typeface="Calibri"/>
+                  <a:cs typeface="Calibri"/>
+                  <a:sym typeface="Calibri"/>
+                </a:rPr>
+                <a:t>We deeply understand Fakeeh's unique workflows and goals — not pre-built templates.</a:t>
+              </a:r>
+              <a:endParaRPr b="0" sz="950">
+                <a:solidFill>
+                  <a:srgbClr val="5A6A7A"/>
+                </a:solidFill>
+                <a:latin typeface="Calibri"/>
+                <a:ea typeface="Calibri"/>
+                <a:cs typeface="Calibri"/>
+                <a:sym typeface="Calibri"/>
+              </a:endParaRPr>
+            </a:p>
+          </p:txBody>
+        </p:sp>
+      </p:grpSp>
+      <p:grpSp>
+        <p:nvGrpSpPr>
+          <p:cNvPr id="357" name="Google Shape;357;p19"/>
+          <p:cNvGrpSpPr/>
+          <p:nvPr/>
+        </p:nvGrpSpPr>
+        <p:grpSpPr>
+          <a:xfrm>
+            <a:off x="3286125" y="1333500"/>
+            <a:ext cx="2571900" cy="1095300"/>
+            <a:chOff x="0" y="0"/>
+            <a:chExt cx="2571900" cy="1095300"/>
+          </a:xfrm>
+        </p:grpSpPr>
+        <p:sp>
+          <p:nvSpPr>
+            <p:cNvPr id="358" name="Google Shape;358;p19"/>
+            <p:cNvSpPr/>
+            <p:nvPr/>
+          </p:nvSpPr>
+          <p:spPr>
+            <a:xfrm>
+              <a:off x="0" y="0"/>
+              <a:ext cx="2571900" cy="1095300"/>
+            </a:xfrm>
+            <a:prstGeom prst="roundRect">
+              <a:avLst>
+                <a:gd fmla="val 5217" name="adj"/>
+              </a:avLst>
+            </a:prstGeom>
+            <a:solidFill>
+              <a:srgbClr val="FFFFFF"/>
+            </a:solidFill>
+            <a:ln cap="flat" cmpd="sng" w="9525">
+              <a:solidFill>
+                <a:srgbClr val="C8D0D8"/>
+              </a:solidFill>
+              <a:prstDash val="solid"/>
+              <a:round/>
+              <a:headEnd len="sm" w="sm" type="none"/>
+              <a:tailEnd len="sm" w="sm" type="none"/>
+            </a:ln>
+          </p:spPr>
+          <p:txBody>
+            <a:bodyPr anchorCtr="0" anchor="ctr" bIns="0" lIns="0" spcFirstLastPara="1" rIns="0" wrap="square" tIns="0">
+              <a:noAutofit/>
+            </a:bodyPr>
+            <a:lstStyle/>
+            <a:p>
+              <a:pPr indent="0" lvl="0" marL="0" rtl="0" algn="l">
+                <a:spcBef>
+                  <a:spcPts val="0"/>
+                </a:spcBef>
+                <a:spcAft>
+                  <a:spcPts val="0"/>
+                </a:spcAft>
+                <a:buNone/>
+              </a:pPr>
+              <a:r>
+                <a:t/>
+              </a:r>
+              <a:endParaRPr/>
+            </a:p>
+          </p:txBody>
+        </p:sp>
+        <p:sp>
+          <p:nvSpPr>
+            <p:cNvPr id="359" name="Google Shape;359;p19"/>
+            <p:cNvSpPr/>
+            <p:nvPr/>
+          </p:nvSpPr>
+          <p:spPr>
+            <a:xfrm>
+              <a:off x="0" y="0"/>
+              <a:ext cx="38100" cy="1095300"/>
+            </a:xfrm>
+            <a:prstGeom prst="roundRect">
+              <a:avLst>
+                <a:gd fmla="val 50000" name="adj"/>
+              </a:avLst>
+            </a:prstGeom>
+            <a:solidFill>
+              <a:srgbClr val="0D2B3D"/>
+            </a:solidFill>
+            <a:ln>
+              <a:noFill/>
+            </a:ln>
+          </p:spPr>
+          <p:txBody>
+            <a:bodyPr anchorCtr="0" anchor="ctr" bIns="0" lIns="0" spcFirstLastPara="1" rIns="0" wrap="square" tIns="0">
+              <a:noAutofit/>
+            </a:bodyPr>
+            <a:lstStyle/>
+            <a:p>
+              <a:pPr indent="0" lvl="0" marL="0" rtl="0" algn="l">
+                <a:spcBef>
+                  <a:spcPts val="0"/>
+                </a:spcBef>
+                <a:spcAft>
+                  <a:spcPts val="0"/>
+                </a:spcAft>
+                <a:buNone/>
+              </a:pPr>
+              <a:r>
+                <a:t/>
+              </a:r>
+              <a:endParaRPr/>
+            </a:p>
+          </p:txBody>
+        </p:sp>
+        <p:sp>
+          <p:nvSpPr>
+            <p:cNvPr id="360" name="Google Shape;360;p19"/>
+            <p:cNvSpPr txBox="1"/>
+            <p:nvPr/>
+          </p:nvSpPr>
+          <p:spPr>
+            <a:xfrm>
+              <a:off x="142875" y="114300"/>
+              <a:ext cx="2286000" cy="857400"/>
+            </a:xfrm>
+            <a:prstGeom prst="rect">
+              <a:avLst/>
+            </a:prstGeom>
+            <a:solidFill>
+              <a:srgbClr val="000000">
+                <a:alpha val="0"/>
+              </a:srgbClr>
+            </a:solidFill>
+            <a:ln>
+              <a:noFill/>
+            </a:ln>
+          </p:spPr>
+          <p:txBody>
+            <a:bodyPr anchorCtr="0" anchor="t" bIns="0" lIns="0" spcFirstLastPara="1" rIns="0" wrap="square" tIns="0">
+              <a:noAutofit/>
+            </a:bodyPr>
+            <a:lstStyle/>
+            <a:p>
+              <a:pPr indent="0" lvl="0" marL="0" rtl="0" algn="l">
+                <a:spcBef>
+                  <a:spcPts val="0"/>
+                </a:spcBef>
+                <a:spcAft>
+                  <a:spcPts val="0"/>
+                </a:spcAft>
+                <a:buNone/>
+              </a:pPr>
+              <a:r>
+                <a:rPr b="1" lang="en" sz="1300">
+                  <a:solidFill>
+                    <a:srgbClr val="0D2B3D"/>
+                  </a:solidFill>
+                  <a:latin typeface="Calibri"/>
+                  <a:ea typeface="Calibri"/>
+                  <a:cs typeface="Calibri"/>
+                  <a:sym typeface="Calibri"/>
+                </a:rPr>
+                <a:t>02 </a:t>
+              </a:r>
+              <a:r>
+                <a:rPr b="1" lang="en" sz="1200">
+                  <a:solidFill>
+                    <a:srgbClr val="1A1A1A"/>
+                  </a:solidFill>
+                  <a:latin typeface="Calibri"/>
+                  <a:ea typeface="Calibri"/>
+                  <a:cs typeface="Calibri"/>
+                  <a:sym typeface="Calibri"/>
+                </a:rPr>
+                <a:t>Custom Agent Build</a:t>
+              </a:r>
+              <a:endParaRPr b="1" sz="1300">
+                <a:solidFill>
+                  <a:srgbClr val="0D2B3D"/>
+                </a:solidFill>
+                <a:latin typeface="Calibri"/>
+                <a:ea typeface="Calibri"/>
+                <a:cs typeface="Calibri"/>
+                <a:sym typeface="Calibri"/>
+              </a:endParaRPr>
+            </a:p>
+            <a:p>
+              <a:pPr indent="0" lvl="0" marL="0" rtl="0" algn="l">
+                <a:spcBef>
+                  <a:spcPts val="450"/>
+                </a:spcBef>
+                <a:spcAft>
+                  <a:spcPts val="450"/>
+                </a:spcAft>
+                <a:buNone/>
+              </a:pPr>
+              <a:r>
+                <a:rPr b="0" lang="en" sz="950">
+                  <a:solidFill>
+                    <a:srgbClr val="5A6A7A"/>
+                  </a:solidFill>
+                  <a:latin typeface="Calibri"/>
+                  <a:ea typeface="Calibri"/>
+                  <a:cs typeface="Calibri"/>
+                  <a:sym typeface="Calibri"/>
+                </a:rPr>
+                <a:t>Tailor agents for your needs: Arabic intake, post-visit follow-up, chronic care, home health.</a:t>
+              </a:r>
+              <a:endParaRPr b="0" sz="950">
+                <a:solidFill>
+                  <a:srgbClr val="5A6A7A"/>
+                </a:solidFill>
+                <a:latin typeface="Calibri"/>
+                <a:ea typeface="Calibri"/>
+                <a:cs typeface="Calibri"/>
+                <a:sym typeface="Calibri"/>
+              </a:endParaRPr>
+            </a:p>
+          </p:txBody>
+        </p:sp>
+      </p:grpSp>
+      <p:grpSp>
+        <p:nvGrpSpPr>
+          <p:cNvPr id="361" name="Google Shape;361;p19"/>
+          <p:cNvGrpSpPr/>
+          <p:nvPr/>
+        </p:nvGrpSpPr>
+        <p:grpSpPr>
+          <a:xfrm>
+            <a:off x="6096000" y="1333500"/>
+            <a:ext cx="2571900" cy="1095300"/>
+            <a:chOff x="0" y="0"/>
+            <a:chExt cx="2571900" cy="1095300"/>
+          </a:xfrm>
+        </p:grpSpPr>
+        <p:sp>
+          <p:nvSpPr>
+            <p:cNvPr id="362" name="Google Shape;362;p19"/>
+            <p:cNvSpPr/>
+            <p:nvPr/>
+          </p:nvSpPr>
+          <p:spPr>
+            <a:xfrm>
+              <a:off x="0" y="0"/>
+              <a:ext cx="2571900" cy="1095300"/>
+            </a:xfrm>
+            <a:prstGeom prst="roundRect">
+              <a:avLst>
+                <a:gd fmla="val 5217" name="adj"/>
+              </a:avLst>
+            </a:prstGeom>
+            <a:solidFill>
+              <a:srgbClr val="FFFFFF"/>
+            </a:solidFill>
+            <a:ln cap="flat" cmpd="sng" w="9525">
+              <a:solidFill>
+                <a:srgbClr val="C8D0D8"/>
+              </a:solidFill>
+              <a:prstDash val="solid"/>
+              <a:round/>
+              <a:headEnd len="sm" w="sm" type="none"/>
+              <a:tailEnd len="sm" w="sm" type="none"/>
+            </a:ln>
+          </p:spPr>
+          <p:txBody>
+            <a:bodyPr anchorCtr="0" anchor="ctr" bIns="0" lIns="0" spcFirstLastPara="1" rIns="0" wrap="square" tIns="0">
+              <a:noAutofit/>
+            </a:bodyPr>
+            <a:lstStyle/>
+            <a:p>
+              <a:pPr indent="0" lvl="0" marL="0" rtl="0" algn="l">
+                <a:spcBef>
+                  <a:spcPts val="0"/>
+                </a:spcBef>
+                <a:spcAft>
+                  <a:spcPts val="0"/>
+                </a:spcAft>
+                <a:buNone/>
+              </a:pPr>
+              <a:r>
+                <a:t/>
+              </a:r>
+              <a:endParaRPr/>
+            </a:p>
+          </p:txBody>
+        </p:sp>
+        <p:sp>
+          <p:nvSpPr>
+            <p:cNvPr id="363" name="Google Shape;363;p19"/>
+            <p:cNvSpPr/>
+            <p:nvPr/>
+          </p:nvSpPr>
+          <p:spPr>
+            <a:xfrm>
+              <a:off x="0" y="0"/>
+              <a:ext cx="38100" cy="1095300"/>
+            </a:xfrm>
+            <a:prstGeom prst="roundRect">
+              <a:avLst>
+                <a:gd fmla="val 50000" name="adj"/>
+              </a:avLst>
+            </a:prstGeom>
+            <a:solidFill>
+              <a:srgbClr val="0D2B3D"/>
+            </a:solidFill>
+            <a:ln>
+              <a:noFill/>
+            </a:ln>
+          </p:spPr>
+          <p:txBody>
+            <a:bodyPr anchorCtr="0" anchor="ctr" bIns="0" lIns="0" spcFirstLastPara="1" rIns="0" wrap="square" tIns="0">
+              <a:noAutofit/>
+            </a:bodyPr>
+            <a:lstStyle/>
+            <a:p>
+              <a:pPr indent="0" lvl="0" marL="0" rtl="0" algn="l">
+                <a:spcBef>
+                  <a:spcPts val="0"/>
+                </a:spcBef>
+                <a:spcAft>
+                  <a:spcPts val="0"/>
+                </a:spcAft>
+                <a:buNone/>
+              </a:pPr>
+              <a:r>
+                <a:t/>
+              </a:r>
+              <a:endParaRPr/>
+            </a:p>
+          </p:txBody>
+        </p:sp>
+        <p:sp>
+          <p:nvSpPr>
+            <p:cNvPr id="364" name="Google Shape;364;p19"/>
+            <p:cNvSpPr txBox="1"/>
+            <p:nvPr/>
+          </p:nvSpPr>
+          <p:spPr>
+            <a:xfrm>
+              <a:off x="142875" y="114300"/>
+              <a:ext cx="2286000" cy="857400"/>
+            </a:xfrm>
+            <a:prstGeom prst="rect">
+              <a:avLst/>
+            </a:prstGeom>
+            <a:solidFill>
+              <a:srgbClr val="000000">
+                <a:alpha val="0"/>
+              </a:srgbClr>
+            </a:solidFill>
+            <a:ln>
+              <a:noFill/>
+            </a:ln>
+          </p:spPr>
+          <p:txBody>
+            <a:bodyPr anchorCtr="0" anchor="t" bIns="0" lIns="0" spcFirstLastPara="1" rIns="0" wrap="square" tIns="0">
+              <a:noAutofit/>
+            </a:bodyPr>
+            <a:lstStyle/>
+            <a:p>
+              <a:pPr indent="0" lvl="0" marL="0" rtl="0" algn="l">
+                <a:spcBef>
+                  <a:spcPts val="0"/>
+                </a:spcBef>
+                <a:spcAft>
+                  <a:spcPts val="0"/>
+                </a:spcAft>
+                <a:buNone/>
+              </a:pPr>
+              <a:r>
+                <a:rPr b="1" lang="en" sz="1300">
+                  <a:solidFill>
+                    <a:srgbClr val="0D2B3D"/>
+                  </a:solidFill>
+                  <a:latin typeface="Calibri"/>
+                  <a:ea typeface="Calibri"/>
+                  <a:cs typeface="Calibri"/>
+                  <a:sym typeface="Calibri"/>
+                </a:rPr>
+                <a:t>03 </a:t>
+              </a:r>
+              <a:r>
+                <a:rPr b="1" lang="en" sz="1200">
+                  <a:solidFill>
+                    <a:srgbClr val="1A1A1A"/>
+                  </a:solidFill>
+                  <a:latin typeface="Calibri"/>
+                  <a:ea typeface="Calibri"/>
+                  <a:cs typeface="Calibri"/>
+                  <a:sym typeface="Calibri"/>
+                </a:rPr>
+                <a:t>Rigorous Testing</a:t>
+              </a:r>
+              <a:endParaRPr b="1" sz="1300">
+                <a:solidFill>
+                  <a:srgbClr val="0D2B3D"/>
+                </a:solidFill>
+                <a:latin typeface="Calibri"/>
+                <a:ea typeface="Calibri"/>
+                <a:cs typeface="Calibri"/>
+                <a:sym typeface="Calibri"/>
+              </a:endParaRPr>
+            </a:p>
+            <a:p>
+              <a:pPr indent="0" lvl="0" marL="0" rtl="0" algn="l">
+                <a:spcBef>
+                  <a:spcPts val="450"/>
+                </a:spcBef>
+                <a:spcAft>
+                  <a:spcPts val="450"/>
+                </a:spcAft>
+                <a:buNone/>
+              </a:pPr>
+              <a:r>
+                <a:rPr b="0" lang="en" sz="950">
+                  <a:solidFill>
+                    <a:srgbClr val="5A6A7A"/>
+                  </a:solidFill>
+                  <a:latin typeface="Calibri"/>
+                  <a:ea typeface="Calibri"/>
+                  <a:cs typeface="Calibri"/>
+                  <a:sym typeface="Calibri"/>
+                </a:rPr>
+                <a:t>Millions of simulated sessions before launch — accuracy, brand consistency, edge case handling.</a:t>
+              </a:r>
+              <a:endParaRPr b="0" sz="950">
+                <a:solidFill>
+                  <a:srgbClr val="5A6A7A"/>
+                </a:solidFill>
+                <a:latin typeface="Calibri"/>
+                <a:ea typeface="Calibri"/>
+                <a:cs typeface="Calibri"/>
+                <a:sym typeface="Calibri"/>
+              </a:endParaRPr>
+            </a:p>
+          </p:txBody>
+        </p:sp>
+      </p:grpSp>
+      <p:grpSp>
+        <p:nvGrpSpPr>
+          <p:cNvPr id="365" name="Google Shape;365;p19"/>
+          <p:cNvGrpSpPr/>
+          <p:nvPr/>
+        </p:nvGrpSpPr>
+        <p:grpSpPr>
+          <a:xfrm>
+            <a:off x="476250" y="2619375"/>
+            <a:ext cx="2571900" cy="1095300"/>
+            <a:chOff x="0" y="0"/>
+            <a:chExt cx="2571900" cy="1095300"/>
+          </a:xfrm>
+        </p:grpSpPr>
+        <p:sp>
+          <p:nvSpPr>
+            <p:cNvPr id="366" name="Google Shape;366;p19"/>
+            <p:cNvSpPr/>
+            <p:nvPr/>
+          </p:nvSpPr>
+          <p:spPr>
+            <a:xfrm>
+              <a:off x="0" y="0"/>
+              <a:ext cx="2571900" cy="1095300"/>
+            </a:xfrm>
+            <a:prstGeom prst="roundRect">
+              <a:avLst>
+                <a:gd fmla="val 5217" name="adj"/>
+              </a:avLst>
+            </a:prstGeom>
+            <a:solidFill>
+              <a:srgbClr val="FFFFFF"/>
+            </a:solidFill>
+            <a:ln cap="flat" cmpd="sng" w="9525">
+              <a:solidFill>
+                <a:srgbClr val="C8D0D8"/>
+              </a:solidFill>
+              <a:prstDash val="solid"/>
+              <a:round/>
+              <a:headEnd len="sm" w="sm" type="none"/>
+              <a:tailEnd len="sm" w="sm" type="none"/>
+            </a:ln>
+          </p:spPr>
+          <p:txBody>
+            <a:bodyPr anchorCtr="0" anchor="ctr" bIns="0" lIns="0" spcFirstLastPara="1" rIns="0" wrap="square" tIns="0">
+              <a:noAutofit/>
+            </a:bodyPr>
+            <a:lstStyle/>
+            <a:p>
+              <a:pPr indent="0" lvl="0" marL="0" rtl="0" algn="l">
+                <a:spcBef>
+                  <a:spcPts val="0"/>
+                </a:spcBef>
+                <a:spcAft>
+                  <a:spcPts val="0"/>
+                </a:spcAft>
+                <a:buNone/>
+              </a:pPr>
+              <a:r>
+                <a:t/>
+              </a:r>
+              <a:endParaRPr/>
+            </a:p>
+          </p:txBody>
+        </p:sp>
+        <p:sp>
+          <p:nvSpPr>
+            <p:cNvPr id="367" name="Google Shape;367;p19"/>
+            <p:cNvSpPr/>
+            <p:nvPr/>
+          </p:nvSpPr>
+          <p:spPr>
+            <a:xfrm>
+              <a:off x="0" y="0"/>
+              <a:ext cx="38100" cy="1095300"/>
+            </a:xfrm>
+            <a:prstGeom prst="roundRect">
+              <a:avLst>
+                <a:gd fmla="val 50000" name="adj"/>
+              </a:avLst>
+            </a:prstGeom>
+            <a:solidFill>
+              <a:srgbClr val="0D2B3D"/>
+            </a:solidFill>
+            <a:ln>
+              <a:noFill/>
+            </a:ln>
+          </p:spPr>
+          <p:txBody>
+            <a:bodyPr anchorCtr="0" anchor="ctr" bIns="0" lIns="0" spcFirstLastPara="1" rIns="0" wrap="square" tIns="0">
+              <a:noAutofit/>
+            </a:bodyPr>
+            <a:lstStyle/>
+            <a:p>
+              <a:pPr indent="0" lvl="0" marL="0" rtl="0" algn="l">
+                <a:spcBef>
+                  <a:spcPts val="0"/>
+                </a:spcBef>
+                <a:spcAft>
+                  <a:spcPts val="0"/>
+                </a:spcAft>
+                <a:buNone/>
+              </a:pPr>
+              <a:r>
+                <a:t/>
+              </a:r>
+              <a:endParaRPr/>
+            </a:p>
+          </p:txBody>
+        </p:sp>
+        <p:sp>
+          <p:nvSpPr>
+            <p:cNvPr id="368" name="Google Shape;368;p19"/>
+            <p:cNvSpPr txBox="1"/>
+            <p:nvPr/>
+          </p:nvSpPr>
+          <p:spPr>
+            <a:xfrm>
+              <a:off x="142875" y="114300"/>
+              <a:ext cx="2286000" cy="857400"/>
+            </a:xfrm>
+            <a:prstGeom prst="rect">
+              <a:avLst/>
+            </a:prstGeom>
+            <a:solidFill>
+              <a:srgbClr val="000000">
+                <a:alpha val="0"/>
+              </a:srgbClr>
+            </a:solidFill>
+            <a:ln>
+              <a:noFill/>
+            </a:ln>
+          </p:spPr>
+          <p:txBody>
+            <a:bodyPr anchorCtr="0" anchor="t" bIns="0" lIns="0" spcFirstLastPara="1" rIns="0" wrap="square" tIns="0">
+              <a:noAutofit/>
+            </a:bodyPr>
+            <a:lstStyle/>
+            <a:p>
+              <a:pPr indent="0" lvl="0" marL="0" rtl="0" algn="l">
+                <a:spcBef>
+                  <a:spcPts val="0"/>
+                </a:spcBef>
+                <a:spcAft>
+                  <a:spcPts val="0"/>
+                </a:spcAft>
+                <a:buNone/>
+              </a:pPr>
+              <a:r>
+                <a:rPr b="1" lang="en" sz="1300">
+                  <a:solidFill>
+                    <a:srgbClr val="0D2B3D"/>
+                  </a:solidFill>
+                  <a:latin typeface="Calibri"/>
+                  <a:ea typeface="Calibri"/>
+                  <a:cs typeface="Calibri"/>
+                  <a:sym typeface="Calibri"/>
+                </a:rPr>
+                <a:t>04 </a:t>
+              </a:r>
+              <a:r>
+                <a:rPr b="1" lang="en" sz="1200">
+                  <a:solidFill>
+                    <a:srgbClr val="1A1A1A"/>
+                  </a:solidFill>
+                  <a:latin typeface="Calibri"/>
+                  <a:ea typeface="Calibri"/>
+                  <a:cs typeface="Calibri"/>
+                  <a:sym typeface="Calibri"/>
+                </a:rPr>
+                <a:t>Development in 6 Weeks</a:t>
+              </a:r>
+              <a:endParaRPr b="1" sz="1300">
+                <a:solidFill>
+                  <a:srgbClr val="0D2B3D"/>
+                </a:solidFill>
+                <a:latin typeface="Calibri"/>
+                <a:ea typeface="Calibri"/>
+                <a:cs typeface="Calibri"/>
+                <a:sym typeface="Calibri"/>
+              </a:endParaRPr>
+            </a:p>
+            <a:p>
+              <a:pPr indent="0" lvl="0" marL="0" rtl="0" algn="l">
+                <a:spcBef>
+                  <a:spcPts val="450"/>
+                </a:spcBef>
+                <a:spcAft>
+                  <a:spcPts val="450"/>
+                </a:spcAft>
+                <a:buNone/>
+              </a:pPr>
+              <a:r>
+                <a:rPr b="0" lang="en" sz="950">
+                  <a:solidFill>
+                    <a:srgbClr val="5A6A7A"/>
+                  </a:solidFill>
+                  <a:latin typeface="Calibri"/>
+                  <a:ea typeface="Calibri"/>
+                  <a:cs typeface="Calibri"/>
+                  <a:sym typeface="Calibri"/>
+                </a:rPr>
+                <a:t>Full engineering and IT support. Integrate with Fakeeh's YASASII HIS &amp; EHRs. Go live in 6 weeks.</a:t>
+              </a:r>
+              <a:endParaRPr b="0" sz="950">
+                <a:solidFill>
+                  <a:srgbClr val="5A6A7A"/>
+                </a:solidFill>
+                <a:latin typeface="Calibri"/>
+                <a:ea typeface="Calibri"/>
+                <a:cs typeface="Calibri"/>
+                <a:sym typeface="Calibri"/>
+              </a:endParaRPr>
+            </a:p>
+          </p:txBody>
+        </p:sp>
+      </p:grpSp>
+      <p:grpSp>
+        <p:nvGrpSpPr>
+          <p:cNvPr id="369" name="Google Shape;369;p19"/>
+          <p:cNvGrpSpPr/>
+          <p:nvPr/>
+        </p:nvGrpSpPr>
+        <p:grpSpPr>
+          <a:xfrm>
+            <a:off x="3286125" y="2619375"/>
+            <a:ext cx="2571900" cy="1095300"/>
+            <a:chOff x="0" y="0"/>
+            <a:chExt cx="2571900" cy="1095300"/>
+          </a:xfrm>
+        </p:grpSpPr>
+        <p:sp>
+          <p:nvSpPr>
+            <p:cNvPr id="370" name="Google Shape;370;p19"/>
+            <p:cNvSpPr/>
+            <p:nvPr/>
+          </p:nvSpPr>
+          <p:spPr>
+            <a:xfrm>
+              <a:off x="0" y="0"/>
+              <a:ext cx="2571900" cy="1095300"/>
+            </a:xfrm>
+            <a:prstGeom prst="roundRect">
+              <a:avLst>
+                <a:gd fmla="val 5217" name="adj"/>
+              </a:avLst>
+            </a:prstGeom>
+            <a:solidFill>
+              <a:srgbClr val="FFFFFF"/>
+            </a:solidFill>
+            <a:ln cap="flat" cmpd="sng" w="9525">
+              <a:solidFill>
+                <a:srgbClr val="C8D0D8"/>
+              </a:solidFill>
+              <a:prstDash val="solid"/>
+              <a:round/>
+              <a:headEnd len="sm" w="sm" type="none"/>
+              <a:tailEnd len="sm" w="sm" type="none"/>
+            </a:ln>
+          </p:spPr>
+          <p:txBody>
+            <a:bodyPr anchorCtr="0" anchor="ctr" bIns="0" lIns="0" spcFirstLastPara="1" rIns="0" wrap="square" tIns="0">
+              <a:noAutofit/>
+            </a:bodyPr>
+            <a:lstStyle/>
+            <a:p>
+              <a:pPr indent="0" lvl="0" marL="0" rtl="0" algn="l">
+                <a:spcBef>
+                  <a:spcPts val="0"/>
+                </a:spcBef>
+                <a:spcAft>
+                  <a:spcPts val="0"/>
+                </a:spcAft>
+                <a:buNone/>
+              </a:pPr>
+              <a:r>
+                <a:t/>
+              </a:r>
+              <a:endParaRPr/>
+            </a:p>
+          </p:txBody>
+        </p:sp>
+        <p:sp>
+          <p:nvSpPr>
+            <p:cNvPr id="371" name="Google Shape;371;p19"/>
+            <p:cNvSpPr/>
+            <p:nvPr/>
+          </p:nvSpPr>
+          <p:spPr>
+            <a:xfrm>
+              <a:off x="0" y="0"/>
+              <a:ext cx="38100" cy="1095300"/>
+            </a:xfrm>
+            <a:prstGeom prst="roundRect">
+              <a:avLst>
+                <a:gd fmla="val 50000" name="adj"/>
+              </a:avLst>
+            </a:prstGeom>
+            <a:solidFill>
+              <a:srgbClr val="0D2B3D"/>
+            </a:solidFill>
+            <a:ln>
+              <a:noFill/>
+            </a:ln>
+          </p:spPr>
+          <p:txBody>
+            <a:bodyPr anchorCtr="0" anchor="ctr" bIns="0" lIns="0" spcFirstLastPara="1" rIns="0" wrap="square" tIns="0">
+              <a:noAutofit/>
+            </a:bodyPr>
+            <a:lstStyle/>
+            <a:p>
+              <a:pPr indent="0" lvl="0" marL="0" rtl="0" algn="l">
+                <a:spcBef>
+                  <a:spcPts val="0"/>
+                </a:spcBef>
+                <a:spcAft>
+                  <a:spcPts val="0"/>
+                </a:spcAft>
+                <a:buNone/>
+              </a:pPr>
+              <a:r>
+                <a:t/>
+              </a:r>
+              <a:endParaRPr/>
+            </a:p>
+          </p:txBody>
+        </p:sp>
+        <p:sp>
+          <p:nvSpPr>
+            <p:cNvPr id="372" name="Google Shape;372;p19"/>
+            <p:cNvSpPr txBox="1"/>
+            <p:nvPr/>
+          </p:nvSpPr>
+          <p:spPr>
+            <a:xfrm>
+              <a:off x="142875" y="114300"/>
+              <a:ext cx="2286000" cy="857400"/>
+            </a:xfrm>
+            <a:prstGeom prst="rect">
+              <a:avLst/>
+            </a:prstGeom>
+            <a:solidFill>
+              <a:srgbClr val="000000">
+                <a:alpha val="0"/>
+              </a:srgbClr>
+            </a:solidFill>
+            <a:ln>
+              <a:noFill/>
+            </a:ln>
+          </p:spPr>
+          <p:txBody>
+            <a:bodyPr anchorCtr="0" anchor="t" bIns="0" lIns="0" spcFirstLastPara="1" rIns="0" wrap="square" tIns="0">
+              <a:noAutofit/>
+            </a:bodyPr>
+            <a:lstStyle/>
+            <a:p>
+              <a:pPr indent="0" lvl="0" marL="0" rtl="0" algn="l">
+                <a:spcBef>
+                  <a:spcPts val="0"/>
+                </a:spcBef>
+                <a:spcAft>
+                  <a:spcPts val="0"/>
+                </a:spcAft>
+                <a:buNone/>
+              </a:pPr>
+              <a:r>
+                <a:rPr b="1" lang="en" sz="1300">
+                  <a:solidFill>
+                    <a:srgbClr val="0D2B3D"/>
+                  </a:solidFill>
+                  <a:latin typeface="Calibri"/>
+                  <a:ea typeface="Calibri"/>
+                  <a:cs typeface="Calibri"/>
+                  <a:sym typeface="Calibri"/>
+                </a:rPr>
+                <a:t>05 </a:t>
+              </a:r>
+              <a:r>
+                <a:rPr b="1" lang="en" sz="1200">
+                  <a:solidFill>
+                    <a:srgbClr val="1A1A1A"/>
+                  </a:solidFill>
+                  <a:latin typeface="Calibri"/>
+                  <a:ea typeface="Calibri"/>
+                  <a:cs typeface="Calibri"/>
+                  <a:sym typeface="Calibri"/>
+                </a:rPr>
+                <a:t>Monitoring</a:t>
+              </a:r>
+              <a:endParaRPr b="1" sz="1300">
+                <a:solidFill>
+                  <a:srgbClr val="0D2B3D"/>
+                </a:solidFill>
+                <a:latin typeface="Calibri"/>
+                <a:ea typeface="Calibri"/>
+                <a:cs typeface="Calibri"/>
+                <a:sym typeface="Calibri"/>
+              </a:endParaRPr>
+            </a:p>
+            <a:p>
+              <a:pPr indent="0" lvl="0" marL="0" rtl="0" algn="l">
+                <a:spcBef>
+                  <a:spcPts val="450"/>
+                </a:spcBef>
+                <a:spcAft>
+                  <a:spcPts val="450"/>
+                </a:spcAft>
+                <a:buNone/>
+              </a:pPr>
+              <a:r>
+                <a:rPr b="0" lang="en" sz="950">
+                  <a:solidFill>
+                    <a:srgbClr val="5A6A7A"/>
+                  </a:solidFill>
+                  <a:latin typeface="Calibri"/>
+                  <a:ea typeface="Calibri"/>
+                  <a:cs typeface="Calibri"/>
+                  <a:sym typeface="Calibri"/>
+                </a:rPr>
+                <a:t>Continuous monitoring with real-time risk flags, full visibility into agent performance and ROI.</a:t>
+              </a:r>
+              <a:endParaRPr b="0" sz="950">
+                <a:solidFill>
+                  <a:srgbClr val="5A6A7A"/>
+                </a:solidFill>
+                <a:latin typeface="Calibri"/>
+                <a:ea typeface="Calibri"/>
+                <a:cs typeface="Calibri"/>
+                <a:sym typeface="Calibri"/>
+              </a:endParaRPr>
+            </a:p>
+          </p:txBody>
+        </p:sp>
+      </p:grpSp>
+      <p:grpSp>
+        <p:nvGrpSpPr>
+          <p:cNvPr id="373" name="Google Shape;373;p19"/>
+          <p:cNvGrpSpPr/>
+          <p:nvPr/>
+        </p:nvGrpSpPr>
+        <p:grpSpPr>
+          <a:xfrm>
+            <a:off x="6096000" y="2619375"/>
+            <a:ext cx="2571900" cy="1095300"/>
+            <a:chOff x="0" y="0"/>
+            <a:chExt cx="2571900" cy="1095300"/>
+          </a:xfrm>
+        </p:grpSpPr>
+        <p:sp>
+          <p:nvSpPr>
+            <p:cNvPr id="374" name="Google Shape;374;p19"/>
+            <p:cNvSpPr/>
+            <p:nvPr/>
+          </p:nvSpPr>
+          <p:spPr>
+            <a:xfrm>
+              <a:off x="0" y="0"/>
+              <a:ext cx="2571900" cy="1095300"/>
+            </a:xfrm>
+            <a:prstGeom prst="roundRect">
+              <a:avLst>
+                <a:gd fmla="val 5217" name="adj"/>
+              </a:avLst>
+            </a:prstGeom>
+            <a:solidFill>
+              <a:srgbClr val="FFFFFF"/>
+            </a:solidFill>
+            <a:ln cap="flat" cmpd="sng" w="9525">
+              <a:solidFill>
+                <a:srgbClr val="C8D0D8"/>
+              </a:solidFill>
+              <a:prstDash val="solid"/>
+              <a:round/>
+              <a:headEnd len="sm" w="sm" type="none"/>
+              <a:tailEnd len="sm" w="sm" type="none"/>
+            </a:ln>
+          </p:spPr>
+          <p:txBody>
+            <a:bodyPr anchorCtr="0" anchor="ctr" bIns="0" lIns="0" spcFirstLastPara="1" rIns="0" wrap="square" tIns="0">
+              <a:noAutofit/>
+            </a:bodyPr>
+            <a:lstStyle/>
+            <a:p>
+              <a:pPr indent="0" lvl="0" marL="0" rtl="0" algn="l">
+                <a:spcBef>
+                  <a:spcPts val="0"/>
+                </a:spcBef>
+                <a:spcAft>
+                  <a:spcPts val="0"/>
+                </a:spcAft>
+                <a:buNone/>
+              </a:pPr>
+              <a:r>
+                <a:t/>
+              </a:r>
+              <a:endParaRPr/>
+            </a:p>
+          </p:txBody>
+        </p:sp>
+        <p:sp>
+          <p:nvSpPr>
+            <p:cNvPr id="375" name="Google Shape;375;p19"/>
+            <p:cNvSpPr/>
+            <p:nvPr/>
+          </p:nvSpPr>
+          <p:spPr>
+            <a:xfrm>
+              <a:off x="0" y="0"/>
+              <a:ext cx="38100" cy="1095300"/>
+            </a:xfrm>
+            <a:prstGeom prst="roundRect">
+              <a:avLst>
+                <a:gd fmla="val 50000" name="adj"/>
+              </a:avLst>
+            </a:prstGeom>
+            <a:solidFill>
+              <a:srgbClr val="0D2B3D"/>
+            </a:solidFill>
+            <a:ln>
+              <a:noFill/>
+            </a:ln>
+          </p:spPr>
+          <p:txBody>
+            <a:bodyPr anchorCtr="0" anchor="ctr" bIns="0" lIns="0" spcFirstLastPara="1" rIns="0" wrap="square" tIns="0">
+              <a:noAutofit/>
+            </a:bodyPr>
+            <a:lstStyle/>
+            <a:p>
+              <a:pPr indent="0" lvl="0" marL="0" rtl="0" algn="l">
+                <a:spcBef>
+                  <a:spcPts val="0"/>
+                </a:spcBef>
+                <a:spcAft>
+                  <a:spcPts val="0"/>
+                </a:spcAft>
+                <a:buNone/>
+              </a:pPr>
+              <a:r>
+                <a:t/>
+              </a:r>
+              <a:endParaRPr/>
+            </a:p>
+          </p:txBody>
+        </p:sp>
+        <p:sp>
+          <p:nvSpPr>
+            <p:cNvPr id="376" name="Google Shape;376;p19"/>
+            <p:cNvSpPr txBox="1"/>
+            <p:nvPr/>
+          </p:nvSpPr>
+          <p:spPr>
+            <a:xfrm>
+              <a:off x="142875" y="114300"/>
+              <a:ext cx="2286000" cy="857400"/>
+            </a:xfrm>
+            <a:prstGeom prst="rect">
+              <a:avLst/>
+            </a:prstGeom>
+            <a:solidFill>
+              <a:srgbClr val="000000">
+                <a:alpha val="0"/>
+              </a:srgbClr>
+            </a:solidFill>
+            <a:ln>
+              <a:noFill/>
+            </a:ln>
+          </p:spPr>
+          <p:txBody>
+            <a:bodyPr anchorCtr="0" anchor="t" bIns="0" lIns="0" spcFirstLastPara="1" rIns="0" wrap="square" tIns="0">
+              <a:noAutofit/>
+            </a:bodyPr>
+            <a:lstStyle/>
+            <a:p>
+              <a:pPr indent="0" lvl="0" marL="0" rtl="0" algn="l">
+                <a:spcBef>
+                  <a:spcPts val="0"/>
+                </a:spcBef>
+                <a:spcAft>
+                  <a:spcPts val="0"/>
+                </a:spcAft>
+                <a:buNone/>
+              </a:pPr>
+              <a:r>
+                <a:rPr b="1" lang="en" sz="1300">
+                  <a:solidFill>
+                    <a:srgbClr val="0D2B3D"/>
+                  </a:solidFill>
+                  <a:latin typeface="Calibri"/>
+                  <a:ea typeface="Calibri"/>
+                  <a:cs typeface="Calibri"/>
+                  <a:sym typeface="Calibri"/>
+                </a:rPr>
+                <a:t>06 </a:t>
+              </a:r>
+              <a:r>
+                <a:rPr b="1" lang="en" sz="1200">
+                  <a:solidFill>
+                    <a:srgbClr val="1A1A1A"/>
+                  </a:solidFill>
+                  <a:latin typeface="Calibri"/>
+                  <a:ea typeface="Calibri"/>
+                  <a:cs typeface="Calibri"/>
+                  <a:sym typeface="Calibri"/>
+                </a:rPr>
+                <a:t>Continuous Improvement</a:t>
+              </a:r>
+              <a:endParaRPr b="1" sz="1300">
+                <a:solidFill>
+                  <a:srgbClr val="0D2B3D"/>
+                </a:solidFill>
+                <a:latin typeface="Calibri"/>
+                <a:ea typeface="Calibri"/>
+                <a:cs typeface="Calibri"/>
+                <a:sym typeface="Calibri"/>
+              </a:endParaRPr>
+            </a:p>
+            <a:p>
+              <a:pPr indent="0" lvl="0" marL="0" rtl="0" algn="l">
+                <a:spcBef>
+                  <a:spcPts val="450"/>
+                </a:spcBef>
+                <a:spcAft>
+                  <a:spcPts val="450"/>
+                </a:spcAft>
+                <a:buNone/>
+              </a:pPr>
+              <a:r>
+                <a:rPr b="0" lang="en" sz="950">
+                  <a:solidFill>
+                    <a:srgbClr val="5A6A7A"/>
+                  </a:solidFill>
+                  <a:latin typeface="Calibri"/>
+                  <a:ea typeface="Calibri"/>
+                  <a:cs typeface="Calibri"/>
+                  <a:sym typeface="Calibri"/>
+                </a:rPr>
+                <a:t>We refine your agents based on real Fakeeh patient interactions so they get smarter over time.</a:t>
+              </a:r>
+              <a:endParaRPr b="0" sz="950">
+                <a:solidFill>
+                  <a:srgbClr val="5A6A7A"/>
+                </a:solidFill>
+                <a:latin typeface="Calibri"/>
+                <a:ea typeface="Calibri"/>
+                <a:cs typeface="Calibri"/>
+                <a:sym typeface="Calibri"/>
+              </a:endParaRPr>
+            </a:p>
+          </p:txBody>
+        </p:sp>
+      </p:grpSp>
+      <p:sp>
+        <p:nvSpPr>
+          <p:cNvPr id="377" name="Google Shape;377;p19"/>
+          <p:cNvSpPr txBox="1"/>
+          <p:nvPr/>
+        </p:nvSpPr>
+        <p:spPr>
+          <a:xfrm>
+            <a:off x="476250" y="428625"/>
+            <a:ext cx="5715000" cy="400200"/>
+          </a:xfrm>
+          <a:prstGeom prst="rect">
+            <a:avLst/>
+          </a:prstGeom>
+          <a:solidFill>
+            <a:srgbClr val="000000">
+              <a:alpha val="0"/>
+            </a:srgbClr>
           </a:solidFill>
           <a:ln>
             <a:noFill/>
           </a:ln>
         </p:spPr>
         <p:txBody>
-          <a:bodyPr/>
+          <a:bodyPr anchorCtr="0" anchor="ctr" bIns="0" lIns="0" spcFirstLastPara="1" rIns="0" wrap="square" tIns="0">
+            <a:spAutoFit/>
+          </a:bodyPr>
           <a:lstStyle/>
-          <a:p/>
+          <a:p>
+            <a:pPr indent="0" lvl="0" marL="0" rtl="0" algn="l">
+              <a:spcBef>
+                <a:spcPts val="0"/>
+              </a:spcBef>
+              <a:spcAft>
+                <a:spcPts val="0"/>
+              </a:spcAft>
+              <a:buNone/>
+            </a:pPr>
+            <a:r>
+              <a:rPr b="1" lang="en" sz="2600">
+                <a:solidFill>
+                  <a:srgbClr val="0D2B3D"/>
+                </a:solidFill>
+                <a:latin typeface="Calibri"/>
+                <a:ea typeface="Calibri"/>
+                <a:cs typeface="Calibri"/>
+                <a:sym typeface="Calibri"/>
+              </a:rPr>
+              <a:t>Your AI partner, end to end.</a:t>
+            </a:r>
+            <a:endParaRPr b="1" sz="2600">
+              <a:solidFill>
+                <a:srgbClr val="0D2B3D"/>
+              </a:solidFill>
+              <a:latin typeface="Calibri"/>
+              <a:ea typeface="Calibri"/>
+              <a:cs typeface="Calibri"/>
+              <a:sym typeface="Calibri"/>
+            </a:endParaRPr>
+          </a:p>
         </p:txBody>
       </p:sp>
       <p:sp>
         <p:nvSpPr>
-          <p:cNvPr id="95623560" name="deco_5623560_2194560"/>
-          <p:cNvSpPr>
-            <a:spLocks noGrp="1"/>
-          </p:cNvSpPr>
+          <p:cNvPr id="378" name="Google Shape;378;p19"/>
+          <p:cNvSpPr txBox="1"/>
           <p:nvPr/>
         </p:nvSpPr>
         <p:spPr>
           <a:xfrm>
-            <a:off x="5623560" y="2194560"/>
-            <a:ext cx="1737360" cy="1645920"/>
+            <a:off x="476250" y="857250"/>
+            <a:ext cx="6191400" cy="169200"/>
           </a:xfrm>
           <a:prstGeom prst="rect">
             <a:avLst/>
           </a:prstGeom>
           <a:solidFill>
-            <a:srgbClr val="8A2E22"/>
+            <a:srgbClr val="000000">
+              <a:alpha val="0"/>
+            </a:srgbClr>
           </a:solidFill>
           <a:ln>
             <a:noFill/>
           </a:ln>
         </p:spPr>
         <p:txBody>
-          <a:bodyPr/>
+          <a:bodyPr anchorCtr="0" anchor="ctr" bIns="0" lIns="0" spcFirstLastPara="1" rIns="0" wrap="square" tIns="0">
+            <a:spAutoFit/>
+          </a:bodyPr>
           <a:lstStyle/>
-          <a:p/>
+          <a:p>
+            <a:pPr indent="0" lvl="0" marL="0" rtl="0" algn="l">
+              <a:spcBef>
+                <a:spcPts val="0"/>
+              </a:spcBef>
+              <a:spcAft>
+                <a:spcPts val="0"/>
+              </a:spcAft>
+              <a:buNone/>
+            </a:pPr>
+            <a:r>
+              <a:rPr b="0" i="1" lang="en" sz="1100">
+                <a:solidFill>
+                  <a:srgbClr val="5A6A7A"/>
+                </a:solidFill>
+                <a:latin typeface="Calibri"/>
+                <a:ea typeface="Calibri"/>
+                <a:cs typeface="Calibri"/>
+                <a:sym typeface="Calibri"/>
+              </a:rPr>
+              <a:t>From discovery to post-development, our team handles the complexity so Fakeeh can stay focused on care.</a:t>
+            </a:r>
+            <a:endParaRPr b="0" i="1" sz="1100">
+              <a:solidFill>
+                <a:srgbClr val="5A6A7A"/>
+              </a:solidFill>
+              <a:latin typeface="Calibri"/>
+              <a:ea typeface="Calibri"/>
+              <a:cs typeface="Calibri"/>
+              <a:sym typeface="Calibri"/>
+            </a:endParaRPr>
+          </a:p>
         </p:txBody>
       </p:sp>
-      <p:sp>
-        <p:nvSpPr>
-          <p:cNvPr id="95623560" name="deco_5623560_182880"/>
-          <p:cNvSpPr>
-            <a:spLocks noGrp="1"/>
-          </p:cNvSpPr>
+      <p:pic>
+        <p:nvPicPr>
+          <p:cNvPr id="379" name="Google Shape;379;p19" title="download.jfif"/>
+          <p:cNvPicPr preferRelativeResize="0"/>
           <p:nvPr/>
-        </p:nvSpPr>
+        </p:nvPicPr>
+        <p:blipFill>
+          <a:blip r:embed="rId2">
+            <a:alphaModFix/>
+          </a:blip>
+          <a:stretch>
+            <a:fillRect/>
+          </a:stretch>
+        </p:blipFill>
         <p:spPr>
           <a:xfrm>
-            <a:off x="5623560" y="182880"/>
-            <a:ext cx="822960" cy="1005840"/>
+            <a:off x="7941600" y="4628100"/>
+            <a:ext cx="966625" cy="241650"/>
           </a:xfrm>
           <a:prstGeom prst="rect">
             <a:avLst/>
           </a:prstGeom>
-          <a:solidFill>
-            <a:srgbClr val="C85040"/>
-          </a:solidFill>
+          <a:noFill/>
           <a:ln>
             <a:noFill/>
           </a:ln>
         </p:spPr>
-        <p:txBody>
-          <a:bodyPr/>
-          <a:lstStyle/>
-          <a:p/>
-        </p:txBody>
-      </p:sp>
-      <p:sp>
-        <p:nvSpPr>
-          <p:cNvPr id="95623560" name="deco_5623560_3840480"/>
-          <p:cNvSpPr>
-            <a:spLocks noGrp="1"/>
-          </p:cNvSpPr>
-          <p:nvPr/>
-        </p:nvSpPr>
-        <p:spPr>
-          <a:xfrm>
-            <a:off x="5623560" y="3840480"/>
-            <a:ext cx="3520440" cy="1280160"/>
-          </a:xfrm>
-          <a:prstGeom prst="rect">
-            <a:avLst/>
-          </a:prstGeom>
-          <a:solidFill>
-            <a:srgbClr val="8A2E22"/>
-          </a:solidFill>
-          <a:ln>
-            <a:noFill/>
-          </a:ln>
-        </p:spPr>
-        <p:txBody>
-          <a:bodyPr/>
-          <a:lstStyle/>
-          <a:p/>
-        </p:txBody>
-      </p:sp>
-      <p:sp>
-        <p:nvSpPr>
-          <p:cNvPr id="96858000" name="deco_6858000_2926080"/>
-          <p:cNvSpPr>
-            <a:spLocks noGrp="1"/>
-          </p:cNvSpPr>
-          <p:nvPr/>
-        </p:nvSpPr>
-        <p:spPr>
-          <a:xfrm>
-            <a:off x="6858000" y="2926080"/>
-            <a:ext cx="2286000" cy="1828800"/>
-          </a:xfrm>
-          <a:prstGeom prst="rect">
-            <a:avLst/>
-          </a:prstGeom>
-          <a:solidFill>
-            <a:srgbClr val="D4604E"/>
-          </a:solidFill>
-          <a:ln>
-            <a:noFill/>
-          </a:ln>
-        </p:spPr>
-        <p:txBody>
-          <a:bodyPr/>
-          <a:lstStyle/>
-          <a:p/>
-        </p:txBody>
-      </p:sp>
+      </p:pic>
     </p:spTree>
   </p:cSld>
   <p:clrMapOvr>

</xml_diff>